<commit_message>
docs: localize and redesign LZ 6 forecast
</commit_message>
<xml_diff>
--- a/docs/forecast/lz6-when-ready.pptx
+++ b/docs/forecast/lz6-when-ready.pptx
@@ -2,13 +2,13 @@
 <file path=ppt/presentation.xml><?xml version="1.0" encoding="utf-8"?>
 <p:presentation xmlns:p="http://schemas.openxmlformats.org/presentationml/2006/main">
   <p:sldMasterIdLst>
-    <p:sldMasterId xmlns:r="http://schemas.openxmlformats.org/officeDocument/2006/relationships" id="2147483648" r:id="Re914d6915a3441f5"/>
+    <p:sldMasterId xmlns:r="http://schemas.openxmlformats.org/officeDocument/2006/relationships" id="2147483648" r:id="R82a9caec32004f2c"/>
   </p:sldMasterIdLst>
   <p:notesMasterIdLst>
-    <p:notesMasterId xmlns:r="http://schemas.openxmlformats.org/officeDocument/2006/relationships" r:id="R1fd36c36875e4392"/>
+    <p:notesMasterId xmlns:r="http://schemas.openxmlformats.org/officeDocument/2006/relationships" r:id="R654c9f7af4264fc8"/>
   </p:notesMasterIdLst>
   <p:sldIdLst>
-    <p:sldId xmlns:r="http://schemas.openxmlformats.org/officeDocument/2006/relationships" id="256" r:id="Rb18b3648a28545fb"/>
+    <p:sldId xmlns:r="http://schemas.openxmlformats.org/officeDocument/2006/relationships" id="256" r:id="R92b847a8f4ee4c5c"/>
   </p:sldIdLst>
   <p:sldSz cx="12192000" cy="6858000"/>
   <p:notesSz cx="6858000" cy="9144000"/>
@@ -442,7 +442,7 @@
           <a:lstStyle xmlns:a="http://schemas.openxmlformats.org/drawingml/2006/main"/>
           <a:p xmlns:a="http://schemas.openxmlformats.org/drawingml/2006/main">
             <a:r>
-              <a:t>Источник: https://github.com/pallets/click. Выгрузка закрытых issues через GitHub Search API за 06.04.2026–04.10.2026. Модель: bootstrap недельного throughput, 10 000 прогонов, seed 20261008, backlog 18 элементов. P50 15.11.2026, P70 22.11.2026, P85 29.11.2026, P95 13.12.2026.</a:t>
+              <a:t>Дереккөз: https://github.com/pallets/click. 06.04.2026–04.10.2026 аралығындағы 106 жабылған issue. Модель: апталық throughput деректерін қайтарумен bootstrap іріктеу, 10 000 симуляция, seed 20261008, 18 элемент. P50 — 15.11.2026, P70 — 22.11.2026, P85 — 29.11.2026, P95 — 13.12.2026.</a:t>
             </a:r>
           </a:p>
         </p:txBody>
@@ -510,7 +510,7 @@
   </p:cSld>
   <p:clrMap bg1="lt1" tx1="dk1" bg2="lt2" tx2="dk2" accent1="accent1" accent2="accent2" accent3="accent3" accent4="accent4" accent5="accent5" accent6="accent6" hlink="hlink" folHlink="folHlink"/>
   <p:sldLayoutIdLst>
-    <p:sldLayoutId xmlns:r="http://schemas.openxmlformats.org/officeDocument/2006/relationships" id="2147483649" r:id="R6296961a41db4820"/>
+    <p:sldLayoutId xmlns:r="http://schemas.openxmlformats.org/officeDocument/2006/relationships" id="2147483649" r:id="R9fa3ff62b2194f38"/>
   </p:sldLayoutIdLst>
   <p:txStyles>
     <p:titleStyle>
@@ -1037,189 +1037,13 @@
 </a:theme>
 </file>
 
-<file path=ppt/slides/charts/chart1.xml><?xml version="1.0" encoding="utf-8"?>
-<c:chartSpace xmlns:c="http://schemas.openxmlformats.org/drawingml/2006/chart" xmlns:r="http://schemas.openxmlformats.org/officeDocument/2006/relationships">
-  <c:lang val="en-US"/>
-  <c:chart>
-    <c:plotArea>
-      <c:lineChart>
-        <c:grouping val="standard"/>
-        <c:ser>
-          <c:idx val="0"/>
-          <c:order val="0"/>
-          <c:tx>
-            <c:v>Вероятность завершения, %</c:v>
-          </c:tx>
-          <c:spPr>
-            <a:solidFill xmlns:a="http://schemas.openxmlformats.org/drawingml/2006/main">
-              <a:srgbClr val="1F4E78"/>
-            </a:solidFill>
-            <a:ln xmlns:a="http://schemas.openxmlformats.org/drawingml/2006/main" w="38100">
-              <a:solidFill>
-                <a:srgbClr val="1F4E78"/>
-              </a:solidFill>
-            </a:ln>
-          </c:spPr>
-          <c:marker>
-            <c:symbol val="none"/>
-          </c:marker>
-          <c:cat>
-            <c:numRef>
-              <c:f>'Chart Data'!$A$2:$A$5</c:f>
-              <c:numCache>
-                <c:formatCode>General</c:formatCode>
-                <c:ptCount val="4"/>
-                <c:pt idx="0">
-                  <c:v>15.11</c:v>
-                </c:pt>
-                <c:pt idx="1">
-                  <c:v>22.11</c:v>
-                </c:pt>
-                <c:pt idx="2">
-                  <c:v>29.11</c:v>
-                </c:pt>
-                <c:pt idx="3">
-                  <c:v>13.12</c:v>
-                </c:pt>
-              </c:numCache>
-            </c:numRef>
-          </c:cat>
-          <c:val>
-            <c:numRef>
-              <c:f>'Chart Data'!$B$2:$B$5</c:f>
-              <c:numCache>
-                <c:formatCode>General</c:formatCode>
-                <c:ptCount val="4"/>
-                <c:pt idx="0">
-                  <c:v>50</c:v>
-                </c:pt>
-                <c:pt idx="1">
-                  <c:v>70</c:v>
-                </c:pt>
-                <c:pt idx="2">
-                  <c:v>85</c:v>
-                </c:pt>
-                <c:pt idx="3">
-                  <c:v>95</c:v>
-                </c:pt>
-              </c:numCache>
-            </c:numRef>
-          </c:val>
-        </c:ser>
-        <c:dLbls>
-          <c:txPr>
-            <a:bodyPr xmlns:a="http://schemas.openxmlformats.org/drawingml/2006/main" anchorCtr="1"/>
-            <a:lstStyle xmlns:a="http://schemas.openxmlformats.org/drawingml/2006/main"/>
-            <a:p xmlns:a="http://schemas.openxmlformats.org/drawingml/2006/main">
-              <a:pPr>
-                <a:defRPr>
-                  <a:latin typeface="Arial"/>
-                  <a:ea typeface="Arial"/>
-                  <a:cs typeface="Arial"/>
-                </a:defRPr>
-              </a:pPr>
-            </a:p>
-          </c:txPr>
-          <c:showLegendKey val="0"/>
-          <c:showVal val="1"/>
-          <c:showCatName val="0"/>
-          <c:showSerName val="0"/>
-          <c:showPercent val="0"/>
-          <c:showBubbleSize val="0"/>
-          <c:showLeaderLines val="0"/>
-        </c:dLbls>
-        <c:axId val="48650112"/>
-        <c:axId val="48672768"/>
-      </c:lineChart>
-      <c:catAx>
-        <c:axId val="48650112"/>
-        <c:scaling>
-          <c:orientation val="minMax"/>
-        </c:scaling>
-        <c:delete val="0"/>
-        <c:axPos val="b"/>
-        <c:numFmt formatCode="General"/>
-        <c:majorTickMark val="none"/>
-        <c:minorTickMark val="none"/>
-        <c:spPr>
-          <a:ln xmlns:a="http://schemas.openxmlformats.org/drawingml/2006/main" w="9525">
-            <a:solidFill>
-              <a:srgbClr val="D4D4D4"/>
-            </a:solidFill>
-            <a:prstDash val="solid"/>
-          </a:ln>
-        </c:spPr>
-        <c:txPr>
-          <a:bodyPr xmlns:a="http://schemas.openxmlformats.org/drawingml/2006/main" anchorCtr="1"/>
-          <a:lstStyle xmlns:a="http://schemas.openxmlformats.org/drawingml/2006/main"/>
-          <a:p xmlns:a="http://schemas.openxmlformats.org/drawingml/2006/main">
-            <a:pPr>
-              <a:defRPr>
-                <a:solidFill>
-                  <a:srgbClr val="666666"/>
-                </a:solidFill>
-                <a:latin typeface="Arial"/>
-                <a:ea typeface="Arial"/>
-                <a:cs typeface="Arial"/>
-              </a:defRPr>
-            </a:pPr>
-          </a:p>
-        </c:txPr>
-        <c:crossAx val="48672768"/>
-      </c:catAx>
-      <c:valAx>
-        <c:axId val="48672768"/>
-        <c:scaling>
-          <c:orientation val="minMax"/>
-        </c:scaling>
-        <c:delete val="1"/>
-        <c:axPos val="l"/>
-        <c:numFmt formatCode="General"/>
-        <c:majorTickMark val="none"/>
-        <c:minorTickMark val="none"/>
-        <c:spPr>
-          <a:ln xmlns:a="http://schemas.openxmlformats.org/drawingml/2006/main" w="9525">
-            <a:solidFill>
-              <a:srgbClr val="D4D4D4"/>
-            </a:solidFill>
-            <a:prstDash val="solid"/>
-          </a:ln>
-        </c:spPr>
-        <c:txPr>
-          <a:bodyPr xmlns:a="http://schemas.openxmlformats.org/drawingml/2006/main" anchorCtr="1"/>
-          <a:lstStyle xmlns:a="http://schemas.openxmlformats.org/drawingml/2006/main"/>
-          <a:p xmlns:a="http://schemas.openxmlformats.org/drawingml/2006/main">
-            <a:pPr>
-              <a:defRPr>
-                <a:solidFill>
-                  <a:srgbClr val="666666"/>
-                </a:solidFill>
-                <a:latin typeface="Arial"/>
-                <a:ea typeface="Arial"/>
-                <a:cs typeface="Arial"/>
-              </a:defRPr>
-            </a:pPr>
-          </a:p>
-        </c:txPr>
-        <c:crossAx val="48650112"/>
-        <c:crossBetween val="between"/>
-      </c:valAx>
-    </c:plotArea>
-    <c:plotVisOnly val="1"/>
-  </c:chart>
-  <c:externalData r:id="rIdChartSnapshot1">
-    <c:autoUpdate val="0"/>
-  </c:externalData>
-</c:chartSpace>
-</file>
-
 <file path=ppt/slides/slide1.xml><?xml version="1.0" encoding="utf-8"?>
 <p:sld xmlns:p="http://schemas.openxmlformats.org/presentationml/2006/main">
   <p:cSld>
     <p:bg>
       <p:bgPr>
         <a:solidFill xmlns:a="http://schemas.openxmlformats.org/drawingml/2006/main">
-          <a:srgbClr val="F8FAFC"/>
+          <a:srgbClr val="09131F"/>
         </a:solidFill>
       </p:bgPr>
     </p:bg>
@@ -1234,22 +1058,82 @@
       </p:grpSpPr>
       <p:sp>
         <p:nvSpPr>
-          <p:cNvPr id="11" name="">
-            <a:extLst xmlns:a="http://schemas.openxmlformats.org/drawingml/2006/main">
-              <a:ext uri="{FF2B5EF4-FFF2-40B4-BE49-F238E27FC236}">
-                <a16:creationId xmlns:a16="http://schemas.microsoft.com/office/drawing/2014/main" id="{BE42D123-A4A7-4F15-A4BF-0096EDAF2C68}"/>
-              </a:ext>
-            </a:extLst>
-          </p:cNvPr>
-          <p:cNvSpPr>
-            <a:spLocks xmlns:a="http://schemas.openxmlformats.org/drawingml/2006/main" noGrp="1"/>
-          </p:cNvSpPr>
-          <p:nvPr/>
-        </p:nvSpPr>
-        <p:spPr>
-          <a:xfrm xmlns:a="http://schemas.openxmlformats.org/drawingml/2006/main">
-            <a:off x="647700" y="400050"/>
-            <a:ext cx="10896600" cy="552450"/>
+          <p:cNvPr id="38" name="">
+            <a:extLst xmlns:a="http://schemas.openxmlformats.org/drawingml/2006/main">
+              <a:ext uri="{FF2B5EF4-FFF2-40B4-BE49-F238E27FC236}">
+                <a16:creationId xmlns:a16="http://schemas.microsoft.com/office/drawing/2014/main" id="{B7888E90-C5CA-4E00-AE9D-4D1E0B2B2D05}"/>
+              </a:ext>
+            </a:extLst>
+          </p:cNvPr>
+          <p:cNvSpPr>
+            <a:spLocks xmlns:a="http://schemas.openxmlformats.org/drawingml/2006/main" noGrp="1"/>
+          </p:cNvSpPr>
+          <p:nvPr/>
+        </p:nvSpPr>
+        <p:spPr>
+          <a:xfrm xmlns:a="http://schemas.openxmlformats.org/drawingml/2006/main">
+            <a:off x="0" y="0"/>
+            <a:ext cx="114300" cy="6858000"/>
+          </a:xfrm>
+          <a:prstGeom xmlns:a="http://schemas.openxmlformats.org/drawingml/2006/main" prst="rect">
+            <a:avLst/>
+          </a:prstGeom>
+          <a:solidFill xmlns:a="http://schemas.openxmlformats.org/drawingml/2006/main">
+            <a:srgbClr val="41B5E6"/>
+          </a:solidFill>
+          <a:ln xmlns:a="http://schemas.openxmlformats.org/drawingml/2006/main" w="0">
+            <a:noFill/>
+          </a:ln>
+        </p:spPr>
+      </p:sp>
+      <p:sp>
+        <p:nvSpPr>
+          <p:cNvPr id="2" name="">
+            <a:extLst xmlns:a="http://schemas.openxmlformats.org/drawingml/2006/main">
+              <a:ext uri="{FF2B5EF4-FFF2-40B4-BE49-F238E27FC236}">
+                <a16:creationId xmlns:a16="http://schemas.microsoft.com/office/drawing/2014/main" id="{5354E05E-730F-45DD-8DB4-27E42E794255}"/>
+              </a:ext>
+            </a:extLst>
+          </p:cNvPr>
+          <p:cNvSpPr>
+            <a:spLocks xmlns:a="http://schemas.openxmlformats.org/drawingml/2006/main" noGrp="1"/>
+          </p:cNvSpPr>
+          <p:nvPr/>
+        </p:nvSpPr>
+        <p:spPr>
+          <a:xfrm xmlns:a="http://schemas.openxmlformats.org/drawingml/2006/main">
+            <a:off x="10572750" y="-1428750"/>
+            <a:ext cx="3143250" cy="3143250"/>
+          </a:xfrm>
+          <a:prstGeom xmlns:a="http://schemas.openxmlformats.org/drawingml/2006/main" prst="ellipse">
+            <a:avLst/>
+          </a:prstGeom>
+          <a:solidFill xmlns:a="http://schemas.openxmlformats.org/drawingml/2006/main">
+            <a:srgbClr val="111F2F"/>
+          </a:solidFill>
+          <a:ln xmlns:a="http://schemas.openxmlformats.org/drawingml/2006/main" w="0">
+            <a:noFill/>
+          </a:ln>
+        </p:spPr>
+      </p:sp>
+      <p:sp>
+        <p:nvSpPr>
+          <p:cNvPr id="3" name="">
+            <a:extLst xmlns:a="http://schemas.openxmlformats.org/drawingml/2006/main">
+              <a:ext uri="{FF2B5EF4-FFF2-40B4-BE49-F238E27FC236}">
+                <a16:creationId xmlns:a16="http://schemas.microsoft.com/office/drawing/2014/main" id="{AFC6F060-7407-4BA9-B7DB-BD69A0A5B4D2}"/>
+              </a:ext>
+            </a:extLst>
+          </p:cNvPr>
+          <p:cNvSpPr>
+            <a:spLocks xmlns:a="http://schemas.openxmlformats.org/drawingml/2006/main" noGrp="1"/>
+          </p:cNvSpPr>
+          <p:nvPr/>
+        </p:nvSpPr>
+        <p:spPr>
+          <a:xfrm xmlns:a="http://schemas.openxmlformats.org/drawingml/2006/main">
+            <a:off x="419100" y="304800"/>
+            <a:ext cx="5334000" cy="266700"/>
           </a:xfrm>
           <a:prstGeom xmlns:a="http://schemas.openxmlformats.org/drawingml/2006/main" prst="rect">
             <a:avLst/>
@@ -1260,53 +1144,53 @@
           </a:ln>
         </p:spPr>
         <p:txBody>
-          <a:bodyPr xmlns:a="http://schemas.openxmlformats.org/drawingml/2006/main">
-            <a:noAutofit/>
+          <a:bodyPr xmlns:a="http://schemas.openxmlformats.org/drawingml/2006/main" anchor="ctr">
+            <a:normAutofit fontScale="100000"/>
           </a:bodyPr>
           <a:lstStyle xmlns:a="http://schemas.openxmlformats.org/drawingml/2006/main"/>
           <a:p xmlns:a="http://schemas.openxmlformats.org/drawingml/2006/main">
-            <a:pPr>
-              <a:defRPr sz="2700" b="1">
-                <a:solidFill>
-                  <a:srgbClr val="142735"/>
-                </a:solidFill>
-                <a:latin typeface="Arial"/>
-                <a:ea typeface="Arial"/>
-                <a:cs typeface="Arial"/>
+            <a:pPr algn="l">
+              <a:defRPr sz="1125" b="1">
+                <a:solidFill>
+                  <a:srgbClr val="41B5E6"/>
+                </a:solidFill>
+                <a:latin typeface="Century Gothic"/>
+                <a:ea typeface="Century Gothic"/>
+                <a:cs typeface="Century Gothic"/>
               </a:defRPr>
             </a:pPr>
             <a:r>
-              <a:rPr sz="2700" b="1">
-                <a:solidFill>
-                  <a:srgbClr val="142735"/>
-                </a:solidFill>
-                <a:latin typeface="Arial"/>
-                <a:ea typeface="Arial"/>
-                <a:cs typeface="Arial"/>
+              <a:rPr sz="1125" b="1">
+                <a:solidFill>
+                  <a:srgbClr val="41B5E6"/>
+                </a:solidFill>
+                <a:latin typeface="Century Gothic"/>
+                <a:ea typeface="Century Gothic"/>
+                <a:cs typeface="Century Gothic"/>
               </a:rPr>
-              <a:t>Когда будет готов ENUWay</a:t>
+              <a:t>ЛЗ 6  ·  МОНТЕ-КАРЛО БОЛЖАМЫ</a:t>
             </a:r>
           </a:p>
         </p:txBody>
       </p:sp>
       <p:sp>
         <p:nvSpPr>
-          <p:cNvPr id="2" name="">
-            <a:extLst xmlns:a="http://schemas.openxmlformats.org/drawingml/2006/main">
-              <a:ext uri="{FF2B5EF4-FFF2-40B4-BE49-F238E27FC236}">
-                <a16:creationId xmlns:a16="http://schemas.microsoft.com/office/drawing/2014/main" id="{F09D8EBC-375B-48CB-9A35-AF75E803EF1F}"/>
-              </a:ext>
-            </a:extLst>
-          </p:cNvPr>
-          <p:cNvSpPr>
-            <a:spLocks xmlns:a="http://schemas.openxmlformats.org/drawingml/2006/main" noGrp="1"/>
-          </p:cNvSpPr>
-          <p:nvPr/>
-        </p:nvSpPr>
-        <p:spPr>
-          <a:xfrm xmlns:a="http://schemas.openxmlformats.org/drawingml/2006/main">
-            <a:off x="666750" y="1000125"/>
-            <a:ext cx="10572750" cy="333375"/>
+          <p:cNvPr id="4" name="">
+            <a:extLst xmlns:a="http://schemas.openxmlformats.org/drawingml/2006/main">
+              <a:ext uri="{FF2B5EF4-FFF2-40B4-BE49-F238E27FC236}">
+                <a16:creationId xmlns:a16="http://schemas.microsoft.com/office/drawing/2014/main" id="{01993C6D-8183-41AB-8BF2-F4A528829F72}"/>
+              </a:ext>
+            </a:extLst>
+          </p:cNvPr>
+          <p:cNvSpPr>
+            <a:spLocks xmlns:a="http://schemas.openxmlformats.org/drawingml/2006/main" noGrp="1"/>
+          </p:cNvSpPr>
+          <p:nvPr/>
+        </p:nvSpPr>
+        <p:spPr>
+          <a:xfrm xmlns:a="http://schemas.openxmlformats.org/drawingml/2006/main">
+            <a:off x="400050" y="742950"/>
+            <a:ext cx="5429250" cy="990600"/>
           </a:xfrm>
           <a:prstGeom xmlns:a="http://schemas.openxmlformats.org/drawingml/2006/main" prst="rect">
             <a:avLst/>
@@ -1317,104 +1201,54 @@
           </a:ln>
         </p:spPr>
         <p:txBody>
-          <a:bodyPr xmlns:a="http://schemas.openxmlformats.org/drawingml/2006/main">
-            <a:noAutofit/>
+          <a:bodyPr xmlns:a="http://schemas.openxmlformats.org/drawingml/2006/main" anchor="ctr">
+            <a:normAutofit fontScale="100000"/>
           </a:bodyPr>
           <a:lstStyle xmlns:a="http://schemas.openxmlformats.org/drawingml/2006/main"/>
           <a:p xmlns:a="http://schemas.openxmlformats.org/drawingml/2006/main">
-            <a:pPr>
-              <a:defRPr sz="1350">
-                <a:solidFill>
-                  <a:srgbClr val="435466"/>
-                </a:solidFill>
-                <a:latin typeface="Arial"/>
-                <a:ea typeface="Arial"/>
-                <a:cs typeface="Arial"/>
+            <a:pPr algn="l">
+              <a:defRPr sz="2925" b="1">
+                <a:solidFill>
+                  <a:srgbClr val="F6FAFD"/>
+                </a:solidFill>
+                <a:latin typeface="Century Gothic"/>
+                <a:ea typeface="Century Gothic"/>
+                <a:cs typeface="Century Gothic"/>
               </a:defRPr>
             </a:pPr>
             <a:r>
-              <a:rPr sz="1350">
-                <a:solidFill>
-                  <a:srgbClr val="435466"/>
-                </a:solidFill>
-                <a:latin typeface="Arial"/>
-                <a:ea typeface="Arial"/>
-                <a:cs typeface="Arial"/>
+              <a:rPr sz="2925" b="1">
+                <a:solidFill>
+                  <a:srgbClr val="F6FAFD"/>
+                </a:solidFill>
+                <a:latin typeface="Century Gothic"/>
+                <a:ea typeface="Century Gothic"/>
+                <a:cs typeface="Century Gothic"/>
               </a:rPr>
-              <a:t>Прогноз для backlog из 18 элементов по 10 000 симуляциям Монте-Карло</a:t>
+              <a:t>ENUWay қашан</a:t>
             </a:r>
           </a:p>
-        </p:txBody>
-      </p:sp>
-      <p:graphicFrame>
-        <p:nvGraphicFramePr>
-          <p:cNvPr id="13" name="Chart"/>
-          <p:cNvGraphicFramePr/>
-          <p:nvPr/>
-        </p:nvGraphicFramePr>
-        <p:xfrm>
-          <a:off xmlns:a="http://schemas.openxmlformats.org/drawingml/2006/main" x="628650" y="1695450"/>
-          <a:ext xmlns:a="http://schemas.openxmlformats.org/drawingml/2006/main" cx="6572250" cy="3333750"/>
-        </p:xfrm>
-        <a:graphic xmlns:a="http://schemas.openxmlformats.org/drawingml/2006/main">
-          <a:graphicData uri="http://schemas.openxmlformats.org/drawingml/2006/chart">
-            <c:chart xmlns:r="http://schemas.openxmlformats.org/officeDocument/2006/relationships" xmlns:c="http://schemas.openxmlformats.org/drawingml/2006/chart" r:id="Rf3b8afe1bda74572"/>
-          </a:graphicData>
-        </a:graphic>
-      </p:graphicFrame>
-      <p:sp>
-        <p:nvSpPr>
-          <p:cNvPr id="4" name="">
-            <a:extLst xmlns:a="http://schemas.openxmlformats.org/drawingml/2006/main">
-              <a:ext uri="{FF2B5EF4-FFF2-40B4-BE49-F238E27FC236}">
-                <a16:creationId xmlns:a16="http://schemas.microsoft.com/office/drawing/2014/main" id="{B1D7C1C6-1045-4577-A12E-51D4E54E83B4}"/>
-              </a:ext>
-            </a:extLst>
-          </p:cNvPr>
-          <p:cNvSpPr>
-            <a:spLocks xmlns:a="http://schemas.openxmlformats.org/drawingml/2006/main" noGrp="1"/>
-          </p:cNvSpPr>
-          <p:nvPr/>
-        </p:nvSpPr>
-        <p:spPr>
-          <a:xfrm xmlns:a="http://schemas.openxmlformats.org/drawingml/2006/main">
-            <a:off x="7715250" y="1714500"/>
-            <a:ext cx="3524250" cy="342900"/>
-          </a:xfrm>
-          <a:prstGeom xmlns:a="http://schemas.openxmlformats.org/drawingml/2006/main" prst="rect">
-            <a:avLst/>
-          </a:prstGeom>
-          <a:noFill xmlns:a="http://schemas.openxmlformats.org/drawingml/2006/main"/>
-          <a:ln xmlns:a="http://schemas.openxmlformats.org/drawingml/2006/main" w="0">
-            <a:noFill/>
-          </a:ln>
-        </p:spPr>
-        <p:txBody>
-          <a:bodyPr xmlns:a="http://schemas.openxmlformats.org/drawingml/2006/main">
-            <a:noAutofit/>
-          </a:bodyPr>
-          <a:lstStyle xmlns:a="http://schemas.openxmlformats.org/drawingml/2006/main"/>
           <a:p xmlns:a="http://schemas.openxmlformats.org/drawingml/2006/main">
-            <a:pPr>
-              <a:defRPr sz="1200" b="1">
-                <a:solidFill>
-                  <a:srgbClr val="1F4E78"/>
-                </a:solidFill>
-                <a:latin typeface="Arial"/>
-                <a:ea typeface="Arial"/>
-                <a:cs typeface="Arial"/>
+            <a:pPr algn="l">
+              <a:defRPr sz="2925" b="1">
+                <a:solidFill>
+                  <a:srgbClr val="F6FAFD"/>
+                </a:solidFill>
+                <a:latin typeface="Century Gothic"/>
+                <a:ea typeface="Century Gothic"/>
+                <a:cs typeface="Century Gothic"/>
               </a:defRPr>
             </a:pPr>
             <a:r>
-              <a:rPr sz="1200" b="1">
-                <a:solidFill>
-                  <a:srgbClr val="1F4E78"/>
-                </a:solidFill>
-                <a:latin typeface="Arial"/>
-                <a:ea typeface="Arial"/>
-                <a:cs typeface="Arial"/>
+              <a:rPr sz="2925" b="1">
+                <a:solidFill>
+                  <a:srgbClr val="F6FAFD"/>
+                </a:solidFill>
+                <a:latin typeface="Century Gothic"/>
+                <a:ea typeface="Century Gothic"/>
+                <a:cs typeface="Century Gothic"/>
               </a:rPr>
-              <a:t>РЕКОМЕНДУЕМЫЙ ОРИЕНТИР</a:t>
+              <a:t>дайын болады?</a:t>
             </a:r>
           </a:p>
         </p:txBody>
@@ -1424,19 +1258,19 @@
           <p:cNvPr id="5" name="">
             <a:extLst xmlns:a="http://schemas.openxmlformats.org/drawingml/2006/main">
               <a:ext uri="{FF2B5EF4-FFF2-40B4-BE49-F238E27FC236}">
-                <a16:creationId xmlns:a16="http://schemas.microsoft.com/office/drawing/2014/main" id="{DB8BFD7C-9931-4284-A774-C9E47CA22025}"/>
-              </a:ext>
-            </a:extLst>
-          </p:cNvPr>
-          <p:cNvSpPr>
-            <a:spLocks xmlns:a="http://schemas.openxmlformats.org/drawingml/2006/main" noGrp="1"/>
-          </p:cNvSpPr>
-          <p:nvPr/>
-        </p:nvSpPr>
-        <p:spPr>
-          <a:xfrm xmlns:a="http://schemas.openxmlformats.org/drawingml/2006/main">
-            <a:off x="7677150" y="2114550"/>
-            <a:ext cx="3714750" cy="857250"/>
+                <a16:creationId xmlns:a16="http://schemas.microsoft.com/office/drawing/2014/main" id="{91DE05C5-BDD8-44CA-A554-751E4460C65B}"/>
+              </a:ext>
+            </a:extLst>
+          </p:cNvPr>
+          <p:cNvSpPr>
+            <a:spLocks xmlns:a="http://schemas.openxmlformats.org/drawingml/2006/main" noGrp="1"/>
+          </p:cNvSpPr>
+          <p:nvPr/>
+        </p:nvSpPr>
+        <p:spPr>
+          <a:xfrm xmlns:a="http://schemas.openxmlformats.org/drawingml/2006/main">
+            <a:off x="419100" y="1809750"/>
+            <a:ext cx="5048250" cy="285750"/>
           </a:xfrm>
           <a:prstGeom xmlns:a="http://schemas.openxmlformats.org/drawingml/2006/main" prst="rect">
             <a:avLst/>
@@ -1447,31 +1281,31 @@
           </a:ln>
         </p:spPr>
         <p:txBody>
-          <a:bodyPr xmlns:a="http://schemas.openxmlformats.org/drawingml/2006/main">
+          <a:bodyPr xmlns:a="http://schemas.openxmlformats.org/drawingml/2006/main" anchor="ctr">
             <a:normAutofit fontScale="100000"/>
           </a:bodyPr>
           <a:lstStyle xmlns:a="http://schemas.openxmlformats.org/drawingml/2006/main"/>
           <a:p xmlns:a="http://schemas.openxmlformats.org/drawingml/2006/main">
-            <a:pPr>
-              <a:defRPr sz="2550" b="1">
-                <a:solidFill>
-                  <a:srgbClr val="142735"/>
-                </a:solidFill>
-                <a:latin typeface="Arial"/>
-                <a:ea typeface="Arial"/>
-                <a:cs typeface="Arial"/>
+            <a:pPr algn="l">
+              <a:defRPr sz="1275" b="0">
+                <a:solidFill>
+                  <a:srgbClr val="9EADBD"/>
+                </a:solidFill>
+                <a:latin typeface="Century Gothic"/>
+                <a:ea typeface="Century Gothic"/>
+                <a:cs typeface="Century Gothic"/>
               </a:defRPr>
             </a:pPr>
             <a:r>
-              <a:rPr sz="2550" b="1">
-                <a:solidFill>
-                  <a:srgbClr val="142735"/>
-                </a:solidFill>
-                <a:latin typeface="Arial"/>
-                <a:ea typeface="Arial"/>
-                <a:cs typeface="Arial"/>
+              <a:rPr sz="1275" b="0">
+                <a:solidFill>
+                  <a:srgbClr val="9EADBD"/>
+                </a:solidFill>
+                <a:latin typeface="Century Gothic"/>
+                <a:ea typeface="Century Gothic"/>
+                <a:cs typeface="Century Gothic"/>
               </a:rPr>
-              <a:t>29 ноября 2026</a:t>
+              <a:t>18 жұмыс элементі  ·  10 000 симуляция</a:t>
             </a:r>
           </a:p>
         </p:txBody>
@@ -1481,19 +1315,19 @@
           <p:cNvPr id="6" name="">
             <a:extLst xmlns:a="http://schemas.openxmlformats.org/drawingml/2006/main">
               <a:ext uri="{FF2B5EF4-FFF2-40B4-BE49-F238E27FC236}">
-                <a16:creationId xmlns:a16="http://schemas.microsoft.com/office/drawing/2014/main" id="{F7488652-6C69-401B-B85A-D058CAB97EE4}"/>
-              </a:ext>
-            </a:extLst>
-          </p:cNvPr>
-          <p:cNvSpPr>
-            <a:spLocks xmlns:a="http://schemas.openxmlformats.org/drawingml/2006/main" noGrp="1"/>
-          </p:cNvSpPr>
-          <p:nvPr/>
-        </p:nvSpPr>
-        <p:spPr>
-          <a:xfrm xmlns:a="http://schemas.openxmlformats.org/drawingml/2006/main">
-            <a:off x="7715250" y="2933700"/>
-            <a:ext cx="3476625" cy="533400"/>
+                <a16:creationId xmlns:a16="http://schemas.microsoft.com/office/drawing/2014/main" id="{9383310E-07B6-40D7-95DA-0E12DF683EDC}"/>
+              </a:ext>
+            </a:extLst>
+          </p:cNvPr>
+          <p:cNvSpPr>
+            <a:spLocks xmlns:a="http://schemas.openxmlformats.org/drawingml/2006/main" noGrp="1"/>
+          </p:cNvSpPr>
+          <p:nvPr/>
+        </p:nvSpPr>
+        <p:spPr>
+          <a:xfrm xmlns:a="http://schemas.openxmlformats.org/drawingml/2006/main">
+            <a:off x="419100" y="2628900"/>
+            <a:ext cx="4762500" cy="247650"/>
           </a:xfrm>
           <a:prstGeom xmlns:a="http://schemas.openxmlformats.org/drawingml/2006/main" prst="rect">
             <a:avLst/>
@@ -1504,133 +1338,1430 @@
           </a:ln>
         </p:spPr>
         <p:txBody>
-          <a:bodyPr xmlns:a="http://schemas.openxmlformats.org/drawingml/2006/main">
-            <a:noAutofit/>
+          <a:bodyPr xmlns:a="http://schemas.openxmlformats.org/drawingml/2006/main" anchor="ctr">
+            <a:normAutofit fontScale="100000"/>
           </a:bodyPr>
           <a:lstStyle xmlns:a="http://schemas.openxmlformats.org/drawingml/2006/main"/>
           <a:p xmlns:a="http://schemas.openxmlformats.org/drawingml/2006/main">
-            <a:pPr>
+            <a:pPr algn="l">
+              <a:defRPr sz="975" b="1">
+                <a:solidFill>
+                  <a:srgbClr val="9EADBD"/>
+                </a:solidFill>
+                <a:latin typeface="Century Gothic"/>
+                <a:ea typeface="Century Gothic"/>
+                <a:cs typeface="Century Gothic"/>
+              </a:defRPr>
+            </a:pPr>
+            <a:r>
+              <a:rPr sz="975" b="1">
+                <a:solidFill>
+                  <a:srgbClr val="9EADBD"/>
+                </a:solidFill>
+                <a:latin typeface="Century Gothic"/>
+                <a:ea typeface="Century Gothic"/>
+                <a:cs typeface="Century Gothic"/>
+              </a:rPr>
+              <a:t>ЖҰМЫС ДИАПАЗОНЫ  ·  P50–P85</a:t>
+            </a:r>
+          </a:p>
+        </p:txBody>
+      </p:sp>
+      <p:sp>
+        <p:nvSpPr>
+          <p:cNvPr id="7" name="">
+            <a:extLst xmlns:a="http://schemas.openxmlformats.org/drawingml/2006/main">
+              <a:ext uri="{FF2B5EF4-FFF2-40B4-BE49-F238E27FC236}">
+                <a16:creationId xmlns:a16="http://schemas.microsoft.com/office/drawing/2014/main" id="{29232816-58CA-47C6-A241-D7785E6C330F}"/>
+              </a:ext>
+            </a:extLst>
+          </p:cNvPr>
+          <p:cNvSpPr>
+            <a:spLocks xmlns:a="http://schemas.openxmlformats.org/drawingml/2006/main" noGrp="1"/>
+          </p:cNvSpPr>
+          <p:nvPr/>
+        </p:nvSpPr>
+        <p:spPr>
+          <a:xfrm xmlns:a="http://schemas.openxmlformats.org/drawingml/2006/main">
+            <a:off x="400050" y="2905125"/>
+            <a:ext cx="5286375" cy="590550"/>
+          </a:xfrm>
+          <a:prstGeom xmlns:a="http://schemas.openxmlformats.org/drawingml/2006/main" prst="rect">
+            <a:avLst/>
+          </a:prstGeom>
+          <a:noFill xmlns:a="http://schemas.openxmlformats.org/drawingml/2006/main"/>
+          <a:ln xmlns:a="http://schemas.openxmlformats.org/drawingml/2006/main" w="0">
+            <a:noFill/>
+          </a:ln>
+        </p:spPr>
+        <p:txBody>
+          <a:bodyPr xmlns:a="http://schemas.openxmlformats.org/drawingml/2006/main" anchor="ctr">
+            <a:normAutofit fontScale="99242"/>
+          </a:bodyPr>
+          <a:lstStyle xmlns:a="http://schemas.openxmlformats.org/drawingml/2006/main"/>
+          <a:p xmlns:a="http://schemas.openxmlformats.org/drawingml/2006/main">
+            <a:pPr algn="l">
+              <a:defRPr sz="3300" b="1">
+                <a:solidFill>
+                  <a:srgbClr val="F6FAFD"/>
+                </a:solidFill>
+                <a:latin typeface="Century Gothic"/>
+                <a:ea typeface="Century Gothic"/>
+                <a:cs typeface="Century Gothic"/>
+              </a:defRPr>
+            </a:pPr>
+            <a:r>
+              <a:rPr sz="3300" b="1">
+                <a:solidFill>
+                  <a:srgbClr val="F6FAFD"/>
+                </a:solidFill>
+                <a:latin typeface="Century Gothic"/>
+                <a:ea typeface="Century Gothic"/>
+                <a:cs typeface="Century Gothic"/>
+              </a:rPr>
+              <a:t>15–29 қараша</a:t>
+            </a:r>
+          </a:p>
+        </p:txBody>
+      </p:sp>
+      <p:sp>
+        <p:nvSpPr>
+          <p:cNvPr id="8" name="">
+            <a:extLst xmlns:a="http://schemas.openxmlformats.org/drawingml/2006/main">
+              <a:ext uri="{FF2B5EF4-FFF2-40B4-BE49-F238E27FC236}">
+                <a16:creationId xmlns:a16="http://schemas.microsoft.com/office/drawing/2014/main" id="{72F5677D-DC36-4225-8B74-C190E0118AAC}"/>
+              </a:ext>
+            </a:extLst>
+          </p:cNvPr>
+          <p:cNvSpPr>
+            <a:spLocks xmlns:a="http://schemas.openxmlformats.org/drawingml/2006/main" noGrp="1"/>
+          </p:cNvSpPr>
+          <p:nvPr/>
+        </p:nvSpPr>
+        <p:spPr>
+          <a:xfrm xmlns:a="http://schemas.openxmlformats.org/drawingml/2006/main">
+            <a:off x="419100" y="3724275"/>
+            <a:ext cx="438150" cy="38100"/>
+          </a:xfrm>
+          <a:prstGeom xmlns:a="http://schemas.openxmlformats.org/drawingml/2006/main" prst="roundRect">
+            <a:avLst>
+              <a:gd name="adj" fmla="val 50000"/>
+            </a:avLst>
+          </a:prstGeom>
+          <a:solidFill xmlns:a="http://schemas.openxmlformats.org/drawingml/2006/main">
+            <a:srgbClr val="FF6B36"/>
+          </a:solidFill>
+          <a:ln xmlns:a="http://schemas.openxmlformats.org/drawingml/2006/main" w="0">
+            <a:noFill/>
+          </a:ln>
+        </p:spPr>
+      </p:sp>
+      <p:sp>
+        <p:nvSpPr>
+          <p:cNvPr id="9" name="">
+            <a:extLst xmlns:a="http://schemas.openxmlformats.org/drawingml/2006/main">
+              <a:ext uri="{FF2B5EF4-FFF2-40B4-BE49-F238E27FC236}">
+                <a16:creationId xmlns:a16="http://schemas.microsoft.com/office/drawing/2014/main" id="{DB8B881B-E2ED-4765-BD7C-66BDB919DD6C}"/>
+              </a:ext>
+            </a:extLst>
+          </p:cNvPr>
+          <p:cNvSpPr>
+            <a:spLocks xmlns:a="http://schemas.openxmlformats.org/drawingml/2006/main" noGrp="1"/>
+          </p:cNvSpPr>
+          <p:nvPr/>
+        </p:nvSpPr>
+        <p:spPr>
+          <a:xfrm xmlns:a="http://schemas.openxmlformats.org/drawingml/2006/main">
+            <a:off x="971550" y="3581400"/>
+            <a:ext cx="3333750" cy="323850"/>
+          </a:xfrm>
+          <a:prstGeom xmlns:a="http://schemas.openxmlformats.org/drawingml/2006/main" prst="rect">
+            <a:avLst/>
+          </a:prstGeom>
+          <a:noFill xmlns:a="http://schemas.openxmlformats.org/drawingml/2006/main"/>
+          <a:ln xmlns:a="http://schemas.openxmlformats.org/drawingml/2006/main" w="0">
+            <a:noFill/>
+          </a:ln>
+        </p:spPr>
+        <p:txBody>
+          <a:bodyPr xmlns:a="http://schemas.openxmlformats.org/drawingml/2006/main" anchor="ctr">
+            <a:normAutofit fontScale="88406"/>
+          </a:bodyPr>
+          <a:lstStyle xmlns:a="http://schemas.openxmlformats.org/drawingml/2006/main"/>
+          <a:p xmlns:a="http://schemas.openxmlformats.org/drawingml/2006/main">
+            <a:pPr algn="l">
+              <a:defRPr sz="1725" b="1">
+                <a:solidFill>
+                  <a:srgbClr val="FF6B36"/>
+                </a:solidFill>
+                <a:latin typeface="Century Gothic"/>
+                <a:ea typeface="Century Gothic"/>
+                <a:cs typeface="Century Gothic"/>
+              </a:defRPr>
+            </a:pPr>
+            <a:r>
+              <a:rPr sz="1725" b="1">
+                <a:solidFill>
+                  <a:srgbClr val="FF6B36"/>
+                </a:solidFill>
+                <a:latin typeface="Century Gothic"/>
+                <a:ea typeface="Century Gothic"/>
+                <a:cs typeface="Century Gothic"/>
+              </a:rPr>
+              <a:t>P85  ·  29.11.2026</a:t>
+            </a:r>
+          </a:p>
+        </p:txBody>
+      </p:sp>
+      <p:sp>
+        <p:nvSpPr>
+          <p:cNvPr id="10" name="">
+            <a:extLst xmlns:a="http://schemas.openxmlformats.org/drawingml/2006/main">
+              <a:ext uri="{FF2B5EF4-FFF2-40B4-BE49-F238E27FC236}">
+                <a16:creationId xmlns:a16="http://schemas.microsoft.com/office/drawing/2014/main" id="{995FD281-7FDC-4634-B4A1-A4FD322BEBD2}"/>
+              </a:ext>
+            </a:extLst>
+          </p:cNvPr>
+          <p:cNvSpPr>
+            <a:spLocks xmlns:a="http://schemas.openxmlformats.org/drawingml/2006/main" noGrp="1"/>
+          </p:cNvSpPr>
+          <p:nvPr/>
+        </p:nvSpPr>
+        <p:spPr>
+          <a:xfrm xmlns:a="http://schemas.openxmlformats.org/drawingml/2006/main">
+            <a:off x="419100" y="4000500"/>
+            <a:ext cx="5143500" cy="323850"/>
+          </a:xfrm>
+          <a:prstGeom xmlns:a="http://schemas.openxmlformats.org/drawingml/2006/main" prst="rect">
+            <a:avLst/>
+          </a:prstGeom>
+          <a:noFill xmlns:a="http://schemas.openxmlformats.org/drawingml/2006/main"/>
+          <a:ln xmlns:a="http://schemas.openxmlformats.org/drawingml/2006/main" w="0">
+            <a:noFill/>
+          </a:ln>
+        </p:spPr>
+        <p:txBody>
+          <a:bodyPr xmlns:a="http://schemas.openxmlformats.org/drawingml/2006/main" anchor="ctr">
+            <a:normAutofit fontScale="100000"/>
+          </a:bodyPr>
+          <a:lstStyle xmlns:a="http://schemas.openxmlformats.org/drawingml/2006/main"/>
+          <a:p xmlns:a="http://schemas.openxmlformats.org/drawingml/2006/main">
+            <a:pPr algn="l">
+              <a:defRPr sz="1200" b="0">
+                <a:solidFill>
+                  <a:srgbClr val="F6FAFD"/>
+                </a:solidFill>
+                <a:latin typeface="Century Gothic"/>
+                <a:ea typeface="Century Gothic"/>
+                <a:cs typeface="Century Gothic"/>
+              </a:defRPr>
+            </a:pPr>
+            <a:r>
+              <a:rPr sz="1200" b="0">
+                <a:solidFill>
+                  <a:srgbClr val="F6FAFD"/>
+                </a:solidFill>
+                <a:latin typeface="Century Gothic"/>
+                <a:ea typeface="Century Gothic"/>
+                <a:cs typeface="Century Gothic"/>
+              </a:rPr>
+              <a:t>Осы күнге дейін аяқтау ықтималдығы — 85%</a:t>
+            </a:r>
+          </a:p>
+        </p:txBody>
+      </p:sp>
+      <p:sp>
+        <p:nvSpPr>
+          <p:cNvPr id="11" name="">
+            <a:extLst xmlns:a="http://schemas.openxmlformats.org/drawingml/2006/main">
+              <a:ext uri="{FF2B5EF4-FFF2-40B4-BE49-F238E27FC236}">
+                <a16:creationId xmlns:a16="http://schemas.microsoft.com/office/drawing/2014/main" id="{36DF8D88-4AB1-4C07-804D-09347CFDA248}"/>
+              </a:ext>
+            </a:extLst>
+          </p:cNvPr>
+          <p:cNvSpPr>
+            <a:spLocks xmlns:a="http://schemas.openxmlformats.org/drawingml/2006/main" noGrp="1"/>
+          </p:cNvSpPr>
+          <p:nvPr/>
+        </p:nvSpPr>
+        <p:spPr>
+          <a:xfrm xmlns:a="http://schemas.openxmlformats.org/drawingml/2006/main">
+            <a:off x="419100" y="4953000"/>
+            <a:ext cx="2857500" cy="228600"/>
+          </a:xfrm>
+          <a:prstGeom xmlns:a="http://schemas.openxmlformats.org/drawingml/2006/main" prst="rect">
+            <a:avLst/>
+          </a:prstGeom>
+          <a:noFill xmlns:a="http://schemas.openxmlformats.org/drawingml/2006/main"/>
+          <a:ln xmlns:a="http://schemas.openxmlformats.org/drawingml/2006/main" w="0">
+            <a:noFill/>
+          </a:ln>
+        </p:spPr>
+        <p:txBody>
+          <a:bodyPr xmlns:a="http://schemas.openxmlformats.org/drawingml/2006/main" anchor="ctr">
+            <a:normAutofit fontScale="100000"/>
+          </a:bodyPr>
+          <a:lstStyle xmlns:a="http://schemas.openxmlformats.org/drawingml/2006/main"/>
+          <a:p xmlns:a="http://schemas.openxmlformats.org/drawingml/2006/main">
+            <a:pPr algn="l">
+              <a:defRPr sz="900" b="1">
+                <a:solidFill>
+                  <a:srgbClr val="41B5E6"/>
+                </a:solidFill>
+                <a:latin typeface="Century Gothic"/>
+                <a:ea typeface="Century Gothic"/>
+                <a:cs typeface="Century Gothic"/>
+              </a:defRPr>
+            </a:pPr>
+            <a:r>
+              <a:rPr sz="900" b="1">
+                <a:solidFill>
+                  <a:srgbClr val="41B5E6"/>
+                </a:solidFill>
+                <a:latin typeface="Century Gothic"/>
+                <a:ea typeface="Century Gothic"/>
+                <a:cs typeface="Century Gothic"/>
+              </a:rPr>
+              <a:t>БОЛЖАМ ШАРТТАРЫ</a:t>
+            </a:r>
+          </a:p>
+        </p:txBody>
+      </p:sp>
+      <p:sp>
+        <p:nvSpPr>
+          <p:cNvPr id="12" name="">
+            <a:extLst xmlns:a="http://schemas.openxmlformats.org/drawingml/2006/main">
+              <a:ext uri="{FF2B5EF4-FFF2-40B4-BE49-F238E27FC236}">
+                <a16:creationId xmlns:a16="http://schemas.microsoft.com/office/drawing/2014/main" id="{DCA3E4CF-2ADF-4254-90C3-CBB8954EE039}"/>
+              </a:ext>
+            </a:extLst>
+          </p:cNvPr>
+          <p:cNvSpPr>
+            <a:spLocks xmlns:a="http://schemas.openxmlformats.org/drawingml/2006/main" noGrp="1"/>
+          </p:cNvSpPr>
+          <p:nvPr/>
+        </p:nvSpPr>
+        <p:spPr>
+          <a:xfrm xmlns:a="http://schemas.openxmlformats.org/drawingml/2006/main">
+            <a:off x="419100" y="5257800"/>
+            <a:ext cx="5191125" cy="628650"/>
+          </a:xfrm>
+          <a:prstGeom xmlns:a="http://schemas.openxmlformats.org/drawingml/2006/main" prst="rect">
+            <a:avLst/>
+          </a:prstGeom>
+          <a:noFill xmlns:a="http://schemas.openxmlformats.org/drawingml/2006/main"/>
+          <a:ln xmlns:a="http://schemas.openxmlformats.org/drawingml/2006/main" w="0">
+            <a:noFill/>
+          </a:ln>
+        </p:spPr>
+        <p:txBody>
+          <a:bodyPr xmlns:a="http://schemas.openxmlformats.org/drawingml/2006/main" anchor="ctr">
+            <a:normAutofit fontScale="100000"/>
+          </a:bodyPr>
+          <a:lstStyle xmlns:a="http://schemas.openxmlformats.org/drawingml/2006/main"/>
+          <a:p xmlns:a="http://schemas.openxmlformats.org/drawingml/2006/main">
+            <a:pPr algn="l">
+              <a:defRPr sz="1050" b="0">
+                <a:solidFill>
+                  <a:srgbClr val="9EADBD"/>
+                </a:solidFill>
+                <a:latin typeface="Century Gothic"/>
+                <a:ea typeface="Century Gothic"/>
+                <a:cs typeface="Century Gothic"/>
+              </a:defRPr>
+            </a:pPr>
+            <a:r>
+              <a:rPr sz="1050" b="0">
+                <a:solidFill>
+                  <a:srgbClr val="9EADBD"/>
+                </a:solidFill>
+                <a:latin typeface="Century Gothic"/>
+                <a:ea typeface="Century Gothic"/>
+                <a:cs typeface="Century Gothic"/>
+              </a:rPr>
+              <a:t>Көлем 18 элемент болып қалады. Команда құрамы өзгермейді. Апталық өнімділік тарихи үлестірімге сәйкес алынды.</a:t>
+            </a:r>
+          </a:p>
+        </p:txBody>
+      </p:sp>
+      <p:sp>
+        <p:nvSpPr>
+          <p:cNvPr id="13" name="">
+            <a:extLst xmlns:a="http://schemas.openxmlformats.org/drawingml/2006/main">
+              <a:ext uri="{FF2B5EF4-FFF2-40B4-BE49-F238E27FC236}">
+                <a16:creationId xmlns:a16="http://schemas.microsoft.com/office/drawing/2014/main" id="{FF63BAEC-AC8B-491F-9BDA-E21783F85F53}"/>
+              </a:ext>
+            </a:extLst>
+          </p:cNvPr>
+          <p:cNvSpPr>
+            <a:spLocks xmlns:a="http://schemas.openxmlformats.org/drawingml/2006/main" noGrp="1"/>
+          </p:cNvSpPr>
+          <p:nvPr/>
+        </p:nvSpPr>
+        <p:spPr>
+          <a:xfrm xmlns:a="http://schemas.openxmlformats.org/drawingml/2006/main">
+            <a:off x="6076950" y="533400"/>
+            <a:ext cx="5467350" cy="5295900"/>
+          </a:xfrm>
+          <a:prstGeom xmlns:a="http://schemas.openxmlformats.org/drawingml/2006/main" prst="roundRect">
+            <a:avLst>
+              <a:gd name="adj" fmla="val 4317"/>
+            </a:avLst>
+          </a:prstGeom>
+          <a:solidFill xmlns:a="http://schemas.openxmlformats.org/drawingml/2006/main">
+            <a:srgbClr val="111F2F"/>
+          </a:solidFill>
+          <a:ln xmlns:a="http://schemas.openxmlformats.org/drawingml/2006/main" w="0">
+            <a:noFill/>
+          </a:ln>
+        </p:spPr>
+      </p:sp>
+      <p:sp>
+        <p:nvSpPr>
+          <p:cNvPr id="14" name="">
+            <a:extLst xmlns:a="http://schemas.openxmlformats.org/drawingml/2006/main">
+              <a:ext uri="{FF2B5EF4-FFF2-40B4-BE49-F238E27FC236}">
+                <a16:creationId xmlns:a16="http://schemas.microsoft.com/office/drawing/2014/main" id="{DDFB4D10-F0FF-4039-8FAF-C8EA024BC7DD}"/>
+              </a:ext>
+            </a:extLst>
+          </p:cNvPr>
+          <p:cNvSpPr>
+            <a:spLocks xmlns:a="http://schemas.openxmlformats.org/drawingml/2006/main" noGrp="1"/>
+          </p:cNvSpPr>
+          <p:nvPr/>
+        </p:nvSpPr>
+        <p:spPr>
+          <a:xfrm xmlns:a="http://schemas.openxmlformats.org/drawingml/2006/main">
+            <a:off x="6515100" y="857250"/>
+            <a:ext cx="4286250" cy="228600"/>
+          </a:xfrm>
+          <a:prstGeom xmlns:a="http://schemas.openxmlformats.org/drawingml/2006/main" prst="rect">
+            <a:avLst/>
+          </a:prstGeom>
+          <a:noFill xmlns:a="http://schemas.openxmlformats.org/drawingml/2006/main"/>
+          <a:ln xmlns:a="http://schemas.openxmlformats.org/drawingml/2006/main" w="0">
+            <a:noFill/>
+          </a:ln>
+        </p:spPr>
+        <p:txBody>
+          <a:bodyPr xmlns:a="http://schemas.openxmlformats.org/drawingml/2006/main" anchor="ctr">
+            <a:normAutofit fontScale="92308"/>
+          </a:bodyPr>
+          <a:lstStyle xmlns:a="http://schemas.openxmlformats.org/drawingml/2006/main"/>
+          <a:p xmlns:a="http://schemas.openxmlformats.org/drawingml/2006/main">
+            <a:pPr algn="l">
+              <a:defRPr sz="975" b="1">
+                <a:solidFill>
+                  <a:srgbClr val="41B5E6"/>
+                </a:solidFill>
+                <a:latin typeface="Century Gothic"/>
+                <a:ea typeface="Century Gothic"/>
+                <a:cs typeface="Century Gothic"/>
+              </a:defRPr>
+            </a:pPr>
+            <a:r>
+              <a:rPr sz="975" b="1">
+                <a:solidFill>
+                  <a:srgbClr val="41B5E6"/>
+                </a:solidFill>
+                <a:latin typeface="Century Gothic"/>
+                <a:ea typeface="Century Gothic"/>
+                <a:cs typeface="Century Gothic"/>
+              </a:rPr>
+              <a:t>АЯҚТАЛУ ЫҚТИМАЛДЫҒЫ</a:t>
+            </a:r>
+          </a:p>
+        </p:txBody>
+      </p:sp>
+      <p:sp>
+        <p:nvSpPr>
+          <p:cNvPr id="15" name="">
+            <a:extLst xmlns:a="http://schemas.openxmlformats.org/drawingml/2006/main">
+              <a:ext uri="{FF2B5EF4-FFF2-40B4-BE49-F238E27FC236}">
+                <a16:creationId xmlns:a16="http://schemas.microsoft.com/office/drawing/2014/main" id="{D57432C7-9A84-48DE-80C4-AB71A4D46777}"/>
+              </a:ext>
+            </a:extLst>
+          </p:cNvPr>
+          <p:cNvSpPr>
+            <a:spLocks xmlns:a="http://schemas.openxmlformats.org/drawingml/2006/main" noGrp="1"/>
+          </p:cNvSpPr>
+          <p:nvPr/>
+        </p:nvSpPr>
+        <p:spPr>
+          <a:xfrm xmlns:a="http://schemas.openxmlformats.org/drawingml/2006/main">
+            <a:off x="6477000" y="1190625"/>
+            <a:ext cx="2428875" cy="876300"/>
+          </a:xfrm>
+          <a:prstGeom xmlns:a="http://schemas.openxmlformats.org/drawingml/2006/main" prst="rect">
+            <a:avLst/>
+          </a:prstGeom>
+          <a:noFill xmlns:a="http://schemas.openxmlformats.org/drawingml/2006/main"/>
+          <a:ln xmlns:a="http://schemas.openxmlformats.org/drawingml/2006/main" w="0">
+            <a:noFill/>
+          </a:ln>
+        </p:spPr>
+        <p:txBody>
+          <a:bodyPr xmlns:a="http://schemas.openxmlformats.org/drawingml/2006/main" anchor="ctr">
+            <a:normAutofit fontScale="98095"/>
+          </a:bodyPr>
+          <a:lstStyle xmlns:a="http://schemas.openxmlformats.org/drawingml/2006/main"/>
+          <a:p xmlns:a="http://schemas.openxmlformats.org/drawingml/2006/main">
+            <a:pPr algn="l">
+              <a:defRPr sz="5250" b="1">
+                <a:solidFill>
+                  <a:srgbClr val="F6FAFD"/>
+                </a:solidFill>
+                <a:latin typeface="Century Gothic"/>
+                <a:ea typeface="Century Gothic"/>
+                <a:cs typeface="Century Gothic"/>
+              </a:defRPr>
+            </a:pPr>
+            <a:r>
+              <a:rPr sz="5250" b="1">
+                <a:solidFill>
+                  <a:srgbClr val="F6FAFD"/>
+                </a:solidFill>
+                <a:latin typeface="Century Gothic"/>
+                <a:ea typeface="Century Gothic"/>
+                <a:cs typeface="Century Gothic"/>
+              </a:rPr>
+              <a:t>85%</a:t>
+            </a:r>
+          </a:p>
+        </p:txBody>
+      </p:sp>
+      <p:sp>
+        <p:nvSpPr>
+          <p:cNvPr id="16" name="">
+            <a:extLst xmlns:a="http://schemas.openxmlformats.org/drawingml/2006/main">
+              <a:ext uri="{FF2B5EF4-FFF2-40B4-BE49-F238E27FC236}">
+                <a16:creationId xmlns:a16="http://schemas.microsoft.com/office/drawing/2014/main" id="{912B0F3E-F038-42EB-81AF-33E1277DD892}"/>
+              </a:ext>
+            </a:extLst>
+          </p:cNvPr>
+          <p:cNvSpPr>
+            <a:spLocks xmlns:a="http://schemas.openxmlformats.org/drawingml/2006/main" noGrp="1"/>
+          </p:cNvSpPr>
+          <p:nvPr/>
+        </p:nvSpPr>
+        <p:spPr>
+          <a:xfrm xmlns:a="http://schemas.openxmlformats.org/drawingml/2006/main">
+            <a:off x="8858250" y="1333500"/>
+            <a:ext cx="2238375" cy="666750"/>
+          </a:xfrm>
+          <a:prstGeom xmlns:a="http://schemas.openxmlformats.org/drawingml/2006/main" prst="rect">
+            <a:avLst/>
+          </a:prstGeom>
+          <a:noFill xmlns:a="http://schemas.openxmlformats.org/drawingml/2006/main"/>
+          <a:ln xmlns:a="http://schemas.openxmlformats.org/drawingml/2006/main" w="0">
+            <a:noFill/>
+          </a:ln>
+        </p:spPr>
+        <p:txBody>
+          <a:bodyPr xmlns:a="http://schemas.openxmlformats.org/drawingml/2006/main" anchor="ctr">
+            <a:normAutofit fontScale="100000"/>
+          </a:bodyPr>
+          <a:lstStyle xmlns:a="http://schemas.openxmlformats.org/drawingml/2006/main"/>
+          <a:p xmlns:a="http://schemas.openxmlformats.org/drawingml/2006/main">
+            <a:pPr algn="l">
               <a:defRPr sz="1500" b="1">
                 <a:solidFill>
-                  <a:srgbClr val="E07A3F"/>
-                </a:solidFill>
-                <a:latin typeface="Arial"/>
-                <a:ea typeface="Arial"/>
-                <a:cs typeface="Arial"/>
+                  <a:srgbClr val="F6FAFD"/>
+                </a:solidFill>
+                <a:latin typeface="Century Gothic"/>
+                <a:ea typeface="Century Gothic"/>
+                <a:cs typeface="Century Gothic"/>
               </a:defRPr>
             </a:pPr>
             <a:r>
               <a:rPr sz="1500" b="1">
                 <a:solidFill>
-                  <a:srgbClr val="E07A3F"/>
-                </a:solidFill>
-                <a:latin typeface="Arial"/>
-                <a:ea typeface="Arial"/>
-                <a:cs typeface="Arial"/>
+                  <a:srgbClr val="F6FAFD"/>
+                </a:solidFill>
+                <a:latin typeface="Century Gothic"/>
+                <a:ea typeface="Century Gothic"/>
+                <a:cs typeface="Century Gothic"/>
               </a:rPr>
-              <a:t>85% вероятность завершить к этой дате</a:t>
+              <a:t>29 қарашаға дейін</a:t>
             </a:r>
           </a:p>
-        </p:txBody>
-      </p:sp>
-      <p:sp>
-        <p:nvSpPr>
-          <p:cNvPr id="7" name="">
-            <a:extLst xmlns:a="http://schemas.openxmlformats.org/drawingml/2006/main">
-              <a:ext uri="{FF2B5EF4-FFF2-40B4-BE49-F238E27FC236}">
-                <a16:creationId xmlns:a16="http://schemas.microsoft.com/office/drawing/2014/main" id="{5099783A-296A-4D81-9D9C-0019C11A6189}"/>
-              </a:ext>
-            </a:extLst>
-          </p:cNvPr>
-          <p:cNvSpPr>
-            <a:spLocks xmlns:a="http://schemas.openxmlformats.org/drawingml/2006/main" noGrp="1"/>
-          </p:cNvSpPr>
-          <p:nvPr/>
-        </p:nvSpPr>
-        <p:spPr>
-          <a:xfrm xmlns:a="http://schemas.openxmlformats.org/drawingml/2006/main">
-            <a:off x="7715250" y="3600450"/>
-            <a:ext cx="3524250" cy="590550"/>
-          </a:xfrm>
-          <a:prstGeom xmlns:a="http://schemas.openxmlformats.org/drawingml/2006/main" prst="rect">
-            <a:avLst/>
-          </a:prstGeom>
-          <a:noFill xmlns:a="http://schemas.openxmlformats.org/drawingml/2006/main"/>
-          <a:ln xmlns:a="http://schemas.openxmlformats.org/drawingml/2006/main" w="0">
-            <a:noFill/>
-          </a:ln>
-        </p:spPr>
-        <p:txBody>
-          <a:bodyPr xmlns:a="http://schemas.openxmlformats.org/drawingml/2006/main">
-            <a:noAutofit/>
-          </a:bodyPr>
-          <a:lstStyle xmlns:a="http://schemas.openxmlformats.org/drawingml/2006/main"/>
           <a:p xmlns:a="http://schemas.openxmlformats.org/drawingml/2006/main">
-            <a:pPr>
-              <a:defRPr sz="1425">
-                <a:solidFill>
-                  <a:srgbClr val="253746"/>
-                </a:solidFill>
-                <a:latin typeface="Arial"/>
-                <a:ea typeface="Arial"/>
-                <a:cs typeface="Arial"/>
+            <a:pPr algn="l">
+              <a:defRPr sz="1500" b="1">
+                <a:solidFill>
+                  <a:srgbClr val="F6FAFD"/>
+                </a:solidFill>
+                <a:latin typeface="Century Gothic"/>
+                <a:ea typeface="Century Gothic"/>
+                <a:cs typeface="Century Gothic"/>
               </a:defRPr>
             </a:pPr>
             <a:r>
-              <a:rPr sz="1425">
-                <a:solidFill>
-                  <a:srgbClr val="253746"/>
-                </a:solidFill>
-                <a:latin typeface="Arial"/>
-                <a:ea typeface="Arial"/>
-                <a:cs typeface="Arial"/>
+              <a:rPr sz="1500" b="1">
+                <a:solidFill>
+                  <a:srgbClr val="F6FAFD"/>
+                </a:solidFill>
+                <a:latin typeface="Century Gothic"/>
+                <a:ea typeface="Century Gothic"/>
+                <a:cs typeface="Century Gothic"/>
               </a:rPr>
-              <a:t>Рабочий диапазон P50–P85</a:t>
+              <a:t>аяқтау ықтималдығы</a:t>
+            </a:r>
+          </a:p>
+        </p:txBody>
+      </p:sp>
+      <p:sp>
+        <p:nvSpPr>
+          <p:cNvPr id="17" name="">
+            <a:extLst xmlns:a="http://schemas.openxmlformats.org/drawingml/2006/main">
+              <a:ext uri="{FF2B5EF4-FFF2-40B4-BE49-F238E27FC236}">
+                <a16:creationId xmlns:a16="http://schemas.microsoft.com/office/drawing/2014/main" id="{4A7A49F3-BE6F-435D-976B-9AB640DA55F2}"/>
+              </a:ext>
+            </a:extLst>
+          </p:cNvPr>
+          <p:cNvSpPr>
+            <a:spLocks xmlns:a="http://schemas.openxmlformats.org/drawingml/2006/main" noGrp="1"/>
+          </p:cNvSpPr>
+          <p:nvPr/>
+        </p:nvSpPr>
+        <p:spPr>
+          <a:xfrm xmlns:a="http://schemas.openxmlformats.org/drawingml/2006/main">
+            <a:off x="6515100" y="2419350"/>
+            <a:ext cx="3905250" cy="209550"/>
+          </a:xfrm>
+          <a:prstGeom xmlns:a="http://schemas.openxmlformats.org/drawingml/2006/main" prst="rect">
+            <a:avLst/>
+          </a:prstGeom>
+          <a:noFill xmlns:a="http://schemas.openxmlformats.org/drawingml/2006/main"/>
+          <a:ln xmlns:a="http://schemas.openxmlformats.org/drawingml/2006/main" w="0">
+            <a:noFill/>
+          </a:ln>
+        </p:spPr>
+        <p:txBody>
+          <a:bodyPr xmlns:a="http://schemas.openxmlformats.org/drawingml/2006/main" anchor="ctr">
+            <a:normAutofit fontScale="86111"/>
+          </a:bodyPr>
+          <a:lstStyle xmlns:a="http://schemas.openxmlformats.org/drawingml/2006/main"/>
+          <a:p xmlns:a="http://schemas.openxmlformats.org/drawingml/2006/main">
+            <a:pPr algn="l">
+              <a:defRPr sz="900" b="1">
+                <a:solidFill>
+                  <a:srgbClr val="9EADBD"/>
+                </a:solidFill>
+                <a:latin typeface="Century Gothic"/>
+                <a:ea typeface="Century Gothic"/>
+                <a:cs typeface="Century Gothic"/>
+              </a:defRPr>
+            </a:pPr>
+            <a:r>
+              <a:rPr sz="900" b="1">
+                <a:solidFill>
+                  <a:srgbClr val="9EADBD"/>
+                </a:solidFill>
+                <a:latin typeface="Century Gothic"/>
+                <a:ea typeface="Century Gothic"/>
+                <a:cs typeface="Century Gothic"/>
+              </a:rPr>
+              <a:t>МЕРЗІМДЕР ДИАПАЗОНЫ</a:t>
+            </a:r>
+          </a:p>
+        </p:txBody>
+      </p:sp>
+      <p:sp>
+        <p:nvSpPr>
+          <p:cNvPr id="18" name="">
+            <a:extLst xmlns:a="http://schemas.openxmlformats.org/drawingml/2006/main">
+              <a:ext uri="{FF2B5EF4-FFF2-40B4-BE49-F238E27FC236}">
+                <a16:creationId xmlns:a16="http://schemas.microsoft.com/office/drawing/2014/main" id="{98D990B5-0A8A-410B-902F-2B87209DA79F}"/>
+              </a:ext>
+            </a:extLst>
+          </p:cNvPr>
+          <p:cNvSpPr>
+            <a:spLocks xmlns:a="http://schemas.openxmlformats.org/drawingml/2006/main" noGrp="1"/>
+          </p:cNvSpPr>
+          <p:nvPr/>
+        </p:nvSpPr>
+        <p:spPr>
+          <a:xfrm xmlns:a="http://schemas.openxmlformats.org/drawingml/2006/main">
+            <a:off x="6858000" y="3333750"/>
+            <a:ext cx="4000500" cy="38100"/>
+          </a:xfrm>
+          <a:prstGeom xmlns:a="http://schemas.openxmlformats.org/drawingml/2006/main" prst="roundRect">
+            <a:avLst>
+              <a:gd name="adj" fmla="val 50000"/>
+            </a:avLst>
+          </a:prstGeom>
+          <a:solidFill xmlns:a="http://schemas.openxmlformats.org/drawingml/2006/main">
+            <a:srgbClr val="29445D"/>
+          </a:solidFill>
+          <a:ln xmlns:a="http://schemas.openxmlformats.org/drawingml/2006/main" w="0">
+            <a:noFill/>
+          </a:ln>
+        </p:spPr>
+      </p:sp>
+      <p:sp>
+        <p:nvSpPr>
+          <p:cNvPr id="19" name="">
+            <a:extLst xmlns:a="http://schemas.openxmlformats.org/drawingml/2006/main">
+              <a:ext uri="{FF2B5EF4-FFF2-40B4-BE49-F238E27FC236}">
+                <a16:creationId xmlns:a16="http://schemas.microsoft.com/office/drawing/2014/main" id="{19F1CFAC-A955-40DF-8AEE-D38914347F2E}"/>
+              </a:ext>
+            </a:extLst>
+          </p:cNvPr>
+          <p:cNvSpPr>
+            <a:spLocks xmlns:a="http://schemas.openxmlformats.org/drawingml/2006/main" noGrp="1"/>
+          </p:cNvSpPr>
+          <p:nvPr/>
+        </p:nvSpPr>
+        <p:spPr>
+          <a:xfrm xmlns:a="http://schemas.openxmlformats.org/drawingml/2006/main">
+            <a:off x="6791325" y="2895600"/>
+            <a:ext cx="742950" cy="228600"/>
+          </a:xfrm>
+          <a:prstGeom xmlns:a="http://schemas.openxmlformats.org/drawingml/2006/main" prst="rect">
+            <a:avLst/>
+          </a:prstGeom>
+          <a:noFill xmlns:a="http://schemas.openxmlformats.org/drawingml/2006/main"/>
+          <a:ln xmlns:a="http://schemas.openxmlformats.org/drawingml/2006/main" w="0">
+            <a:noFill/>
+          </a:ln>
+        </p:spPr>
+        <p:txBody>
+          <a:bodyPr xmlns:a="http://schemas.openxmlformats.org/drawingml/2006/main" anchor="ctr">
+            <a:normAutofit fontScale="92308"/>
+          </a:bodyPr>
+          <a:lstStyle xmlns:a="http://schemas.openxmlformats.org/drawingml/2006/main"/>
+          <a:p xmlns:a="http://schemas.openxmlformats.org/drawingml/2006/main">
+            <a:pPr algn="ctr">
+              <a:defRPr sz="975" b="1">
+                <a:solidFill>
+                  <a:srgbClr val="41B5E6"/>
+                </a:solidFill>
+                <a:latin typeface="Century Gothic"/>
+                <a:ea typeface="Century Gothic"/>
+                <a:cs typeface="Century Gothic"/>
+              </a:defRPr>
+            </a:pPr>
+            <a:r>
+              <a:rPr sz="975" b="1">
+                <a:solidFill>
+                  <a:srgbClr val="41B5E6"/>
+                </a:solidFill>
+                <a:latin typeface="Century Gothic"/>
+                <a:ea typeface="Century Gothic"/>
+                <a:cs typeface="Century Gothic"/>
+              </a:rPr>
+              <a:t>P50</a:t>
+            </a:r>
+          </a:p>
+        </p:txBody>
+      </p:sp>
+      <p:sp>
+        <p:nvSpPr>
+          <p:cNvPr id="20" name="">
+            <a:extLst xmlns:a="http://schemas.openxmlformats.org/drawingml/2006/main">
+              <a:ext uri="{FF2B5EF4-FFF2-40B4-BE49-F238E27FC236}">
+                <a16:creationId xmlns:a16="http://schemas.microsoft.com/office/drawing/2014/main" id="{36293155-6606-4402-8A78-CA9B1315D87D}"/>
+              </a:ext>
+            </a:extLst>
+          </p:cNvPr>
+          <p:cNvSpPr>
+            <a:spLocks xmlns:a="http://schemas.openxmlformats.org/drawingml/2006/main" noGrp="1"/>
+          </p:cNvSpPr>
+          <p:nvPr/>
+        </p:nvSpPr>
+        <p:spPr>
+          <a:xfrm xmlns:a="http://schemas.openxmlformats.org/drawingml/2006/main">
+            <a:off x="7000875" y="3209925"/>
+            <a:ext cx="285750" cy="285750"/>
+          </a:xfrm>
+          <a:prstGeom xmlns:a="http://schemas.openxmlformats.org/drawingml/2006/main" prst="ellipse">
+            <a:avLst/>
+          </a:prstGeom>
+          <a:solidFill xmlns:a="http://schemas.openxmlformats.org/drawingml/2006/main">
+            <a:srgbClr val="41B5E6"/>
+          </a:solidFill>
+          <a:ln xmlns:a="http://schemas.openxmlformats.org/drawingml/2006/main" w="0">
+            <a:noFill/>
+          </a:ln>
+        </p:spPr>
+      </p:sp>
+      <p:sp>
+        <p:nvSpPr>
+          <p:cNvPr id="21" name="">
+            <a:extLst xmlns:a="http://schemas.openxmlformats.org/drawingml/2006/main">
+              <a:ext uri="{FF2B5EF4-FFF2-40B4-BE49-F238E27FC236}">
+                <a16:creationId xmlns:a16="http://schemas.microsoft.com/office/drawing/2014/main" id="{BFC9B650-34A8-4315-8A25-F3F833123B3A}"/>
+              </a:ext>
+            </a:extLst>
+          </p:cNvPr>
+          <p:cNvSpPr>
+            <a:spLocks xmlns:a="http://schemas.openxmlformats.org/drawingml/2006/main" noGrp="1"/>
+          </p:cNvSpPr>
+          <p:nvPr/>
+        </p:nvSpPr>
+        <p:spPr>
+          <a:xfrm xmlns:a="http://schemas.openxmlformats.org/drawingml/2006/main">
+            <a:off x="6762750" y="3638550"/>
+            <a:ext cx="781050" cy="228600"/>
+          </a:xfrm>
+          <a:prstGeom xmlns:a="http://schemas.openxmlformats.org/drawingml/2006/main" prst="rect">
+            <a:avLst/>
+          </a:prstGeom>
+          <a:noFill xmlns:a="http://schemas.openxmlformats.org/drawingml/2006/main"/>
+          <a:ln xmlns:a="http://schemas.openxmlformats.org/drawingml/2006/main" w="0">
+            <a:noFill/>
+          </a:ln>
+        </p:spPr>
+        <p:txBody>
+          <a:bodyPr xmlns:a="http://schemas.openxmlformats.org/drawingml/2006/main" anchor="ctr">
+            <a:normAutofit fontScale="92308"/>
+          </a:bodyPr>
+          <a:lstStyle xmlns:a="http://schemas.openxmlformats.org/drawingml/2006/main"/>
+          <a:p xmlns:a="http://schemas.openxmlformats.org/drawingml/2006/main">
+            <a:pPr algn="ctr">
+              <a:defRPr sz="975" b="1">
+                <a:solidFill>
+                  <a:srgbClr val="F6FAFD"/>
+                </a:solidFill>
+                <a:latin typeface="Century Gothic"/>
+                <a:ea typeface="Century Gothic"/>
+                <a:cs typeface="Century Gothic"/>
+              </a:defRPr>
+            </a:pPr>
+            <a:r>
+              <a:rPr sz="975" b="1">
+                <a:solidFill>
+                  <a:srgbClr val="F6FAFD"/>
+                </a:solidFill>
+                <a:latin typeface="Century Gothic"/>
+                <a:ea typeface="Century Gothic"/>
+                <a:cs typeface="Century Gothic"/>
+              </a:rPr>
+              <a:t>15.11</a:t>
+            </a:r>
+          </a:p>
+        </p:txBody>
+      </p:sp>
+      <p:sp>
+        <p:nvSpPr>
+          <p:cNvPr id="22" name="">
+            <a:extLst xmlns:a="http://schemas.openxmlformats.org/drawingml/2006/main">
+              <a:ext uri="{FF2B5EF4-FFF2-40B4-BE49-F238E27FC236}">
+                <a16:creationId xmlns:a16="http://schemas.microsoft.com/office/drawing/2014/main" id="{3FD87748-99F4-43FC-B479-D7C17E726316}"/>
+              </a:ext>
+            </a:extLst>
+          </p:cNvPr>
+          <p:cNvSpPr>
+            <a:spLocks xmlns:a="http://schemas.openxmlformats.org/drawingml/2006/main" noGrp="1"/>
+          </p:cNvSpPr>
+          <p:nvPr/>
+        </p:nvSpPr>
+        <p:spPr>
+          <a:xfrm xmlns:a="http://schemas.openxmlformats.org/drawingml/2006/main">
+            <a:off x="7981950" y="2895600"/>
+            <a:ext cx="742950" cy="228600"/>
+          </a:xfrm>
+          <a:prstGeom xmlns:a="http://schemas.openxmlformats.org/drawingml/2006/main" prst="rect">
+            <a:avLst/>
+          </a:prstGeom>
+          <a:noFill xmlns:a="http://schemas.openxmlformats.org/drawingml/2006/main"/>
+          <a:ln xmlns:a="http://schemas.openxmlformats.org/drawingml/2006/main" w="0">
+            <a:noFill/>
+          </a:ln>
+        </p:spPr>
+        <p:txBody>
+          <a:bodyPr xmlns:a="http://schemas.openxmlformats.org/drawingml/2006/main" anchor="ctr">
+            <a:normAutofit fontScale="92308"/>
+          </a:bodyPr>
+          <a:lstStyle xmlns:a="http://schemas.openxmlformats.org/drawingml/2006/main"/>
+          <a:p xmlns:a="http://schemas.openxmlformats.org/drawingml/2006/main">
+            <a:pPr algn="ctr">
+              <a:defRPr sz="975" b="1">
+                <a:solidFill>
+                  <a:srgbClr val="41B5E6"/>
+                </a:solidFill>
+                <a:latin typeface="Century Gothic"/>
+                <a:ea typeface="Century Gothic"/>
+                <a:cs typeface="Century Gothic"/>
+              </a:defRPr>
+            </a:pPr>
+            <a:r>
+              <a:rPr sz="975" b="1">
+                <a:solidFill>
+                  <a:srgbClr val="41B5E6"/>
+                </a:solidFill>
+                <a:latin typeface="Century Gothic"/>
+                <a:ea typeface="Century Gothic"/>
+                <a:cs typeface="Century Gothic"/>
+              </a:rPr>
+              <a:t>P70</a:t>
+            </a:r>
+          </a:p>
+        </p:txBody>
+      </p:sp>
+      <p:sp>
+        <p:nvSpPr>
+          <p:cNvPr id="23" name="">
+            <a:extLst xmlns:a="http://schemas.openxmlformats.org/drawingml/2006/main">
+              <a:ext uri="{FF2B5EF4-FFF2-40B4-BE49-F238E27FC236}">
+                <a16:creationId xmlns:a16="http://schemas.microsoft.com/office/drawing/2014/main" id="{BAD4FC55-47FF-40B8-B91E-CF01CB97BE5C}"/>
+              </a:ext>
+            </a:extLst>
+          </p:cNvPr>
+          <p:cNvSpPr>
+            <a:spLocks xmlns:a="http://schemas.openxmlformats.org/drawingml/2006/main" noGrp="1"/>
+          </p:cNvSpPr>
+          <p:nvPr/>
+        </p:nvSpPr>
+        <p:spPr>
+          <a:xfrm xmlns:a="http://schemas.openxmlformats.org/drawingml/2006/main">
+            <a:off x="8191500" y="3209925"/>
+            <a:ext cx="285750" cy="285750"/>
+          </a:xfrm>
+          <a:prstGeom xmlns:a="http://schemas.openxmlformats.org/drawingml/2006/main" prst="ellipse">
+            <a:avLst/>
+          </a:prstGeom>
+          <a:solidFill xmlns:a="http://schemas.openxmlformats.org/drawingml/2006/main">
+            <a:srgbClr val="41B5E6"/>
+          </a:solidFill>
+          <a:ln xmlns:a="http://schemas.openxmlformats.org/drawingml/2006/main" w="0">
+            <a:noFill/>
+          </a:ln>
+        </p:spPr>
+      </p:sp>
+      <p:sp>
+        <p:nvSpPr>
+          <p:cNvPr id="24" name="">
+            <a:extLst xmlns:a="http://schemas.openxmlformats.org/drawingml/2006/main">
+              <a:ext uri="{FF2B5EF4-FFF2-40B4-BE49-F238E27FC236}">
+                <a16:creationId xmlns:a16="http://schemas.microsoft.com/office/drawing/2014/main" id="{4F6E131D-C8C3-4450-9DF4-069D421DF85E}"/>
+              </a:ext>
+            </a:extLst>
+          </p:cNvPr>
+          <p:cNvSpPr>
+            <a:spLocks xmlns:a="http://schemas.openxmlformats.org/drawingml/2006/main" noGrp="1"/>
+          </p:cNvSpPr>
+          <p:nvPr/>
+        </p:nvSpPr>
+        <p:spPr>
+          <a:xfrm xmlns:a="http://schemas.openxmlformats.org/drawingml/2006/main">
+            <a:off x="7953375" y="3638550"/>
+            <a:ext cx="781050" cy="228600"/>
+          </a:xfrm>
+          <a:prstGeom xmlns:a="http://schemas.openxmlformats.org/drawingml/2006/main" prst="rect">
+            <a:avLst/>
+          </a:prstGeom>
+          <a:noFill xmlns:a="http://schemas.openxmlformats.org/drawingml/2006/main"/>
+          <a:ln xmlns:a="http://schemas.openxmlformats.org/drawingml/2006/main" w="0">
+            <a:noFill/>
+          </a:ln>
+        </p:spPr>
+        <p:txBody>
+          <a:bodyPr xmlns:a="http://schemas.openxmlformats.org/drawingml/2006/main" anchor="ctr">
+            <a:normAutofit fontScale="92308"/>
+          </a:bodyPr>
+          <a:lstStyle xmlns:a="http://schemas.openxmlformats.org/drawingml/2006/main"/>
+          <a:p xmlns:a="http://schemas.openxmlformats.org/drawingml/2006/main">
+            <a:pPr algn="ctr">
+              <a:defRPr sz="975" b="1">
+                <a:solidFill>
+                  <a:srgbClr val="F6FAFD"/>
+                </a:solidFill>
+                <a:latin typeface="Century Gothic"/>
+                <a:ea typeface="Century Gothic"/>
+                <a:cs typeface="Century Gothic"/>
+              </a:defRPr>
+            </a:pPr>
+            <a:r>
+              <a:rPr sz="975" b="1">
+                <a:solidFill>
+                  <a:srgbClr val="F6FAFD"/>
+                </a:solidFill>
+                <a:latin typeface="Century Gothic"/>
+                <a:ea typeface="Century Gothic"/>
+                <a:cs typeface="Century Gothic"/>
+              </a:rPr>
+              <a:t>22.11</a:t>
+            </a:r>
+          </a:p>
+        </p:txBody>
+      </p:sp>
+      <p:sp>
+        <p:nvSpPr>
+          <p:cNvPr id="25" name="">
+            <a:extLst xmlns:a="http://schemas.openxmlformats.org/drawingml/2006/main">
+              <a:ext uri="{FF2B5EF4-FFF2-40B4-BE49-F238E27FC236}">
+                <a16:creationId xmlns:a16="http://schemas.microsoft.com/office/drawing/2014/main" id="{7AAF9638-CC31-44F9-B547-9748E20BC97A}"/>
+              </a:ext>
+            </a:extLst>
+          </p:cNvPr>
+          <p:cNvSpPr>
+            <a:spLocks xmlns:a="http://schemas.openxmlformats.org/drawingml/2006/main" noGrp="1"/>
+          </p:cNvSpPr>
+          <p:nvPr/>
+        </p:nvSpPr>
+        <p:spPr>
+          <a:xfrm xmlns:a="http://schemas.openxmlformats.org/drawingml/2006/main">
+            <a:off x="9172575" y="2895600"/>
+            <a:ext cx="742950" cy="228600"/>
+          </a:xfrm>
+          <a:prstGeom xmlns:a="http://schemas.openxmlformats.org/drawingml/2006/main" prst="rect">
+            <a:avLst/>
+          </a:prstGeom>
+          <a:noFill xmlns:a="http://schemas.openxmlformats.org/drawingml/2006/main"/>
+          <a:ln xmlns:a="http://schemas.openxmlformats.org/drawingml/2006/main" w="0">
+            <a:noFill/>
+          </a:ln>
+        </p:spPr>
+        <p:txBody>
+          <a:bodyPr xmlns:a="http://schemas.openxmlformats.org/drawingml/2006/main" anchor="ctr">
+            <a:normAutofit fontScale="92308"/>
+          </a:bodyPr>
+          <a:lstStyle xmlns:a="http://schemas.openxmlformats.org/drawingml/2006/main"/>
+          <a:p xmlns:a="http://schemas.openxmlformats.org/drawingml/2006/main">
+            <a:pPr algn="ctr">
+              <a:defRPr sz="975" b="1">
+                <a:solidFill>
+                  <a:srgbClr val="FF6B36"/>
+                </a:solidFill>
+                <a:latin typeface="Century Gothic"/>
+                <a:ea typeface="Century Gothic"/>
+                <a:cs typeface="Century Gothic"/>
+              </a:defRPr>
+            </a:pPr>
+            <a:r>
+              <a:rPr sz="975" b="1">
+                <a:solidFill>
+                  <a:srgbClr val="FF6B36"/>
+                </a:solidFill>
+                <a:latin typeface="Century Gothic"/>
+                <a:ea typeface="Century Gothic"/>
+                <a:cs typeface="Century Gothic"/>
+              </a:rPr>
+              <a:t>P85</a:t>
+            </a:r>
+          </a:p>
+        </p:txBody>
+      </p:sp>
+      <p:sp>
+        <p:nvSpPr>
+          <p:cNvPr id="26" name="">
+            <a:extLst xmlns:a="http://schemas.openxmlformats.org/drawingml/2006/main">
+              <a:ext uri="{FF2B5EF4-FFF2-40B4-BE49-F238E27FC236}">
+                <a16:creationId xmlns:a16="http://schemas.microsoft.com/office/drawing/2014/main" id="{DF555139-CA68-476C-B69D-A81C4D35C1F8}"/>
+              </a:ext>
+            </a:extLst>
+          </p:cNvPr>
+          <p:cNvSpPr>
+            <a:spLocks xmlns:a="http://schemas.openxmlformats.org/drawingml/2006/main" noGrp="1"/>
+          </p:cNvSpPr>
+          <p:nvPr/>
+        </p:nvSpPr>
+        <p:spPr>
+          <a:xfrm xmlns:a="http://schemas.openxmlformats.org/drawingml/2006/main">
+            <a:off x="9382125" y="3209925"/>
+            <a:ext cx="285750" cy="285750"/>
+          </a:xfrm>
+          <a:prstGeom xmlns:a="http://schemas.openxmlformats.org/drawingml/2006/main" prst="ellipse">
+            <a:avLst/>
+          </a:prstGeom>
+          <a:solidFill xmlns:a="http://schemas.openxmlformats.org/drawingml/2006/main">
+            <a:srgbClr val="FF6B36"/>
+          </a:solidFill>
+          <a:ln xmlns:a="http://schemas.openxmlformats.org/drawingml/2006/main" w="0">
+            <a:noFill/>
+          </a:ln>
+        </p:spPr>
+      </p:sp>
+      <p:sp>
+        <p:nvSpPr>
+          <p:cNvPr id="27" name="">
+            <a:extLst xmlns:a="http://schemas.openxmlformats.org/drawingml/2006/main">
+              <a:ext uri="{FF2B5EF4-FFF2-40B4-BE49-F238E27FC236}">
+                <a16:creationId xmlns:a16="http://schemas.microsoft.com/office/drawing/2014/main" id="{226F346A-4585-49DF-9B36-966DC528C24C}"/>
+              </a:ext>
+            </a:extLst>
+          </p:cNvPr>
+          <p:cNvSpPr>
+            <a:spLocks xmlns:a="http://schemas.openxmlformats.org/drawingml/2006/main" noGrp="1"/>
+          </p:cNvSpPr>
+          <p:nvPr/>
+        </p:nvSpPr>
+        <p:spPr>
+          <a:xfrm xmlns:a="http://schemas.openxmlformats.org/drawingml/2006/main">
+            <a:off x="9144000" y="3638550"/>
+            <a:ext cx="781050" cy="228600"/>
+          </a:xfrm>
+          <a:prstGeom xmlns:a="http://schemas.openxmlformats.org/drawingml/2006/main" prst="rect">
+            <a:avLst/>
+          </a:prstGeom>
+          <a:noFill xmlns:a="http://schemas.openxmlformats.org/drawingml/2006/main"/>
+          <a:ln xmlns:a="http://schemas.openxmlformats.org/drawingml/2006/main" w="0">
+            <a:noFill/>
+          </a:ln>
+        </p:spPr>
+        <p:txBody>
+          <a:bodyPr xmlns:a="http://schemas.openxmlformats.org/drawingml/2006/main" anchor="ctr">
+            <a:normAutofit fontScale="92308"/>
+          </a:bodyPr>
+          <a:lstStyle xmlns:a="http://schemas.openxmlformats.org/drawingml/2006/main"/>
+          <a:p xmlns:a="http://schemas.openxmlformats.org/drawingml/2006/main">
+            <a:pPr algn="ctr">
+              <a:defRPr sz="975" b="1">
+                <a:solidFill>
+                  <a:srgbClr val="F6FAFD"/>
+                </a:solidFill>
+                <a:latin typeface="Century Gothic"/>
+                <a:ea typeface="Century Gothic"/>
+                <a:cs typeface="Century Gothic"/>
+              </a:defRPr>
+            </a:pPr>
+            <a:r>
+              <a:rPr sz="975" b="1">
+                <a:solidFill>
+                  <a:srgbClr val="F6FAFD"/>
+                </a:solidFill>
+                <a:latin typeface="Century Gothic"/>
+                <a:ea typeface="Century Gothic"/>
+                <a:cs typeface="Century Gothic"/>
+              </a:rPr>
+              <a:t>29.11</a:t>
+            </a:r>
+          </a:p>
+        </p:txBody>
+      </p:sp>
+      <p:sp>
+        <p:nvSpPr>
+          <p:cNvPr id="28" name="">
+            <a:extLst xmlns:a="http://schemas.openxmlformats.org/drawingml/2006/main">
+              <a:ext uri="{FF2B5EF4-FFF2-40B4-BE49-F238E27FC236}">
+                <a16:creationId xmlns:a16="http://schemas.microsoft.com/office/drawing/2014/main" id="{D348C09B-BAE4-49DB-AC93-70C06F684408}"/>
+              </a:ext>
+            </a:extLst>
+          </p:cNvPr>
+          <p:cNvSpPr>
+            <a:spLocks xmlns:a="http://schemas.openxmlformats.org/drawingml/2006/main" noGrp="1"/>
+          </p:cNvSpPr>
+          <p:nvPr/>
+        </p:nvSpPr>
+        <p:spPr>
+          <a:xfrm xmlns:a="http://schemas.openxmlformats.org/drawingml/2006/main">
+            <a:off x="10363200" y="2895600"/>
+            <a:ext cx="742950" cy="228600"/>
+          </a:xfrm>
+          <a:prstGeom xmlns:a="http://schemas.openxmlformats.org/drawingml/2006/main" prst="rect">
+            <a:avLst/>
+          </a:prstGeom>
+          <a:noFill xmlns:a="http://schemas.openxmlformats.org/drawingml/2006/main"/>
+          <a:ln xmlns:a="http://schemas.openxmlformats.org/drawingml/2006/main" w="0">
+            <a:noFill/>
+          </a:ln>
+        </p:spPr>
+        <p:txBody>
+          <a:bodyPr xmlns:a="http://schemas.openxmlformats.org/drawingml/2006/main" anchor="ctr">
+            <a:normAutofit fontScale="92308"/>
+          </a:bodyPr>
+          <a:lstStyle xmlns:a="http://schemas.openxmlformats.org/drawingml/2006/main"/>
+          <a:p xmlns:a="http://schemas.openxmlformats.org/drawingml/2006/main">
+            <a:pPr algn="ctr">
+              <a:defRPr sz="975" b="1">
+                <a:solidFill>
+                  <a:srgbClr val="61D2A4"/>
+                </a:solidFill>
+                <a:latin typeface="Century Gothic"/>
+                <a:ea typeface="Century Gothic"/>
+                <a:cs typeface="Century Gothic"/>
+              </a:defRPr>
+            </a:pPr>
+            <a:r>
+              <a:rPr sz="975" b="1">
+                <a:solidFill>
+                  <a:srgbClr val="61D2A4"/>
+                </a:solidFill>
+                <a:latin typeface="Century Gothic"/>
+                <a:ea typeface="Century Gothic"/>
+                <a:cs typeface="Century Gothic"/>
+              </a:rPr>
+              <a:t>P95</a:t>
+            </a:r>
+          </a:p>
+        </p:txBody>
+      </p:sp>
+      <p:sp>
+        <p:nvSpPr>
+          <p:cNvPr id="29" name="">
+            <a:extLst xmlns:a="http://schemas.openxmlformats.org/drawingml/2006/main">
+              <a:ext uri="{FF2B5EF4-FFF2-40B4-BE49-F238E27FC236}">
+                <a16:creationId xmlns:a16="http://schemas.microsoft.com/office/drawing/2014/main" id="{E510AFAA-C716-4E62-9138-4AA70C7FEA0D}"/>
+              </a:ext>
+            </a:extLst>
+          </p:cNvPr>
+          <p:cNvSpPr>
+            <a:spLocks xmlns:a="http://schemas.openxmlformats.org/drawingml/2006/main" noGrp="1"/>
+          </p:cNvSpPr>
+          <p:nvPr/>
+        </p:nvSpPr>
+        <p:spPr>
+          <a:xfrm xmlns:a="http://schemas.openxmlformats.org/drawingml/2006/main">
+            <a:off x="10572750" y="3209925"/>
+            <a:ext cx="285750" cy="285750"/>
+          </a:xfrm>
+          <a:prstGeom xmlns:a="http://schemas.openxmlformats.org/drawingml/2006/main" prst="ellipse">
+            <a:avLst/>
+          </a:prstGeom>
+          <a:solidFill xmlns:a="http://schemas.openxmlformats.org/drawingml/2006/main">
+            <a:srgbClr val="61D2A4"/>
+          </a:solidFill>
+          <a:ln xmlns:a="http://schemas.openxmlformats.org/drawingml/2006/main" w="0">
+            <a:noFill/>
+          </a:ln>
+        </p:spPr>
+      </p:sp>
+      <p:sp>
+        <p:nvSpPr>
+          <p:cNvPr id="30" name="">
+            <a:extLst xmlns:a="http://schemas.openxmlformats.org/drawingml/2006/main">
+              <a:ext uri="{FF2B5EF4-FFF2-40B4-BE49-F238E27FC236}">
+                <a16:creationId xmlns:a16="http://schemas.microsoft.com/office/drawing/2014/main" id="{304FF460-E197-455A-B228-DBBAFC1B643C}"/>
+              </a:ext>
+            </a:extLst>
+          </p:cNvPr>
+          <p:cNvSpPr>
+            <a:spLocks xmlns:a="http://schemas.openxmlformats.org/drawingml/2006/main" noGrp="1"/>
+          </p:cNvSpPr>
+          <p:nvPr/>
+        </p:nvSpPr>
+        <p:spPr>
+          <a:xfrm xmlns:a="http://schemas.openxmlformats.org/drawingml/2006/main">
+            <a:off x="10334625" y="3638550"/>
+            <a:ext cx="781050" cy="228600"/>
+          </a:xfrm>
+          <a:prstGeom xmlns:a="http://schemas.openxmlformats.org/drawingml/2006/main" prst="rect">
+            <a:avLst/>
+          </a:prstGeom>
+          <a:noFill xmlns:a="http://schemas.openxmlformats.org/drawingml/2006/main"/>
+          <a:ln xmlns:a="http://schemas.openxmlformats.org/drawingml/2006/main" w="0">
+            <a:noFill/>
+          </a:ln>
+        </p:spPr>
+        <p:txBody>
+          <a:bodyPr xmlns:a="http://schemas.openxmlformats.org/drawingml/2006/main" anchor="ctr">
+            <a:normAutofit fontScale="92308"/>
+          </a:bodyPr>
+          <a:lstStyle xmlns:a="http://schemas.openxmlformats.org/drawingml/2006/main"/>
+          <a:p xmlns:a="http://schemas.openxmlformats.org/drawingml/2006/main">
+            <a:pPr algn="ctr">
+              <a:defRPr sz="975" b="1">
+                <a:solidFill>
+                  <a:srgbClr val="F6FAFD"/>
+                </a:solidFill>
+                <a:latin typeface="Century Gothic"/>
+                <a:ea typeface="Century Gothic"/>
+                <a:cs typeface="Century Gothic"/>
+              </a:defRPr>
+            </a:pPr>
+            <a:r>
+              <a:rPr sz="975" b="1">
+                <a:solidFill>
+                  <a:srgbClr val="F6FAFD"/>
+                </a:solidFill>
+                <a:latin typeface="Century Gothic"/>
+                <a:ea typeface="Century Gothic"/>
+                <a:cs typeface="Century Gothic"/>
+              </a:rPr>
+              <a:t>13.12</a:t>
+            </a:r>
+          </a:p>
+        </p:txBody>
+      </p:sp>
+      <p:sp>
+        <p:nvSpPr>
+          <p:cNvPr id="31" name="">
+            <a:extLst xmlns:a="http://schemas.openxmlformats.org/drawingml/2006/main">
+              <a:ext uri="{FF2B5EF4-FFF2-40B4-BE49-F238E27FC236}">
+                <a16:creationId xmlns:a16="http://schemas.microsoft.com/office/drawing/2014/main" id="{2DC5E26E-1FB8-4F92-8FBD-6504181A8177}"/>
+              </a:ext>
+            </a:extLst>
+          </p:cNvPr>
+          <p:cNvSpPr>
+            <a:spLocks xmlns:a="http://schemas.openxmlformats.org/drawingml/2006/main" noGrp="1"/>
+          </p:cNvSpPr>
+          <p:nvPr/>
+        </p:nvSpPr>
+        <p:spPr>
+          <a:xfrm xmlns:a="http://schemas.openxmlformats.org/drawingml/2006/main">
+            <a:off x="6515100" y="4267200"/>
+            <a:ext cx="1143000" cy="323850"/>
+          </a:xfrm>
+          <a:prstGeom xmlns:a="http://schemas.openxmlformats.org/drawingml/2006/main" prst="rect">
+            <a:avLst/>
+          </a:prstGeom>
+          <a:noFill xmlns:a="http://schemas.openxmlformats.org/drawingml/2006/main"/>
+          <a:ln xmlns:a="http://schemas.openxmlformats.org/drawingml/2006/main" w="0">
+            <a:noFill/>
+          </a:ln>
+        </p:spPr>
+        <p:txBody>
+          <a:bodyPr xmlns:a="http://schemas.openxmlformats.org/drawingml/2006/main" anchor="ctr">
+            <a:normAutofit fontScale="84722"/>
+          </a:bodyPr>
+          <a:lstStyle xmlns:a="http://schemas.openxmlformats.org/drawingml/2006/main"/>
+          <a:p xmlns:a="http://schemas.openxmlformats.org/drawingml/2006/main">
+            <a:pPr algn="l">
+              <a:defRPr sz="1800" b="1">
+                <a:solidFill>
+                  <a:srgbClr val="41B5E6"/>
+                </a:solidFill>
+                <a:latin typeface="Century Gothic"/>
+                <a:ea typeface="Century Gothic"/>
+                <a:cs typeface="Century Gothic"/>
+              </a:defRPr>
+            </a:pPr>
+            <a:r>
+              <a:rPr sz="1800" b="1">
+                <a:solidFill>
+                  <a:srgbClr val="41B5E6"/>
+                </a:solidFill>
+                <a:latin typeface="Century Gothic"/>
+                <a:ea typeface="Century Gothic"/>
+                <a:cs typeface="Century Gothic"/>
+              </a:rPr>
+              <a:t>50%</a:t>
+            </a:r>
+          </a:p>
+        </p:txBody>
+      </p:sp>
+      <p:sp>
+        <p:nvSpPr>
+          <p:cNvPr id="32" name="">
+            <a:extLst xmlns:a="http://schemas.openxmlformats.org/drawingml/2006/main">
+              <a:ext uri="{FF2B5EF4-FFF2-40B4-BE49-F238E27FC236}">
+                <a16:creationId xmlns:a16="http://schemas.microsoft.com/office/drawing/2014/main" id="{B338EB80-442B-4281-87BC-1C0B11F9BC7E}"/>
+              </a:ext>
+            </a:extLst>
+          </p:cNvPr>
+          <p:cNvSpPr>
+            <a:spLocks xmlns:a="http://schemas.openxmlformats.org/drawingml/2006/main" noGrp="1"/>
+          </p:cNvSpPr>
+          <p:nvPr/>
+        </p:nvSpPr>
+        <p:spPr>
+          <a:xfrm xmlns:a="http://schemas.openxmlformats.org/drawingml/2006/main">
+            <a:off x="6515100" y="4619625"/>
+            <a:ext cx="1714500" cy="495300"/>
+          </a:xfrm>
+          <a:prstGeom xmlns:a="http://schemas.openxmlformats.org/drawingml/2006/main" prst="rect">
+            <a:avLst/>
+          </a:prstGeom>
+          <a:noFill xmlns:a="http://schemas.openxmlformats.org/drawingml/2006/main"/>
+          <a:ln xmlns:a="http://schemas.openxmlformats.org/drawingml/2006/main" w="0">
+            <a:noFill/>
+          </a:ln>
+        </p:spPr>
+        <p:txBody>
+          <a:bodyPr xmlns:a="http://schemas.openxmlformats.org/drawingml/2006/main" anchor="ctr">
+            <a:normAutofit fontScale="100000"/>
+          </a:bodyPr>
+          <a:lstStyle xmlns:a="http://schemas.openxmlformats.org/drawingml/2006/main"/>
+          <a:p xmlns:a="http://schemas.openxmlformats.org/drawingml/2006/main">
+            <a:pPr algn="l">
+              <a:defRPr sz="975" b="0">
+                <a:solidFill>
+                  <a:srgbClr val="9EADBD"/>
+                </a:solidFill>
+                <a:latin typeface="Century Gothic"/>
+                <a:ea typeface="Century Gothic"/>
+                <a:cs typeface="Century Gothic"/>
+              </a:defRPr>
+            </a:pPr>
+            <a:r>
+              <a:rPr sz="975" b="0">
+                <a:solidFill>
+                  <a:srgbClr val="9EADBD"/>
+                </a:solidFill>
+                <a:latin typeface="Century Gothic"/>
+                <a:ea typeface="Century Gothic"/>
+                <a:cs typeface="Century Gothic"/>
+              </a:rPr>
+              <a:t>ең ықтимал орташа</a:t>
             </a:r>
           </a:p>
           <a:p xmlns:a="http://schemas.openxmlformats.org/drawingml/2006/main">
-            <a:pPr>
-              <a:defRPr sz="1425">
-                <a:solidFill>
-                  <a:srgbClr val="253746"/>
-                </a:solidFill>
-                <a:latin typeface="Arial"/>
-                <a:ea typeface="Arial"/>
-                <a:cs typeface="Arial"/>
+            <a:pPr algn="l">
+              <a:defRPr sz="975" b="0">
+                <a:solidFill>
+                  <a:srgbClr val="9EADBD"/>
+                </a:solidFill>
+                <a:latin typeface="Century Gothic"/>
+                <a:ea typeface="Century Gothic"/>
+                <a:cs typeface="Century Gothic"/>
               </a:defRPr>
             </a:pPr>
             <a:r>
-              <a:rPr sz="1425">
-                <a:solidFill>
-                  <a:srgbClr val="253746"/>
-                </a:solidFill>
-                <a:latin typeface="Arial"/>
-                <a:ea typeface="Arial"/>
-                <a:cs typeface="Arial"/>
+              <a:rPr sz="975" b="0">
+                <a:solidFill>
+                  <a:srgbClr val="9EADBD"/>
+                </a:solidFill>
+                <a:latin typeface="Century Gothic"/>
+                <a:ea typeface="Century Gothic"/>
+                <a:cs typeface="Century Gothic"/>
               </a:rPr>
-              <a:t>15–29 ноября</a:t>
+              <a:t>сценарий</a:t>
             </a:r>
           </a:p>
         </p:txBody>
       </p:sp>
       <p:sp>
         <p:nvSpPr>
-          <p:cNvPr id="8" name="">
-            <a:extLst xmlns:a="http://schemas.openxmlformats.org/drawingml/2006/main">
-              <a:ext uri="{FF2B5EF4-FFF2-40B4-BE49-F238E27FC236}">
-                <a16:creationId xmlns:a16="http://schemas.microsoft.com/office/drawing/2014/main" id="{29E657C6-A8F0-449D-B7B7-3C8E880A6EDE}"/>
-              </a:ext>
-            </a:extLst>
-          </p:cNvPr>
-          <p:cNvSpPr>
-            <a:spLocks xmlns:a="http://schemas.openxmlformats.org/drawingml/2006/main" noGrp="1"/>
-          </p:cNvSpPr>
-          <p:nvPr/>
-        </p:nvSpPr>
-        <p:spPr>
-          <a:xfrm xmlns:a="http://schemas.openxmlformats.org/drawingml/2006/main">
-            <a:off x="7715250" y="4391025"/>
-            <a:ext cx="3714750" cy="1028700"/>
+          <p:cNvPr id="33" name="">
+            <a:extLst xmlns:a="http://schemas.openxmlformats.org/drawingml/2006/main">
+              <a:ext uri="{FF2B5EF4-FFF2-40B4-BE49-F238E27FC236}">
+                <a16:creationId xmlns:a16="http://schemas.microsoft.com/office/drawing/2014/main" id="{ADB424B5-AB88-40FD-8F33-0A331A9DCEBF}"/>
+              </a:ext>
+            </a:extLst>
+          </p:cNvPr>
+          <p:cNvSpPr>
+            <a:spLocks xmlns:a="http://schemas.openxmlformats.org/drawingml/2006/main" noGrp="1"/>
+          </p:cNvSpPr>
+          <p:nvPr/>
+        </p:nvSpPr>
+        <p:spPr>
+          <a:xfrm xmlns:a="http://schemas.openxmlformats.org/drawingml/2006/main">
+            <a:off x="8505825" y="4267200"/>
+            <a:ext cx="19050" cy="838200"/>
+          </a:xfrm>
+          <a:prstGeom xmlns:a="http://schemas.openxmlformats.org/drawingml/2006/main" prst="roundRect">
+            <a:avLst>
+              <a:gd name="adj" fmla="val 50000"/>
+            </a:avLst>
+          </a:prstGeom>
+          <a:solidFill xmlns:a="http://schemas.openxmlformats.org/drawingml/2006/main">
+            <a:srgbClr val="29445D"/>
+          </a:solidFill>
+          <a:ln xmlns:a="http://schemas.openxmlformats.org/drawingml/2006/main" w="0">
+            <a:noFill/>
+          </a:ln>
+        </p:spPr>
+      </p:sp>
+      <p:sp>
+        <p:nvSpPr>
+          <p:cNvPr id="34" name="">
+            <a:extLst xmlns:a="http://schemas.openxmlformats.org/drawingml/2006/main">
+              <a:ext uri="{FF2B5EF4-FFF2-40B4-BE49-F238E27FC236}">
+                <a16:creationId xmlns:a16="http://schemas.microsoft.com/office/drawing/2014/main" id="{B59918B6-8021-4972-8AF8-1281E666CE82}"/>
+              </a:ext>
+            </a:extLst>
+          </p:cNvPr>
+          <p:cNvSpPr>
+            <a:spLocks xmlns:a="http://schemas.openxmlformats.org/drawingml/2006/main" noGrp="1"/>
+          </p:cNvSpPr>
+          <p:nvPr/>
+        </p:nvSpPr>
+        <p:spPr>
+          <a:xfrm xmlns:a="http://schemas.openxmlformats.org/drawingml/2006/main">
+            <a:off x="8801100" y="4267200"/>
+            <a:ext cx="1143000" cy="323850"/>
           </a:xfrm>
           <a:prstGeom xmlns:a="http://schemas.openxmlformats.org/drawingml/2006/main" prst="rect">
             <a:avLst/>
@@ -1641,76 +2772,133 @@
           </a:ln>
         </p:spPr>
         <p:txBody>
-          <a:bodyPr xmlns:a="http://schemas.openxmlformats.org/drawingml/2006/main">
-            <a:normAutofit fontScale="98726"/>
+          <a:bodyPr xmlns:a="http://schemas.openxmlformats.org/drawingml/2006/main" anchor="ctr">
+            <a:normAutofit fontScale="84722"/>
           </a:bodyPr>
           <a:lstStyle xmlns:a="http://schemas.openxmlformats.org/drawingml/2006/main"/>
           <a:p xmlns:a="http://schemas.openxmlformats.org/drawingml/2006/main">
-            <a:pPr>
-              <a:defRPr sz="1275">
-                <a:solidFill>
-                  <a:srgbClr val="33475B"/>
-                </a:solidFill>
-                <a:latin typeface="Arial"/>
-                <a:ea typeface="Arial"/>
-                <a:cs typeface="Arial"/>
+            <a:pPr algn="l">
+              <a:defRPr sz="1800" b="1">
+                <a:solidFill>
+                  <a:srgbClr val="61D2A4"/>
+                </a:solidFill>
+                <a:latin typeface="Century Gothic"/>
+                <a:ea typeface="Century Gothic"/>
+                <a:cs typeface="Century Gothic"/>
               </a:defRPr>
             </a:pPr>
             <a:r>
-              <a:rPr sz="1275">
-                <a:solidFill>
-                  <a:srgbClr val="33475B"/>
-                </a:solidFill>
-                <a:latin typeface="Arial"/>
-                <a:ea typeface="Arial"/>
-                <a:cs typeface="Arial"/>
+              <a:rPr sz="1800" b="1">
+                <a:solidFill>
+                  <a:srgbClr val="61D2A4"/>
+                </a:solidFill>
+                <a:latin typeface="Century Gothic"/>
+                <a:ea typeface="Century Gothic"/>
+                <a:cs typeface="Century Gothic"/>
               </a:rPr>
-              <a:t>Допущения</a:t>
+              <a:t>95%</a:t>
+            </a:r>
+          </a:p>
+        </p:txBody>
+      </p:sp>
+      <p:sp>
+        <p:nvSpPr>
+          <p:cNvPr id="35" name="">
+            <a:extLst xmlns:a="http://schemas.openxmlformats.org/drawingml/2006/main">
+              <a:ext uri="{FF2B5EF4-FFF2-40B4-BE49-F238E27FC236}">
+                <a16:creationId xmlns:a16="http://schemas.microsoft.com/office/drawing/2014/main" id="{C975D328-3C5F-4BC8-9379-7522A98C5067}"/>
+              </a:ext>
+            </a:extLst>
+          </p:cNvPr>
+          <p:cNvSpPr>
+            <a:spLocks xmlns:a="http://schemas.openxmlformats.org/drawingml/2006/main" noGrp="1"/>
+          </p:cNvSpPr>
+          <p:nvPr/>
+        </p:nvSpPr>
+        <p:spPr>
+          <a:xfrm xmlns:a="http://schemas.openxmlformats.org/drawingml/2006/main">
+            <a:off x="8801100" y="4619625"/>
+            <a:ext cx="2000250" cy="495300"/>
+          </a:xfrm>
+          <a:prstGeom xmlns:a="http://schemas.openxmlformats.org/drawingml/2006/main" prst="rect">
+            <a:avLst/>
+          </a:prstGeom>
+          <a:noFill xmlns:a="http://schemas.openxmlformats.org/drawingml/2006/main"/>
+          <a:ln xmlns:a="http://schemas.openxmlformats.org/drawingml/2006/main" w="0">
+            <a:noFill/>
+          </a:ln>
+        </p:spPr>
+        <p:txBody>
+          <a:bodyPr xmlns:a="http://schemas.openxmlformats.org/drawingml/2006/main" anchor="ctr">
+            <a:normAutofit fontScale="100000"/>
+          </a:bodyPr>
+          <a:lstStyle xmlns:a="http://schemas.openxmlformats.org/drawingml/2006/main"/>
+          <a:p xmlns:a="http://schemas.openxmlformats.org/drawingml/2006/main">
+            <a:pPr algn="l">
+              <a:defRPr sz="975" b="0">
+                <a:solidFill>
+                  <a:srgbClr val="9EADBD"/>
+                </a:solidFill>
+                <a:latin typeface="Century Gothic"/>
+                <a:ea typeface="Century Gothic"/>
+                <a:cs typeface="Century Gothic"/>
+              </a:defRPr>
+            </a:pPr>
+            <a:r>
+              <a:rPr sz="975" b="0">
+                <a:solidFill>
+                  <a:srgbClr val="9EADBD"/>
+                </a:solidFill>
+                <a:latin typeface="Century Gothic"/>
+                <a:ea typeface="Century Gothic"/>
+                <a:cs typeface="Century Gothic"/>
+              </a:rPr>
+              <a:t>сақтық қоры жоғары</a:t>
             </a:r>
           </a:p>
           <a:p xmlns:a="http://schemas.openxmlformats.org/drawingml/2006/main">
-            <a:pPr>
-              <a:defRPr sz="1275">
-                <a:solidFill>
-                  <a:srgbClr val="33475B"/>
-                </a:solidFill>
-                <a:latin typeface="Arial"/>
-                <a:ea typeface="Arial"/>
-                <a:cs typeface="Arial"/>
+            <a:pPr algn="l">
+              <a:defRPr sz="975" b="0">
+                <a:solidFill>
+                  <a:srgbClr val="9EADBD"/>
+                </a:solidFill>
+                <a:latin typeface="Century Gothic"/>
+                <a:ea typeface="Century Gothic"/>
+                <a:cs typeface="Century Gothic"/>
               </a:defRPr>
             </a:pPr>
             <a:r>
-              <a:rPr sz="1275">
-                <a:solidFill>
-                  <a:srgbClr val="33475B"/>
-                </a:solidFill>
-                <a:latin typeface="Arial"/>
-                <a:ea typeface="Arial"/>
-                <a:cs typeface="Arial"/>
+              <a:rPr sz="975" b="0">
+                <a:solidFill>
+                  <a:srgbClr val="9EADBD"/>
+                </a:solidFill>
+                <a:latin typeface="Century Gothic"/>
+                <a:ea typeface="Century Gothic"/>
+                <a:cs typeface="Century Gothic"/>
               </a:rPr>
-              <a:t>Объём остаётся равным 18 элементам. Состав команды не меняется. Недельный throughput следует историческому распределению.</a:t>
+              <a:t>сценарий</a:t>
             </a:r>
           </a:p>
         </p:txBody>
       </p:sp>
       <p:sp>
         <p:nvSpPr>
-          <p:cNvPr id="9" name="">
-            <a:extLst xmlns:a="http://schemas.openxmlformats.org/drawingml/2006/main">
-              <a:ext uri="{FF2B5EF4-FFF2-40B4-BE49-F238E27FC236}">
-                <a16:creationId xmlns:a16="http://schemas.microsoft.com/office/drawing/2014/main" id="{9E2C70B2-56AE-4EEA-8048-39E9DBE95A8A}"/>
-              </a:ext>
-            </a:extLst>
-          </p:cNvPr>
-          <p:cNvSpPr>
-            <a:spLocks xmlns:a="http://schemas.openxmlformats.org/drawingml/2006/main" noGrp="1"/>
-          </p:cNvSpPr>
-          <p:nvPr/>
-        </p:nvSpPr>
-        <p:spPr>
-          <a:xfrm xmlns:a="http://schemas.openxmlformats.org/drawingml/2006/main">
-            <a:off x="647700" y="5314950"/>
-            <a:ext cx="10763250" cy="723900"/>
+          <p:cNvPr id="36" name="">
+            <a:extLst xmlns:a="http://schemas.openxmlformats.org/drawingml/2006/main">
+              <a:ext uri="{FF2B5EF4-FFF2-40B4-BE49-F238E27FC236}">
+                <a16:creationId xmlns:a16="http://schemas.microsoft.com/office/drawing/2014/main" id="{7A70E89C-2CF3-4774-A690-0DD1FD48BD79}"/>
+              </a:ext>
+            </a:extLst>
+          </p:cNvPr>
+          <p:cNvSpPr>
+            <a:spLocks xmlns:a="http://schemas.openxmlformats.org/drawingml/2006/main" noGrp="1"/>
+          </p:cNvSpPr>
+          <p:nvPr/>
+        </p:nvSpPr>
+        <p:spPr>
+          <a:xfrm xmlns:a="http://schemas.openxmlformats.org/drawingml/2006/main">
+            <a:off x="6076950" y="6019800"/>
+            <a:ext cx="5467350" cy="400050"/>
           </a:xfrm>
           <a:prstGeom xmlns:a="http://schemas.openxmlformats.org/drawingml/2006/main" prst="rect">
             <a:avLst/>
@@ -1721,53 +2909,53 @@
           </a:ln>
         </p:spPr>
         <p:txBody>
-          <a:bodyPr xmlns:a="http://schemas.openxmlformats.org/drawingml/2006/main">
-            <a:normAutofit fontScale="100000"/>
+          <a:bodyPr xmlns:a="http://schemas.openxmlformats.org/drawingml/2006/main" anchor="ctr">
+            <a:normAutofit fontScale="90000"/>
           </a:bodyPr>
           <a:lstStyle xmlns:a="http://schemas.openxmlformats.org/drawingml/2006/main"/>
           <a:p xmlns:a="http://schemas.openxmlformats.org/drawingml/2006/main">
-            <a:pPr>
-              <a:defRPr sz="1350" b="1">
-                <a:solidFill>
-                  <a:srgbClr val="142735"/>
-                </a:solidFill>
-                <a:latin typeface="Arial"/>
-                <a:ea typeface="Arial"/>
-                <a:cs typeface="Arial"/>
+            <a:pPr algn="l">
+              <a:defRPr sz="1125" b="1">
+                <a:solidFill>
+                  <a:srgbClr val="F6FAFD"/>
+                </a:solidFill>
+                <a:latin typeface="Century Gothic"/>
+                <a:ea typeface="Century Gothic"/>
+                <a:cs typeface="Century Gothic"/>
               </a:defRPr>
             </a:pPr>
             <a:r>
-              <a:rPr sz="1350" b="1">
-                <a:solidFill>
-                  <a:srgbClr val="142735"/>
-                </a:solidFill>
-                <a:latin typeface="Arial"/>
-                <a:ea typeface="Arial"/>
-                <a:cs typeface="Arial"/>
+              <a:rPr sz="1125" b="1">
+                <a:solidFill>
+                  <a:srgbClr val="F6FAFD"/>
+                </a:solidFill>
+                <a:latin typeface="Century Gothic"/>
+                <a:ea typeface="Century Gothic"/>
+                <a:cs typeface="Century Gothic"/>
               </a:rPr>
-              <a:t>Прогноз изменят новый scope, внешние блокировки, изменение состава команды или устойчивое изменение throughput.</a:t>
+              <a:t>Жұмыс көлемі, сыртқы блоктаушылар немесе команда құрамының өзгеруі болжамды өзгертеді.</a:t>
             </a:r>
           </a:p>
         </p:txBody>
       </p:sp>
       <p:sp>
         <p:nvSpPr>
-          <p:cNvPr id="10" name="">
-            <a:extLst xmlns:a="http://schemas.openxmlformats.org/drawingml/2006/main">
-              <a:ext uri="{FF2B5EF4-FFF2-40B4-BE49-F238E27FC236}">
-                <a16:creationId xmlns:a16="http://schemas.microsoft.com/office/drawing/2014/main" id="{2E11C8FB-B778-47B2-A1B5-9A6C8347545E}"/>
-              </a:ext>
-            </a:extLst>
-          </p:cNvPr>
-          <p:cNvSpPr>
-            <a:spLocks xmlns:a="http://schemas.openxmlformats.org/drawingml/2006/main" noGrp="1"/>
-          </p:cNvSpPr>
-          <p:nvPr/>
-        </p:nvSpPr>
-        <p:spPr>
-          <a:xfrm xmlns:a="http://schemas.openxmlformats.org/drawingml/2006/main">
-            <a:off x="647700" y="6191250"/>
-            <a:ext cx="10763250" cy="266700"/>
+          <p:cNvPr id="37" name="">
+            <a:extLst xmlns:a="http://schemas.openxmlformats.org/drawingml/2006/main">
+              <a:ext uri="{FF2B5EF4-FFF2-40B4-BE49-F238E27FC236}">
+                <a16:creationId xmlns:a16="http://schemas.microsoft.com/office/drawing/2014/main" id="{DB2CECF8-E90E-4045-9715-4DACCF3B243D}"/>
+              </a:ext>
+            </a:extLst>
+          </p:cNvPr>
+          <p:cNvSpPr>
+            <a:spLocks xmlns:a="http://schemas.openxmlformats.org/drawingml/2006/main" noGrp="1"/>
+          </p:cNvSpPr>
+          <p:nvPr/>
+        </p:nvSpPr>
+        <p:spPr>
+          <a:xfrm xmlns:a="http://schemas.openxmlformats.org/drawingml/2006/main">
+            <a:off x="419100" y="6419850"/>
+            <a:ext cx="6572250" cy="190500"/>
           </a:xfrm>
           <a:prstGeom xmlns:a="http://schemas.openxmlformats.org/drawingml/2006/main" prst="rect">
             <a:avLst/>
@@ -1778,31 +2966,31 @@
           </a:ln>
         </p:spPr>
         <p:txBody>
-          <a:bodyPr xmlns:a="http://schemas.openxmlformats.org/drawingml/2006/main">
-            <a:noAutofit/>
+          <a:bodyPr xmlns:a="http://schemas.openxmlformats.org/drawingml/2006/main" anchor="ctr">
+            <a:normAutofit fontScale="86667"/>
           </a:bodyPr>
           <a:lstStyle xmlns:a="http://schemas.openxmlformats.org/drawingml/2006/main"/>
           <a:p xmlns:a="http://schemas.openxmlformats.org/drawingml/2006/main">
-            <a:pPr>
-              <a:defRPr sz="900">
-                <a:solidFill>
-                  <a:srgbClr val="627384"/>
-                </a:solidFill>
-                <a:latin typeface="Arial"/>
-                <a:ea typeface="Arial"/>
-                <a:cs typeface="Arial"/>
+            <a:pPr algn="l">
+              <a:defRPr sz="750" b="0">
+                <a:solidFill>
+                  <a:srgbClr val="9EADBD"/>
+                </a:solidFill>
+                <a:latin typeface="Century Gothic"/>
+                <a:ea typeface="Century Gothic"/>
+                <a:cs typeface="Century Gothic"/>
               </a:defRPr>
             </a:pPr>
             <a:r>
-              <a:rPr sz="900">
-                <a:solidFill>
-                  <a:srgbClr val="627384"/>
-                </a:solidFill>
-                <a:latin typeface="Arial"/>
-                <a:ea typeface="Arial"/>
-                <a:cs typeface="Arial"/>
+              <a:rPr sz="750" b="0">
+                <a:solidFill>
+                  <a:srgbClr val="9EADBD"/>
+                </a:solidFill>
+                <a:latin typeface="Century Gothic"/>
+                <a:ea typeface="Century Gothic"/>
+                <a:cs typeface="Century Gothic"/>
               </a:rPr>
-              <a:t>Источник истории: 106 закрытых issues Pallets Click, 26 недель, 06.04–04.10.2026. Внешний proxy для учебного прогноза.</a:t>
+              <a:t>Дереккөз: Pallets Click · 106 жабылған тапсырма · 26 апта · сыртқы балама дерек</a:t>
             </a:r>
           </a:p>
         </p:txBody>
@@ -1810,7 +2998,7 @@
     </p:spTree>
     <p:extLst>
       <p:ext uri="{BB962C8B-B14F-4D97-AF65-F5344CB8AC3E}">
-        <p14:creationId xmlns:p14="http://schemas.microsoft.com/office/powerpoint/2010/main" val="211095537"/>
+        <p14:creationId xmlns:p14="http://schemas.microsoft.com/office/powerpoint/2010/main" val="1270668123"/>
       </p:ext>
     </p:extLst>
   </p:cSld>

</xml_diff>

<commit_message>
docs: align LZ 6 forecast with methodology
</commit_message>
<xml_diff>
--- a/docs/forecast/lz6-when-ready.pptx
+++ b/docs/forecast/lz6-when-ready.pptx
@@ -2,13 +2,13 @@
 <file path=ppt/presentation.xml><?xml version="1.0" encoding="utf-8"?>
 <p:presentation xmlns:p="http://schemas.openxmlformats.org/presentationml/2006/main">
   <p:sldMasterIdLst>
-    <p:sldMasterId xmlns:r="http://schemas.openxmlformats.org/officeDocument/2006/relationships" id="2147483648" r:id="R82a9caec32004f2c"/>
+    <p:sldMasterId xmlns:r="http://schemas.openxmlformats.org/officeDocument/2006/relationships" id="2147483648" r:id="R24cd3ad7e0ee4530"/>
   </p:sldMasterIdLst>
   <p:notesMasterIdLst>
-    <p:notesMasterId xmlns:r="http://schemas.openxmlformats.org/officeDocument/2006/relationships" r:id="R654c9f7af4264fc8"/>
+    <p:notesMasterId xmlns:r="http://schemas.openxmlformats.org/officeDocument/2006/relationships" r:id="R1e3a60df065a4871"/>
   </p:notesMasterIdLst>
   <p:sldIdLst>
-    <p:sldId xmlns:r="http://schemas.openxmlformats.org/officeDocument/2006/relationships" id="256" r:id="R92b847a8f4ee4c5c"/>
+    <p:sldId xmlns:r="http://schemas.openxmlformats.org/officeDocument/2006/relationships" id="256" r:id="Rb01807d3190d461e"/>
   </p:sldIdLst>
   <p:sldSz cx="12192000" cy="6858000"/>
   <p:notesSz cx="6858000" cy="9144000"/>
@@ -198,16 +198,16 @@
         <a:srgbClr val="96607D"/>
       </a:folHlink>
     </a:clrScheme>
-    <a:fontScheme name="Office">
+    <a:fontScheme name="">
       <a:majorFont>
-        <a:latin typeface="Calibri Light"/>
-        <a:ea typeface="Calibri Light"/>
-        <a:cs typeface="Calibri Light"/>
+        <a:latin typeface="Aptos"/>
+        <a:ea typeface=""/>
+        <a:cs typeface=""/>
       </a:majorFont>
       <a:minorFont>
-        <a:latin typeface="Calibri"/>
-        <a:ea typeface="Calibri"/>
-        <a:cs typeface="Calibri"/>
+        <a:latin typeface="Aptos"/>
+        <a:ea typeface=""/>
+        <a:cs typeface=""/>
       </a:minorFont>
     </a:fontScheme>
     <a:fmtScheme name="ChatGPT">
@@ -442,7 +442,7 @@
           <a:lstStyle xmlns:a="http://schemas.openxmlformats.org/drawingml/2006/main"/>
           <a:p xmlns:a="http://schemas.openxmlformats.org/drawingml/2006/main">
             <a:r>
-              <a:t>Дереккөз: https://github.com/pallets/click. 06.04.2026–04.10.2026 аралығындағы 106 жабылған issue. Модель: апталық throughput деректерін қайтарумен bootstrap іріктеу, 10 000 симуляция, seed 20261008, 18 элемент. P50 — 15.11.2026, P70 — 22.11.2026, P85 — 29.11.2026, P95 — 13.12.2026.</a:t>
+              <a:t>Дереккөз: https://github.com/pallets/click/issues?q=is%3Aissue%20is%3Aclosed%20closed%3A2026-04-06..2026-10-04. Қаралған күні: 08.10.2026. 06.04.2026–04.10.2026 аралығындағы 106 жабылған issue және 26 толық апта. Модель: тарихи апталық throughput мәнін қайтарумен кездейсоқ таңдау, 10 000 симуляция, seed 20261008, 18 элемент. Нәтиже: 50% — 12.11.2026, 70% — 19.11.2026, 85% — 26.11.2026, 95% — 10.12.2026. OpenAI Codex слайд макеті мен формулировкалардың бастапқы нұсқасын дайындауға қолданылды.</a:t>
             </a:r>
           </a:p>
         </p:txBody>
@@ -475,6 +475,1661 @@
 <file path=ppt/slideLayouts/slideLayout1.xml><?xml version="1.0" encoding="utf-8"?>
 <p:sldLayout xmlns:p="http://schemas.openxmlformats.org/presentationml/2006/main" type="title">
   <p:cSld name="Title Slide">
+    <p:spTree>
+      <p:nvGrpSpPr>
+        <p:cNvPr id="1" name=""/>
+        <p:cNvGrpSpPr/>
+        <p:nvPr/>
+      </p:nvGrpSpPr>
+      <p:grpSpPr>
+        <a:xfrm xmlns:a="http://schemas.openxmlformats.org/drawingml/2006/main"/>
+      </p:grpSpPr>
+      <p:sp>
+        <p:nvSpPr>
+          <p:cNvPr id="3" name="Title">
+            <a:extLst xmlns:a="http://schemas.openxmlformats.org/drawingml/2006/main">
+              <a:ext uri="{FF2B5EF4-FFF2-40B4-BE49-F238E27FC236}">
+                <a16:creationId xmlns:a16="http://schemas.microsoft.com/office/drawing/2014/main" id="{F60C6804-8FA0-4D2D-929C-3DBBA50BE547}"/>
+              </a:ext>
+            </a:extLst>
+          </p:cNvPr>
+          <p:cNvSpPr>
+            <a:spLocks xmlns:a="http://schemas.openxmlformats.org/drawingml/2006/main" noGrp="1"/>
+          </p:cNvSpPr>
+          <p:nvPr>
+            <p:ph type="title" idx="0"/>
+          </p:nvPr>
+        </p:nvSpPr>
+        <p:spPr>
+          <a:xfrm xmlns:a="http://schemas.openxmlformats.org/drawingml/2006/main">
+            <a:off x="1219200" y="2590800"/>
+            <a:ext cx="9753600" cy="990600"/>
+          </a:xfrm>
+          <a:prstGeom xmlns:a="http://schemas.openxmlformats.org/drawingml/2006/main" prst="rect">
+            <a:avLst/>
+          </a:prstGeom>
+          <a:noFill xmlns:a="http://schemas.openxmlformats.org/drawingml/2006/main"/>
+          <a:ln xmlns:a="http://schemas.openxmlformats.org/drawingml/2006/main">
+            <a:noFill/>
+            <a:prstDash val="solid"/>
+          </a:ln>
+        </p:spPr>
+        <p:txBody>
+          <a:bodyPr xmlns:a="http://schemas.openxmlformats.org/drawingml/2006/main" wrap="square" lIns="0" tIns="0" rIns="0" bIns="0" anchor="ctr">
+            <a:normAutofit/>
+          </a:bodyPr>
+          <a:lstStyle xmlns:a="http://schemas.openxmlformats.org/drawingml/2006/main">
+            <a:defPPr algn="ctr">
+              <a:defRPr sz="4800" b="1">
+                <a:solidFill>
+                  <a:schemeClr val="tx1"/>
+                </a:solidFill>
+                <a:latin typeface="+mj-lt"/>
+                <a:ea typeface="+mj-lt"/>
+                <a:cs typeface="+mj-lt"/>
+              </a:defRPr>
+            </a:defPPr>
+            <a:lvl1pPr marL="0" indent="0">
+              <a:lnSpc>
+                <a:spcPct val="110000"/>
+              </a:lnSpc>
+              <a:spcBef>
+                <a:spcPts val="0"/>
+              </a:spcBef>
+              <a:spcAft>
+                <a:spcPts val="0"/>
+              </a:spcAft>
+              <a:buNone/>
+            </a:lvl1pPr>
+            <a:lvl2pPr marL="0" indent="0">
+              <a:lnSpc>
+                <a:spcPct val="110000"/>
+              </a:lnSpc>
+              <a:spcBef>
+                <a:spcPts val="0"/>
+              </a:spcBef>
+              <a:spcAft>
+                <a:spcPts val="0"/>
+              </a:spcAft>
+              <a:buNone/>
+            </a:lvl2pPr>
+            <a:lvl3pPr marL="0" indent="0">
+              <a:lnSpc>
+                <a:spcPct val="110000"/>
+              </a:lnSpc>
+              <a:spcBef>
+                <a:spcPts val="0"/>
+              </a:spcBef>
+              <a:spcAft>
+                <a:spcPts val="0"/>
+              </a:spcAft>
+              <a:buNone/>
+            </a:lvl3pPr>
+            <a:lvl4pPr marL="0" indent="0">
+              <a:lnSpc>
+                <a:spcPct val="110000"/>
+              </a:lnSpc>
+              <a:spcBef>
+                <a:spcPts val="0"/>
+              </a:spcBef>
+              <a:spcAft>
+                <a:spcPts val="0"/>
+              </a:spcAft>
+              <a:buNone/>
+            </a:lvl4pPr>
+            <a:lvl5pPr marL="0" indent="0">
+              <a:lnSpc>
+                <a:spcPct val="110000"/>
+              </a:lnSpc>
+              <a:spcBef>
+                <a:spcPts val="0"/>
+              </a:spcBef>
+              <a:spcAft>
+                <a:spcPts val="0"/>
+              </a:spcAft>
+              <a:buNone/>
+            </a:lvl5pPr>
+            <a:lvl6pPr marL="0" indent="0">
+              <a:lnSpc>
+                <a:spcPct val="110000"/>
+              </a:lnSpc>
+              <a:spcBef>
+                <a:spcPts val="0"/>
+              </a:spcBef>
+              <a:spcAft>
+                <a:spcPts val="0"/>
+              </a:spcAft>
+              <a:buNone/>
+            </a:lvl6pPr>
+            <a:lvl7pPr marL="0" indent="0">
+              <a:lnSpc>
+                <a:spcPct val="110000"/>
+              </a:lnSpc>
+              <a:spcBef>
+                <a:spcPts val="0"/>
+              </a:spcBef>
+              <a:spcAft>
+                <a:spcPts val="0"/>
+              </a:spcAft>
+              <a:buNone/>
+            </a:lvl7pPr>
+            <a:lvl8pPr marL="0" indent="0">
+              <a:lnSpc>
+                <a:spcPct val="110000"/>
+              </a:lnSpc>
+              <a:spcBef>
+                <a:spcPts val="0"/>
+              </a:spcBef>
+              <a:spcAft>
+                <a:spcPts val="0"/>
+              </a:spcAft>
+              <a:buNone/>
+            </a:lvl8pPr>
+            <a:lvl9pPr marL="0" indent="0">
+              <a:lnSpc>
+                <a:spcPct val="110000"/>
+              </a:lnSpc>
+              <a:spcBef>
+                <a:spcPts val="0"/>
+              </a:spcBef>
+              <a:spcAft>
+                <a:spcPts val="0"/>
+              </a:spcAft>
+              <a:buNone/>
+            </a:lvl9pPr>
+          </a:lstStyle>
+          <a:p xmlns:a="http://schemas.openxmlformats.org/drawingml/2006/main"/>
+        </p:txBody>
+      </p:sp>
+      <p:sp>
+        <p:nvSpPr>
+          <p:cNvPr id="2" name="Subtitle">
+            <a:extLst xmlns:a="http://schemas.openxmlformats.org/drawingml/2006/main">
+              <a:ext uri="{FF2B5EF4-FFF2-40B4-BE49-F238E27FC236}">
+                <a16:creationId xmlns:a16="http://schemas.microsoft.com/office/drawing/2014/main" id="{0D7AB263-3B01-4F9C-B377-5D006CA49E6D}"/>
+              </a:ext>
+            </a:extLst>
+          </p:cNvPr>
+          <p:cNvSpPr>
+            <a:spLocks xmlns:a="http://schemas.openxmlformats.org/drawingml/2006/main" noGrp="1"/>
+          </p:cNvSpPr>
+          <p:nvPr>
+            <p:ph type="subTitle" idx="1"/>
+          </p:nvPr>
+        </p:nvSpPr>
+        <p:spPr>
+          <a:xfrm xmlns:a="http://schemas.openxmlformats.org/drawingml/2006/main">
+            <a:off x="1828800" y="3771900"/>
+            <a:ext cx="8534400" cy="762000"/>
+          </a:xfrm>
+          <a:prstGeom xmlns:a="http://schemas.openxmlformats.org/drawingml/2006/main" prst="rect">
+            <a:avLst/>
+          </a:prstGeom>
+          <a:noFill xmlns:a="http://schemas.openxmlformats.org/drawingml/2006/main"/>
+          <a:ln xmlns:a="http://schemas.openxmlformats.org/drawingml/2006/main">
+            <a:noFill/>
+            <a:prstDash val="solid"/>
+          </a:ln>
+        </p:spPr>
+        <p:txBody>
+          <a:bodyPr xmlns:a="http://schemas.openxmlformats.org/drawingml/2006/main" wrap="square" lIns="0" tIns="0" rIns="0" bIns="0" anchor="ctr">
+            <a:normAutofit/>
+          </a:bodyPr>
+          <a:lstStyle xmlns:a="http://schemas.openxmlformats.org/drawingml/2006/main">
+            <a:defPPr algn="ctr">
+              <a:defRPr sz="2100" b="0">
+                <a:solidFill>
+                  <a:schemeClr val="tx1"/>
+                </a:solidFill>
+                <a:latin typeface="+mn-lt"/>
+                <a:ea typeface="+mn-lt"/>
+                <a:cs typeface="+mn-lt"/>
+              </a:defRPr>
+            </a:defPPr>
+            <a:lvl1pPr marL="0" indent="0">
+              <a:lnSpc>
+                <a:spcPct val="110000"/>
+              </a:lnSpc>
+              <a:spcBef>
+                <a:spcPts val="0"/>
+              </a:spcBef>
+              <a:spcAft>
+                <a:spcPts val="0"/>
+              </a:spcAft>
+              <a:buNone/>
+            </a:lvl1pPr>
+            <a:lvl2pPr marL="0" indent="0">
+              <a:lnSpc>
+                <a:spcPct val="110000"/>
+              </a:lnSpc>
+              <a:spcBef>
+                <a:spcPts val="0"/>
+              </a:spcBef>
+              <a:spcAft>
+                <a:spcPts val="0"/>
+              </a:spcAft>
+              <a:buNone/>
+            </a:lvl2pPr>
+            <a:lvl3pPr marL="0" indent="0">
+              <a:lnSpc>
+                <a:spcPct val="110000"/>
+              </a:lnSpc>
+              <a:spcBef>
+                <a:spcPts val="0"/>
+              </a:spcBef>
+              <a:spcAft>
+                <a:spcPts val="0"/>
+              </a:spcAft>
+              <a:buNone/>
+            </a:lvl3pPr>
+            <a:lvl4pPr marL="0" indent="0">
+              <a:lnSpc>
+                <a:spcPct val="110000"/>
+              </a:lnSpc>
+              <a:spcBef>
+                <a:spcPts val="0"/>
+              </a:spcBef>
+              <a:spcAft>
+                <a:spcPts val="0"/>
+              </a:spcAft>
+              <a:buNone/>
+            </a:lvl4pPr>
+            <a:lvl5pPr marL="0" indent="0">
+              <a:lnSpc>
+                <a:spcPct val="110000"/>
+              </a:lnSpc>
+              <a:spcBef>
+                <a:spcPts val="0"/>
+              </a:spcBef>
+              <a:spcAft>
+                <a:spcPts val="0"/>
+              </a:spcAft>
+              <a:buNone/>
+            </a:lvl5pPr>
+            <a:lvl6pPr marL="0" indent="0">
+              <a:lnSpc>
+                <a:spcPct val="110000"/>
+              </a:lnSpc>
+              <a:spcBef>
+                <a:spcPts val="0"/>
+              </a:spcBef>
+              <a:spcAft>
+                <a:spcPts val="0"/>
+              </a:spcAft>
+              <a:buNone/>
+            </a:lvl6pPr>
+            <a:lvl7pPr marL="0" indent="0">
+              <a:lnSpc>
+                <a:spcPct val="110000"/>
+              </a:lnSpc>
+              <a:spcBef>
+                <a:spcPts val="0"/>
+              </a:spcBef>
+              <a:spcAft>
+                <a:spcPts val="0"/>
+              </a:spcAft>
+              <a:buNone/>
+            </a:lvl7pPr>
+            <a:lvl8pPr marL="0" indent="0">
+              <a:lnSpc>
+                <a:spcPct val="110000"/>
+              </a:lnSpc>
+              <a:spcBef>
+                <a:spcPts val="0"/>
+              </a:spcBef>
+              <a:spcAft>
+                <a:spcPts val="0"/>
+              </a:spcAft>
+              <a:buNone/>
+            </a:lvl8pPr>
+            <a:lvl9pPr marL="0" indent="0">
+              <a:lnSpc>
+                <a:spcPct val="110000"/>
+              </a:lnSpc>
+              <a:spcBef>
+                <a:spcPts val="0"/>
+              </a:spcBef>
+              <a:spcAft>
+                <a:spcPts val="0"/>
+              </a:spcAft>
+              <a:buNone/>
+            </a:lvl9pPr>
+          </a:lstStyle>
+          <a:p xmlns:a="http://schemas.openxmlformats.org/drawingml/2006/main"/>
+        </p:txBody>
+      </p:sp>
+    </p:spTree>
+  </p:cSld>
+</p:sldLayout>
+</file>
+
+<file path=ppt/slideLayouts/slideLayout2.xml><?xml version="1.0" encoding="utf-8"?>
+<p:sldLayout xmlns:p="http://schemas.openxmlformats.org/presentationml/2006/main">
+  <p:cSld name="Section Header">
+    <p:spTree>
+      <p:nvGrpSpPr>
+        <p:cNvPr id="1" name=""/>
+        <p:cNvGrpSpPr/>
+        <p:nvPr/>
+      </p:nvGrpSpPr>
+      <p:grpSpPr>
+        <a:xfrm xmlns:a="http://schemas.openxmlformats.org/drawingml/2006/main"/>
+      </p:grpSpPr>
+      <p:sp>
+        <p:nvSpPr>
+          <p:cNvPr id="2" name="Section title">
+            <a:extLst xmlns:a="http://schemas.openxmlformats.org/drawingml/2006/main">
+              <a:ext uri="{FF2B5EF4-FFF2-40B4-BE49-F238E27FC236}">
+                <a16:creationId xmlns:a16="http://schemas.microsoft.com/office/drawing/2014/main" id="{C34FC462-6939-48E2-8704-E68F69E106DB}"/>
+              </a:ext>
+            </a:extLst>
+          </p:cNvPr>
+          <p:cNvSpPr>
+            <a:spLocks xmlns:a="http://schemas.openxmlformats.org/drawingml/2006/main" noGrp="1"/>
+          </p:cNvSpPr>
+          <p:nvPr>
+            <p:ph type="title" idx="0"/>
+          </p:nvPr>
+        </p:nvSpPr>
+        <p:spPr>
+          <a:xfrm xmlns:a="http://schemas.openxmlformats.org/drawingml/2006/main">
+            <a:off x="1219200" y="2857500"/>
+            <a:ext cx="9753600" cy="1143000"/>
+          </a:xfrm>
+          <a:prstGeom xmlns:a="http://schemas.openxmlformats.org/drawingml/2006/main" prst="rect">
+            <a:avLst/>
+          </a:prstGeom>
+          <a:noFill xmlns:a="http://schemas.openxmlformats.org/drawingml/2006/main"/>
+          <a:ln xmlns:a="http://schemas.openxmlformats.org/drawingml/2006/main">
+            <a:noFill/>
+            <a:prstDash val="solid"/>
+          </a:ln>
+        </p:spPr>
+        <p:txBody>
+          <a:bodyPr xmlns:a="http://schemas.openxmlformats.org/drawingml/2006/main" wrap="square" lIns="0" tIns="0" rIns="0" bIns="0" anchor="ctr">
+            <a:normAutofit/>
+          </a:bodyPr>
+          <a:lstStyle xmlns:a="http://schemas.openxmlformats.org/drawingml/2006/main">
+            <a:defPPr algn="ctr">
+              <a:defRPr sz="4200" b="1">
+                <a:solidFill>
+                  <a:schemeClr val="tx1"/>
+                </a:solidFill>
+                <a:latin typeface="+mj-lt"/>
+                <a:ea typeface="+mj-lt"/>
+                <a:cs typeface="+mj-lt"/>
+              </a:defRPr>
+            </a:defPPr>
+            <a:lvl1pPr marL="0" indent="0">
+              <a:lnSpc>
+                <a:spcPct val="110000"/>
+              </a:lnSpc>
+              <a:spcBef>
+                <a:spcPts val="0"/>
+              </a:spcBef>
+              <a:spcAft>
+                <a:spcPts val="0"/>
+              </a:spcAft>
+              <a:buNone/>
+            </a:lvl1pPr>
+            <a:lvl2pPr marL="0" indent="0">
+              <a:lnSpc>
+                <a:spcPct val="110000"/>
+              </a:lnSpc>
+              <a:spcBef>
+                <a:spcPts val="0"/>
+              </a:spcBef>
+              <a:spcAft>
+                <a:spcPts val="0"/>
+              </a:spcAft>
+              <a:buNone/>
+            </a:lvl2pPr>
+            <a:lvl3pPr marL="0" indent="0">
+              <a:lnSpc>
+                <a:spcPct val="110000"/>
+              </a:lnSpc>
+              <a:spcBef>
+                <a:spcPts val="0"/>
+              </a:spcBef>
+              <a:spcAft>
+                <a:spcPts val="0"/>
+              </a:spcAft>
+              <a:buNone/>
+            </a:lvl3pPr>
+            <a:lvl4pPr marL="0" indent="0">
+              <a:lnSpc>
+                <a:spcPct val="110000"/>
+              </a:lnSpc>
+              <a:spcBef>
+                <a:spcPts val="0"/>
+              </a:spcBef>
+              <a:spcAft>
+                <a:spcPts val="0"/>
+              </a:spcAft>
+              <a:buNone/>
+            </a:lvl4pPr>
+            <a:lvl5pPr marL="0" indent="0">
+              <a:lnSpc>
+                <a:spcPct val="110000"/>
+              </a:lnSpc>
+              <a:spcBef>
+                <a:spcPts val="0"/>
+              </a:spcBef>
+              <a:spcAft>
+                <a:spcPts val="0"/>
+              </a:spcAft>
+              <a:buNone/>
+            </a:lvl5pPr>
+            <a:lvl6pPr marL="0" indent="0">
+              <a:lnSpc>
+                <a:spcPct val="110000"/>
+              </a:lnSpc>
+              <a:spcBef>
+                <a:spcPts val="0"/>
+              </a:spcBef>
+              <a:spcAft>
+                <a:spcPts val="0"/>
+              </a:spcAft>
+              <a:buNone/>
+            </a:lvl6pPr>
+            <a:lvl7pPr marL="0" indent="0">
+              <a:lnSpc>
+                <a:spcPct val="110000"/>
+              </a:lnSpc>
+              <a:spcBef>
+                <a:spcPts val="0"/>
+              </a:spcBef>
+              <a:spcAft>
+                <a:spcPts val="0"/>
+              </a:spcAft>
+              <a:buNone/>
+            </a:lvl7pPr>
+            <a:lvl8pPr marL="0" indent="0">
+              <a:lnSpc>
+                <a:spcPct val="110000"/>
+              </a:lnSpc>
+              <a:spcBef>
+                <a:spcPts val="0"/>
+              </a:spcBef>
+              <a:spcAft>
+                <a:spcPts val="0"/>
+              </a:spcAft>
+              <a:buNone/>
+            </a:lvl8pPr>
+            <a:lvl9pPr marL="0" indent="0">
+              <a:lnSpc>
+                <a:spcPct val="110000"/>
+              </a:lnSpc>
+              <a:spcBef>
+                <a:spcPts val="0"/>
+              </a:spcBef>
+              <a:spcAft>
+                <a:spcPts val="0"/>
+              </a:spcAft>
+              <a:buNone/>
+            </a:lvl9pPr>
+          </a:lstStyle>
+          <a:p xmlns:a="http://schemas.openxmlformats.org/drawingml/2006/main"/>
+        </p:txBody>
+      </p:sp>
+    </p:spTree>
+  </p:cSld>
+</p:sldLayout>
+</file>
+
+<file path=ppt/slideLayouts/slideLayout3.xml><?xml version="1.0" encoding="utf-8"?>
+<p:sldLayout xmlns:p="http://schemas.openxmlformats.org/presentationml/2006/main">
+  <p:cSld name="Title and Body">
+    <p:spTree>
+      <p:nvGrpSpPr>
+        <p:cNvPr id="1" name=""/>
+        <p:cNvGrpSpPr/>
+        <p:nvPr/>
+      </p:nvGrpSpPr>
+      <p:grpSpPr>
+        <a:xfrm xmlns:a="http://schemas.openxmlformats.org/drawingml/2006/main"/>
+      </p:grpSpPr>
+      <p:sp>
+        <p:nvSpPr>
+          <p:cNvPr id="3" name="Title">
+            <a:extLst xmlns:a="http://schemas.openxmlformats.org/drawingml/2006/main">
+              <a:ext uri="{FF2B5EF4-FFF2-40B4-BE49-F238E27FC236}">
+                <a16:creationId xmlns:a16="http://schemas.microsoft.com/office/drawing/2014/main" id="{A10980FF-9A4B-48A4-ADCC-E8CF5C7434E3}"/>
+              </a:ext>
+            </a:extLst>
+          </p:cNvPr>
+          <p:cNvSpPr>
+            <a:spLocks xmlns:a="http://schemas.openxmlformats.org/drawingml/2006/main" noGrp="1"/>
+          </p:cNvSpPr>
+          <p:nvPr>
+            <p:ph type="title" idx="0"/>
+          </p:nvPr>
+        </p:nvSpPr>
+        <p:spPr>
+          <a:xfrm xmlns:a="http://schemas.openxmlformats.org/drawingml/2006/main">
+            <a:off x="685800" y="533400"/>
+            <a:ext cx="10820400" cy="838200"/>
+          </a:xfrm>
+          <a:prstGeom xmlns:a="http://schemas.openxmlformats.org/drawingml/2006/main" prst="rect">
+            <a:avLst/>
+          </a:prstGeom>
+          <a:noFill xmlns:a="http://schemas.openxmlformats.org/drawingml/2006/main"/>
+          <a:ln xmlns:a="http://schemas.openxmlformats.org/drawingml/2006/main">
+            <a:noFill/>
+            <a:prstDash val="solid"/>
+          </a:ln>
+        </p:spPr>
+        <p:txBody>
+          <a:bodyPr xmlns:a="http://schemas.openxmlformats.org/drawingml/2006/main" wrap="square" lIns="0" tIns="0" rIns="0" bIns="0" anchor="t">
+            <a:normAutofit/>
+          </a:bodyPr>
+          <a:lstStyle xmlns:a="http://schemas.openxmlformats.org/drawingml/2006/main">
+            <a:defPPr algn="l">
+              <a:defRPr sz="3300" b="1">
+                <a:solidFill>
+                  <a:schemeClr val="tx1"/>
+                </a:solidFill>
+                <a:latin typeface="+mj-lt"/>
+                <a:ea typeface="+mj-lt"/>
+                <a:cs typeface="+mj-lt"/>
+              </a:defRPr>
+            </a:defPPr>
+            <a:lvl1pPr marL="0" indent="0">
+              <a:lnSpc>
+                <a:spcPct val="110000"/>
+              </a:lnSpc>
+              <a:spcBef>
+                <a:spcPts val="0"/>
+              </a:spcBef>
+              <a:spcAft>
+                <a:spcPts val="0"/>
+              </a:spcAft>
+              <a:buNone/>
+            </a:lvl1pPr>
+            <a:lvl2pPr marL="0" indent="0">
+              <a:lnSpc>
+                <a:spcPct val="110000"/>
+              </a:lnSpc>
+              <a:spcBef>
+                <a:spcPts val="0"/>
+              </a:spcBef>
+              <a:spcAft>
+                <a:spcPts val="0"/>
+              </a:spcAft>
+              <a:buNone/>
+            </a:lvl2pPr>
+            <a:lvl3pPr marL="0" indent="0">
+              <a:lnSpc>
+                <a:spcPct val="110000"/>
+              </a:lnSpc>
+              <a:spcBef>
+                <a:spcPts val="0"/>
+              </a:spcBef>
+              <a:spcAft>
+                <a:spcPts val="0"/>
+              </a:spcAft>
+              <a:buNone/>
+            </a:lvl3pPr>
+            <a:lvl4pPr marL="0" indent="0">
+              <a:lnSpc>
+                <a:spcPct val="110000"/>
+              </a:lnSpc>
+              <a:spcBef>
+                <a:spcPts val="0"/>
+              </a:spcBef>
+              <a:spcAft>
+                <a:spcPts val="0"/>
+              </a:spcAft>
+              <a:buNone/>
+            </a:lvl4pPr>
+            <a:lvl5pPr marL="0" indent="0">
+              <a:lnSpc>
+                <a:spcPct val="110000"/>
+              </a:lnSpc>
+              <a:spcBef>
+                <a:spcPts val="0"/>
+              </a:spcBef>
+              <a:spcAft>
+                <a:spcPts val="0"/>
+              </a:spcAft>
+              <a:buNone/>
+            </a:lvl5pPr>
+            <a:lvl6pPr marL="0" indent="0">
+              <a:lnSpc>
+                <a:spcPct val="110000"/>
+              </a:lnSpc>
+              <a:spcBef>
+                <a:spcPts val="0"/>
+              </a:spcBef>
+              <a:spcAft>
+                <a:spcPts val="0"/>
+              </a:spcAft>
+              <a:buNone/>
+            </a:lvl6pPr>
+            <a:lvl7pPr marL="0" indent="0">
+              <a:lnSpc>
+                <a:spcPct val="110000"/>
+              </a:lnSpc>
+              <a:spcBef>
+                <a:spcPts val="0"/>
+              </a:spcBef>
+              <a:spcAft>
+                <a:spcPts val="0"/>
+              </a:spcAft>
+              <a:buNone/>
+            </a:lvl7pPr>
+            <a:lvl8pPr marL="0" indent="0">
+              <a:lnSpc>
+                <a:spcPct val="110000"/>
+              </a:lnSpc>
+              <a:spcBef>
+                <a:spcPts val="0"/>
+              </a:spcBef>
+              <a:spcAft>
+                <a:spcPts val="0"/>
+              </a:spcAft>
+              <a:buNone/>
+            </a:lvl8pPr>
+            <a:lvl9pPr marL="0" indent="0">
+              <a:lnSpc>
+                <a:spcPct val="110000"/>
+              </a:lnSpc>
+              <a:spcBef>
+                <a:spcPts val="0"/>
+              </a:spcBef>
+              <a:spcAft>
+                <a:spcPts val="0"/>
+              </a:spcAft>
+              <a:buNone/>
+            </a:lvl9pPr>
+          </a:lstStyle>
+          <a:p xmlns:a="http://schemas.openxmlformats.org/drawingml/2006/main"/>
+        </p:txBody>
+      </p:sp>
+      <p:sp>
+        <p:nvSpPr>
+          <p:cNvPr id="2" name="Body">
+            <a:extLst xmlns:a="http://schemas.openxmlformats.org/drawingml/2006/main">
+              <a:ext uri="{FF2B5EF4-FFF2-40B4-BE49-F238E27FC236}">
+                <a16:creationId xmlns:a16="http://schemas.microsoft.com/office/drawing/2014/main" id="{F2478FB1-2A19-459E-BEC6-072246C26D80}"/>
+              </a:ext>
+            </a:extLst>
+          </p:cNvPr>
+          <p:cNvSpPr>
+            <a:spLocks xmlns:a="http://schemas.openxmlformats.org/drawingml/2006/main" noGrp="1"/>
+          </p:cNvSpPr>
+          <p:nvPr>
+            <p:ph type="body" idx="1"/>
+          </p:nvPr>
+        </p:nvSpPr>
+        <p:spPr>
+          <a:xfrm xmlns:a="http://schemas.openxmlformats.org/drawingml/2006/main">
+            <a:off x="685800" y="1905000"/>
+            <a:ext cx="10820400" cy="4267200"/>
+          </a:xfrm>
+          <a:prstGeom xmlns:a="http://schemas.openxmlformats.org/drawingml/2006/main" prst="rect">
+            <a:avLst/>
+          </a:prstGeom>
+          <a:noFill xmlns:a="http://schemas.openxmlformats.org/drawingml/2006/main"/>
+          <a:ln xmlns:a="http://schemas.openxmlformats.org/drawingml/2006/main">
+            <a:noFill/>
+            <a:prstDash val="solid"/>
+          </a:ln>
+        </p:spPr>
+        <p:txBody>
+          <a:bodyPr xmlns:a="http://schemas.openxmlformats.org/drawingml/2006/main" wrap="square" lIns="0" tIns="0" rIns="0" bIns="0" anchor="t">
+            <a:normAutofit/>
+          </a:bodyPr>
+          <a:lstStyle xmlns:a="http://schemas.openxmlformats.org/drawingml/2006/main">
+            <a:defPPr algn="l">
+              <a:defRPr sz="2250" b="0">
+                <a:solidFill>
+                  <a:schemeClr val="tx1"/>
+                </a:solidFill>
+                <a:latin typeface="+mn-lt"/>
+                <a:ea typeface="+mn-lt"/>
+                <a:cs typeface="+mn-lt"/>
+              </a:defRPr>
+            </a:defPPr>
+            <a:lvl1pPr marL="228600" indent="-228600">
+              <a:lnSpc>
+                <a:spcPct val="110000"/>
+              </a:lnSpc>
+              <a:spcBef>
+                <a:spcPts val="0"/>
+              </a:spcBef>
+              <a:spcAft>
+                <a:spcPts val="1200"/>
+              </a:spcAft>
+              <a:buChar char="•"/>
+            </a:lvl1pPr>
+            <a:lvl2pPr marL="533400" indent="-228600">
+              <a:lnSpc>
+                <a:spcPct val="110000"/>
+              </a:lnSpc>
+              <a:spcBef>
+                <a:spcPts val="0"/>
+              </a:spcBef>
+              <a:spcAft>
+                <a:spcPts val="1200"/>
+              </a:spcAft>
+              <a:buChar char="•"/>
+            </a:lvl2pPr>
+            <a:lvl3pPr marL="838200" indent="-228600">
+              <a:lnSpc>
+                <a:spcPct val="110000"/>
+              </a:lnSpc>
+              <a:spcBef>
+                <a:spcPts val="0"/>
+              </a:spcBef>
+              <a:spcAft>
+                <a:spcPts val="1200"/>
+              </a:spcAft>
+              <a:buChar char="•"/>
+            </a:lvl3pPr>
+            <a:lvl4pPr marL="1143000" indent="-228600">
+              <a:lnSpc>
+                <a:spcPct val="110000"/>
+              </a:lnSpc>
+              <a:spcBef>
+                <a:spcPts val="0"/>
+              </a:spcBef>
+              <a:spcAft>
+                <a:spcPts val="1200"/>
+              </a:spcAft>
+              <a:buChar char="•"/>
+            </a:lvl4pPr>
+            <a:lvl5pPr marL="1447800" indent="-228600">
+              <a:lnSpc>
+                <a:spcPct val="110000"/>
+              </a:lnSpc>
+              <a:spcBef>
+                <a:spcPts val="0"/>
+              </a:spcBef>
+              <a:spcAft>
+                <a:spcPts val="1200"/>
+              </a:spcAft>
+              <a:buChar char="•"/>
+            </a:lvl5pPr>
+            <a:lvl6pPr marL="1752600" indent="-228600">
+              <a:lnSpc>
+                <a:spcPct val="110000"/>
+              </a:lnSpc>
+              <a:spcBef>
+                <a:spcPts val="0"/>
+              </a:spcBef>
+              <a:spcAft>
+                <a:spcPts val="1200"/>
+              </a:spcAft>
+              <a:buChar char="•"/>
+            </a:lvl6pPr>
+            <a:lvl7pPr marL="2057400" indent="-228600">
+              <a:lnSpc>
+                <a:spcPct val="110000"/>
+              </a:lnSpc>
+              <a:spcBef>
+                <a:spcPts val="0"/>
+              </a:spcBef>
+              <a:spcAft>
+                <a:spcPts val="1200"/>
+              </a:spcAft>
+              <a:buChar char="•"/>
+            </a:lvl7pPr>
+            <a:lvl8pPr marL="2362200" indent="-228600">
+              <a:lnSpc>
+                <a:spcPct val="110000"/>
+              </a:lnSpc>
+              <a:spcBef>
+                <a:spcPts val="0"/>
+              </a:spcBef>
+              <a:spcAft>
+                <a:spcPts val="1200"/>
+              </a:spcAft>
+              <a:buChar char="•"/>
+            </a:lvl8pPr>
+            <a:lvl9pPr marL="2667000" indent="-228600">
+              <a:lnSpc>
+                <a:spcPct val="110000"/>
+              </a:lnSpc>
+              <a:spcBef>
+                <a:spcPts val="0"/>
+              </a:spcBef>
+              <a:spcAft>
+                <a:spcPts val="1200"/>
+              </a:spcAft>
+              <a:buChar char="•"/>
+            </a:lvl9pPr>
+          </a:lstStyle>
+          <a:p xmlns:a="http://schemas.openxmlformats.org/drawingml/2006/main"/>
+        </p:txBody>
+      </p:sp>
+    </p:spTree>
+  </p:cSld>
+</p:sldLayout>
+</file>
+
+<file path=ppt/slideLayouts/slideLayout4.xml><?xml version="1.0" encoding="utf-8"?>
+<p:sldLayout xmlns:p="http://schemas.openxmlformats.org/presentationml/2006/main">
+  <p:cSld name="Title and Two Column">
+    <p:spTree>
+      <p:nvGrpSpPr>
+        <p:cNvPr id="1" name=""/>
+        <p:cNvGrpSpPr/>
+        <p:nvPr/>
+      </p:nvGrpSpPr>
+      <p:grpSpPr>
+        <a:xfrm xmlns:a="http://schemas.openxmlformats.org/drawingml/2006/main"/>
+      </p:grpSpPr>
+      <p:sp>
+        <p:nvSpPr>
+          <p:cNvPr id="4" name="Title">
+            <a:extLst xmlns:a="http://schemas.openxmlformats.org/drawingml/2006/main">
+              <a:ext uri="{FF2B5EF4-FFF2-40B4-BE49-F238E27FC236}">
+                <a16:creationId xmlns:a16="http://schemas.microsoft.com/office/drawing/2014/main" id="{FA637E44-D082-4B56-8CA6-4B1ED85BD057}"/>
+              </a:ext>
+            </a:extLst>
+          </p:cNvPr>
+          <p:cNvSpPr>
+            <a:spLocks xmlns:a="http://schemas.openxmlformats.org/drawingml/2006/main" noGrp="1"/>
+          </p:cNvSpPr>
+          <p:nvPr>
+            <p:ph type="title" idx="0"/>
+          </p:nvPr>
+        </p:nvSpPr>
+        <p:spPr>
+          <a:xfrm xmlns:a="http://schemas.openxmlformats.org/drawingml/2006/main">
+            <a:off x="685800" y="533400"/>
+            <a:ext cx="10820400" cy="838200"/>
+          </a:xfrm>
+          <a:prstGeom xmlns:a="http://schemas.openxmlformats.org/drawingml/2006/main" prst="rect">
+            <a:avLst/>
+          </a:prstGeom>
+          <a:noFill xmlns:a="http://schemas.openxmlformats.org/drawingml/2006/main"/>
+          <a:ln xmlns:a="http://schemas.openxmlformats.org/drawingml/2006/main">
+            <a:noFill/>
+            <a:prstDash val="solid"/>
+          </a:ln>
+        </p:spPr>
+        <p:txBody>
+          <a:bodyPr xmlns:a="http://schemas.openxmlformats.org/drawingml/2006/main" wrap="square" lIns="0" tIns="0" rIns="0" bIns="0" anchor="t">
+            <a:normAutofit/>
+          </a:bodyPr>
+          <a:lstStyle xmlns:a="http://schemas.openxmlformats.org/drawingml/2006/main">
+            <a:defPPr algn="l">
+              <a:defRPr sz="3300" b="1">
+                <a:solidFill>
+                  <a:schemeClr val="tx1"/>
+                </a:solidFill>
+                <a:latin typeface="+mj-lt"/>
+                <a:ea typeface="+mj-lt"/>
+                <a:cs typeface="+mj-lt"/>
+              </a:defRPr>
+            </a:defPPr>
+            <a:lvl1pPr marL="0" indent="0">
+              <a:lnSpc>
+                <a:spcPct val="110000"/>
+              </a:lnSpc>
+              <a:spcBef>
+                <a:spcPts val="0"/>
+              </a:spcBef>
+              <a:spcAft>
+                <a:spcPts val="0"/>
+              </a:spcAft>
+              <a:buNone/>
+            </a:lvl1pPr>
+            <a:lvl2pPr marL="0" indent="0">
+              <a:lnSpc>
+                <a:spcPct val="110000"/>
+              </a:lnSpc>
+              <a:spcBef>
+                <a:spcPts val="0"/>
+              </a:spcBef>
+              <a:spcAft>
+                <a:spcPts val="0"/>
+              </a:spcAft>
+              <a:buNone/>
+            </a:lvl2pPr>
+            <a:lvl3pPr marL="0" indent="0">
+              <a:lnSpc>
+                <a:spcPct val="110000"/>
+              </a:lnSpc>
+              <a:spcBef>
+                <a:spcPts val="0"/>
+              </a:spcBef>
+              <a:spcAft>
+                <a:spcPts val="0"/>
+              </a:spcAft>
+              <a:buNone/>
+            </a:lvl3pPr>
+            <a:lvl4pPr marL="0" indent="0">
+              <a:lnSpc>
+                <a:spcPct val="110000"/>
+              </a:lnSpc>
+              <a:spcBef>
+                <a:spcPts val="0"/>
+              </a:spcBef>
+              <a:spcAft>
+                <a:spcPts val="0"/>
+              </a:spcAft>
+              <a:buNone/>
+            </a:lvl4pPr>
+            <a:lvl5pPr marL="0" indent="0">
+              <a:lnSpc>
+                <a:spcPct val="110000"/>
+              </a:lnSpc>
+              <a:spcBef>
+                <a:spcPts val="0"/>
+              </a:spcBef>
+              <a:spcAft>
+                <a:spcPts val="0"/>
+              </a:spcAft>
+              <a:buNone/>
+            </a:lvl5pPr>
+            <a:lvl6pPr marL="0" indent="0">
+              <a:lnSpc>
+                <a:spcPct val="110000"/>
+              </a:lnSpc>
+              <a:spcBef>
+                <a:spcPts val="0"/>
+              </a:spcBef>
+              <a:spcAft>
+                <a:spcPts val="0"/>
+              </a:spcAft>
+              <a:buNone/>
+            </a:lvl6pPr>
+            <a:lvl7pPr marL="0" indent="0">
+              <a:lnSpc>
+                <a:spcPct val="110000"/>
+              </a:lnSpc>
+              <a:spcBef>
+                <a:spcPts val="0"/>
+              </a:spcBef>
+              <a:spcAft>
+                <a:spcPts val="0"/>
+              </a:spcAft>
+              <a:buNone/>
+            </a:lvl7pPr>
+            <a:lvl8pPr marL="0" indent="0">
+              <a:lnSpc>
+                <a:spcPct val="110000"/>
+              </a:lnSpc>
+              <a:spcBef>
+                <a:spcPts val="0"/>
+              </a:spcBef>
+              <a:spcAft>
+                <a:spcPts val="0"/>
+              </a:spcAft>
+              <a:buNone/>
+            </a:lvl8pPr>
+            <a:lvl9pPr marL="0" indent="0">
+              <a:lnSpc>
+                <a:spcPct val="110000"/>
+              </a:lnSpc>
+              <a:spcBef>
+                <a:spcPts val="0"/>
+              </a:spcBef>
+              <a:spcAft>
+                <a:spcPts val="0"/>
+              </a:spcAft>
+              <a:buNone/>
+            </a:lvl9pPr>
+          </a:lstStyle>
+          <a:p xmlns:a="http://schemas.openxmlformats.org/drawingml/2006/main"/>
+        </p:txBody>
+      </p:sp>
+      <p:sp>
+        <p:nvSpPr>
+          <p:cNvPr id="2" name="Left column">
+            <a:extLst xmlns:a="http://schemas.openxmlformats.org/drawingml/2006/main">
+              <a:ext uri="{FF2B5EF4-FFF2-40B4-BE49-F238E27FC236}">
+                <a16:creationId xmlns:a16="http://schemas.microsoft.com/office/drawing/2014/main" id="{EFB928CB-075B-4636-880B-DF329461FBCE}"/>
+              </a:ext>
+            </a:extLst>
+          </p:cNvPr>
+          <p:cNvSpPr>
+            <a:spLocks xmlns:a="http://schemas.openxmlformats.org/drawingml/2006/main" noGrp="1"/>
+          </p:cNvSpPr>
+          <p:nvPr>
+            <p:ph type="body" idx="1"/>
+          </p:nvPr>
+        </p:nvSpPr>
+        <p:spPr>
+          <a:xfrm xmlns:a="http://schemas.openxmlformats.org/drawingml/2006/main">
+            <a:off x="685800" y="1905000"/>
+            <a:ext cx="5029200" cy="4267200"/>
+          </a:xfrm>
+          <a:prstGeom xmlns:a="http://schemas.openxmlformats.org/drawingml/2006/main" prst="rect">
+            <a:avLst/>
+          </a:prstGeom>
+          <a:noFill xmlns:a="http://schemas.openxmlformats.org/drawingml/2006/main"/>
+          <a:ln xmlns:a="http://schemas.openxmlformats.org/drawingml/2006/main">
+            <a:noFill/>
+            <a:prstDash val="solid"/>
+          </a:ln>
+        </p:spPr>
+        <p:txBody>
+          <a:bodyPr xmlns:a="http://schemas.openxmlformats.org/drawingml/2006/main" wrap="square" lIns="0" tIns="0" rIns="0" bIns="0" anchor="t">
+            <a:normAutofit/>
+          </a:bodyPr>
+          <a:lstStyle xmlns:a="http://schemas.openxmlformats.org/drawingml/2006/main">
+            <a:defPPr algn="l">
+              <a:defRPr sz="2100" b="0">
+                <a:solidFill>
+                  <a:schemeClr val="tx1"/>
+                </a:solidFill>
+                <a:latin typeface="+mn-lt"/>
+                <a:ea typeface="+mn-lt"/>
+                <a:cs typeface="+mn-lt"/>
+              </a:defRPr>
+            </a:defPPr>
+            <a:lvl1pPr marL="228600" indent="-228600">
+              <a:lnSpc>
+                <a:spcPct val="110000"/>
+              </a:lnSpc>
+              <a:spcBef>
+                <a:spcPts val="0"/>
+              </a:spcBef>
+              <a:spcAft>
+                <a:spcPts val="1200"/>
+              </a:spcAft>
+              <a:buChar char="•"/>
+            </a:lvl1pPr>
+            <a:lvl2pPr marL="533400" indent="-228600">
+              <a:lnSpc>
+                <a:spcPct val="110000"/>
+              </a:lnSpc>
+              <a:spcBef>
+                <a:spcPts val="0"/>
+              </a:spcBef>
+              <a:spcAft>
+                <a:spcPts val="1200"/>
+              </a:spcAft>
+              <a:buChar char="•"/>
+            </a:lvl2pPr>
+            <a:lvl3pPr marL="838200" indent="-228600">
+              <a:lnSpc>
+                <a:spcPct val="110000"/>
+              </a:lnSpc>
+              <a:spcBef>
+                <a:spcPts val="0"/>
+              </a:spcBef>
+              <a:spcAft>
+                <a:spcPts val="1200"/>
+              </a:spcAft>
+              <a:buChar char="•"/>
+            </a:lvl3pPr>
+            <a:lvl4pPr marL="1143000" indent="-228600">
+              <a:lnSpc>
+                <a:spcPct val="110000"/>
+              </a:lnSpc>
+              <a:spcBef>
+                <a:spcPts val="0"/>
+              </a:spcBef>
+              <a:spcAft>
+                <a:spcPts val="1200"/>
+              </a:spcAft>
+              <a:buChar char="•"/>
+            </a:lvl4pPr>
+            <a:lvl5pPr marL="1447800" indent="-228600">
+              <a:lnSpc>
+                <a:spcPct val="110000"/>
+              </a:lnSpc>
+              <a:spcBef>
+                <a:spcPts val="0"/>
+              </a:spcBef>
+              <a:spcAft>
+                <a:spcPts val="1200"/>
+              </a:spcAft>
+              <a:buChar char="•"/>
+            </a:lvl5pPr>
+            <a:lvl6pPr marL="1752600" indent="-228600">
+              <a:lnSpc>
+                <a:spcPct val="110000"/>
+              </a:lnSpc>
+              <a:spcBef>
+                <a:spcPts val="0"/>
+              </a:spcBef>
+              <a:spcAft>
+                <a:spcPts val="1200"/>
+              </a:spcAft>
+              <a:buChar char="•"/>
+            </a:lvl6pPr>
+            <a:lvl7pPr marL="2057400" indent="-228600">
+              <a:lnSpc>
+                <a:spcPct val="110000"/>
+              </a:lnSpc>
+              <a:spcBef>
+                <a:spcPts val="0"/>
+              </a:spcBef>
+              <a:spcAft>
+                <a:spcPts val="1200"/>
+              </a:spcAft>
+              <a:buChar char="•"/>
+            </a:lvl7pPr>
+            <a:lvl8pPr marL="2362200" indent="-228600">
+              <a:lnSpc>
+                <a:spcPct val="110000"/>
+              </a:lnSpc>
+              <a:spcBef>
+                <a:spcPts val="0"/>
+              </a:spcBef>
+              <a:spcAft>
+                <a:spcPts val="1200"/>
+              </a:spcAft>
+              <a:buChar char="•"/>
+            </a:lvl8pPr>
+            <a:lvl9pPr marL="2667000" indent="-228600">
+              <a:lnSpc>
+                <a:spcPct val="110000"/>
+              </a:lnSpc>
+              <a:spcBef>
+                <a:spcPts val="0"/>
+              </a:spcBef>
+              <a:spcAft>
+                <a:spcPts val="1200"/>
+              </a:spcAft>
+              <a:buChar char="•"/>
+            </a:lvl9pPr>
+          </a:lstStyle>
+          <a:p xmlns:a="http://schemas.openxmlformats.org/drawingml/2006/main"/>
+        </p:txBody>
+      </p:sp>
+      <p:sp>
+        <p:nvSpPr>
+          <p:cNvPr id="3" name="Right column">
+            <a:extLst xmlns:a="http://schemas.openxmlformats.org/drawingml/2006/main">
+              <a:ext uri="{FF2B5EF4-FFF2-40B4-BE49-F238E27FC236}">
+                <a16:creationId xmlns:a16="http://schemas.microsoft.com/office/drawing/2014/main" id="{E3D66F2C-D25C-4B2F-B6C5-FEAC4C2B3EDA}"/>
+              </a:ext>
+            </a:extLst>
+          </p:cNvPr>
+          <p:cNvSpPr>
+            <a:spLocks xmlns:a="http://schemas.openxmlformats.org/drawingml/2006/main" noGrp="1"/>
+          </p:cNvSpPr>
+          <p:nvPr>
+            <p:ph type="body" idx="2"/>
+          </p:nvPr>
+        </p:nvSpPr>
+        <p:spPr>
+          <a:xfrm xmlns:a="http://schemas.openxmlformats.org/drawingml/2006/main">
+            <a:off x="6477000" y="1905000"/>
+            <a:ext cx="5029200" cy="4267200"/>
+          </a:xfrm>
+          <a:prstGeom xmlns:a="http://schemas.openxmlformats.org/drawingml/2006/main" prst="rect">
+            <a:avLst/>
+          </a:prstGeom>
+          <a:noFill xmlns:a="http://schemas.openxmlformats.org/drawingml/2006/main"/>
+          <a:ln xmlns:a="http://schemas.openxmlformats.org/drawingml/2006/main">
+            <a:noFill/>
+            <a:prstDash val="solid"/>
+          </a:ln>
+        </p:spPr>
+        <p:txBody>
+          <a:bodyPr xmlns:a="http://schemas.openxmlformats.org/drawingml/2006/main" wrap="square" lIns="0" tIns="0" rIns="0" bIns="0" anchor="t">
+            <a:normAutofit/>
+          </a:bodyPr>
+          <a:lstStyle xmlns:a="http://schemas.openxmlformats.org/drawingml/2006/main">
+            <a:defPPr algn="l">
+              <a:defRPr sz="2100" b="0">
+                <a:solidFill>
+                  <a:schemeClr val="tx1"/>
+                </a:solidFill>
+                <a:latin typeface="+mn-lt"/>
+                <a:ea typeface="+mn-lt"/>
+                <a:cs typeface="+mn-lt"/>
+              </a:defRPr>
+            </a:defPPr>
+            <a:lvl1pPr marL="228600" indent="-228600">
+              <a:lnSpc>
+                <a:spcPct val="110000"/>
+              </a:lnSpc>
+              <a:spcBef>
+                <a:spcPts val="0"/>
+              </a:spcBef>
+              <a:spcAft>
+                <a:spcPts val="1200"/>
+              </a:spcAft>
+              <a:buChar char="•"/>
+            </a:lvl1pPr>
+            <a:lvl2pPr marL="533400" indent="-228600">
+              <a:lnSpc>
+                <a:spcPct val="110000"/>
+              </a:lnSpc>
+              <a:spcBef>
+                <a:spcPts val="0"/>
+              </a:spcBef>
+              <a:spcAft>
+                <a:spcPts val="1200"/>
+              </a:spcAft>
+              <a:buChar char="•"/>
+            </a:lvl2pPr>
+            <a:lvl3pPr marL="838200" indent="-228600">
+              <a:lnSpc>
+                <a:spcPct val="110000"/>
+              </a:lnSpc>
+              <a:spcBef>
+                <a:spcPts val="0"/>
+              </a:spcBef>
+              <a:spcAft>
+                <a:spcPts val="1200"/>
+              </a:spcAft>
+              <a:buChar char="•"/>
+            </a:lvl3pPr>
+            <a:lvl4pPr marL="1143000" indent="-228600">
+              <a:lnSpc>
+                <a:spcPct val="110000"/>
+              </a:lnSpc>
+              <a:spcBef>
+                <a:spcPts val="0"/>
+              </a:spcBef>
+              <a:spcAft>
+                <a:spcPts val="1200"/>
+              </a:spcAft>
+              <a:buChar char="•"/>
+            </a:lvl4pPr>
+            <a:lvl5pPr marL="1447800" indent="-228600">
+              <a:lnSpc>
+                <a:spcPct val="110000"/>
+              </a:lnSpc>
+              <a:spcBef>
+                <a:spcPts val="0"/>
+              </a:spcBef>
+              <a:spcAft>
+                <a:spcPts val="1200"/>
+              </a:spcAft>
+              <a:buChar char="•"/>
+            </a:lvl5pPr>
+            <a:lvl6pPr marL="1752600" indent="-228600">
+              <a:lnSpc>
+                <a:spcPct val="110000"/>
+              </a:lnSpc>
+              <a:spcBef>
+                <a:spcPts val="0"/>
+              </a:spcBef>
+              <a:spcAft>
+                <a:spcPts val="1200"/>
+              </a:spcAft>
+              <a:buChar char="•"/>
+            </a:lvl6pPr>
+            <a:lvl7pPr marL="2057400" indent="-228600">
+              <a:lnSpc>
+                <a:spcPct val="110000"/>
+              </a:lnSpc>
+              <a:spcBef>
+                <a:spcPts val="0"/>
+              </a:spcBef>
+              <a:spcAft>
+                <a:spcPts val="1200"/>
+              </a:spcAft>
+              <a:buChar char="•"/>
+            </a:lvl7pPr>
+            <a:lvl8pPr marL="2362200" indent="-228600">
+              <a:lnSpc>
+                <a:spcPct val="110000"/>
+              </a:lnSpc>
+              <a:spcBef>
+                <a:spcPts val="0"/>
+              </a:spcBef>
+              <a:spcAft>
+                <a:spcPts val="1200"/>
+              </a:spcAft>
+              <a:buChar char="•"/>
+            </a:lvl8pPr>
+            <a:lvl9pPr marL="2667000" indent="-228600">
+              <a:lnSpc>
+                <a:spcPct val="110000"/>
+              </a:lnSpc>
+              <a:spcBef>
+                <a:spcPts val="0"/>
+              </a:spcBef>
+              <a:spcAft>
+                <a:spcPts val="1200"/>
+              </a:spcAft>
+              <a:buChar char="•"/>
+            </a:lvl9pPr>
+          </a:lstStyle>
+          <a:p xmlns:a="http://schemas.openxmlformats.org/drawingml/2006/main"/>
+        </p:txBody>
+      </p:sp>
+    </p:spTree>
+  </p:cSld>
+</p:sldLayout>
+</file>
+
+<file path=ppt/slideLayouts/slideLayout5.xml><?xml version="1.0" encoding="utf-8"?>
+<p:sldLayout xmlns:p="http://schemas.openxmlformats.org/presentationml/2006/main">
+  <p:cSld name="Title and One Column">
+    <p:spTree>
+      <p:nvGrpSpPr>
+        <p:cNvPr id="1" name=""/>
+        <p:cNvGrpSpPr/>
+        <p:nvPr/>
+      </p:nvGrpSpPr>
+      <p:grpSpPr>
+        <a:xfrm xmlns:a="http://schemas.openxmlformats.org/drawingml/2006/main"/>
+      </p:grpSpPr>
+      <p:sp>
+        <p:nvSpPr>
+          <p:cNvPr id="3" name="Title">
+            <a:extLst xmlns:a="http://schemas.openxmlformats.org/drawingml/2006/main">
+              <a:ext uri="{FF2B5EF4-FFF2-40B4-BE49-F238E27FC236}">
+                <a16:creationId xmlns:a16="http://schemas.microsoft.com/office/drawing/2014/main" id="{2419F293-3BD3-4357-ACC4-17CF74F5FAD5}"/>
+              </a:ext>
+            </a:extLst>
+          </p:cNvPr>
+          <p:cNvSpPr>
+            <a:spLocks xmlns:a="http://schemas.openxmlformats.org/drawingml/2006/main" noGrp="1"/>
+          </p:cNvSpPr>
+          <p:nvPr>
+            <p:ph type="title" idx="0"/>
+          </p:nvPr>
+        </p:nvSpPr>
+        <p:spPr>
+          <a:xfrm xmlns:a="http://schemas.openxmlformats.org/drawingml/2006/main">
+            <a:off x="685800" y="533400"/>
+            <a:ext cx="10820400" cy="838200"/>
+          </a:xfrm>
+          <a:prstGeom xmlns:a="http://schemas.openxmlformats.org/drawingml/2006/main" prst="rect">
+            <a:avLst/>
+          </a:prstGeom>
+          <a:noFill xmlns:a="http://schemas.openxmlformats.org/drawingml/2006/main"/>
+          <a:ln xmlns:a="http://schemas.openxmlformats.org/drawingml/2006/main">
+            <a:noFill/>
+            <a:prstDash val="solid"/>
+          </a:ln>
+        </p:spPr>
+        <p:txBody>
+          <a:bodyPr xmlns:a="http://schemas.openxmlformats.org/drawingml/2006/main" wrap="square" lIns="0" tIns="0" rIns="0" bIns="0" anchor="t">
+            <a:normAutofit/>
+          </a:bodyPr>
+          <a:lstStyle xmlns:a="http://schemas.openxmlformats.org/drawingml/2006/main">
+            <a:defPPr algn="l">
+              <a:defRPr sz="3300" b="1">
+                <a:solidFill>
+                  <a:schemeClr val="tx1"/>
+                </a:solidFill>
+                <a:latin typeface="+mj-lt"/>
+                <a:ea typeface="+mj-lt"/>
+                <a:cs typeface="+mj-lt"/>
+              </a:defRPr>
+            </a:defPPr>
+            <a:lvl1pPr marL="0" indent="0">
+              <a:lnSpc>
+                <a:spcPct val="110000"/>
+              </a:lnSpc>
+              <a:spcBef>
+                <a:spcPts val="0"/>
+              </a:spcBef>
+              <a:spcAft>
+                <a:spcPts val="0"/>
+              </a:spcAft>
+              <a:buNone/>
+            </a:lvl1pPr>
+            <a:lvl2pPr marL="0" indent="0">
+              <a:lnSpc>
+                <a:spcPct val="110000"/>
+              </a:lnSpc>
+              <a:spcBef>
+                <a:spcPts val="0"/>
+              </a:spcBef>
+              <a:spcAft>
+                <a:spcPts val="0"/>
+              </a:spcAft>
+              <a:buNone/>
+            </a:lvl2pPr>
+            <a:lvl3pPr marL="0" indent="0">
+              <a:lnSpc>
+                <a:spcPct val="110000"/>
+              </a:lnSpc>
+              <a:spcBef>
+                <a:spcPts val="0"/>
+              </a:spcBef>
+              <a:spcAft>
+                <a:spcPts val="0"/>
+              </a:spcAft>
+              <a:buNone/>
+            </a:lvl3pPr>
+            <a:lvl4pPr marL="0" indent="0">
+              <a:lnSpc>
+                <a:spcPct val="110000"/>
+              </a:lnSpc>
+              <a:spcBef>
+                <a:spcPts val="0"/>
+              </a:spcBef>
+              <a:spcAft>
+                <a:spcPts val="0"/>
+              </a:spcAft>
+              <a:buNone/>
+            </a:lvl4pPr>
+            <a:lvl5pPr marL="0" indent="0">
+              <a:lnSpc>
+                <a:spcPct val="110000"/>
+              </a:lnSpc>
+              <a:spcBef>
+                <a:spcPts val="0"/>
+              </a:spcBef>
+              <a:spcAft>
+                <a:spcPts val="0"/>
+              </a:spcAft>
+              <a:buNone/>
+            </a:lvl5pPr>
+            <a:lvl6pPr marL="0" indent="0">
+              <a:lnSpc>
+                <a:spcPct val="110000"/>
+              </a:lnSpc>
+              <a:spcBef>
+                <a:spcPts val="0"/>
+              </a:spcBef>
+              <a:spcAft>
+                <a:spcPts val="0"/>
+              </a:spcAft>
+              <a:buNone/>
+            </a:lvl6pPr>
+            <a:lvl7pPr marL="0" indent="0">
+              <a:lnSpc>
+                <a:spcPct val="110000"/>
+              </a:lnSpc>
+              <a:spcBef>
+                <a:spcPts val="0"/>
+              </a:spcBef>
+              <a:spcAft>
+                <a:spcPts val="0"/>
+              </a:spcAft>
+              <a:buNone/>
+            </a:lvl7pPr>
+            <a:lvl8pPr marL="0" indent="0">
+              <a:lnSpc>
+                <a:spcPct val="110000"/>
+              </a:lnSpc>
+              <a:spcBef>
+                <a:spcPts val="0"/>
+              </a:spcBef>
+              <a:spcAft>
+                <a:spcPts val="0"/>
+              </a:spcAft>
+              <a:buNone/>
+            </a:lvl8pPr>
+            <a:lvl9pPr marL="0" indent="0">
+              <a:lnSpc>
+                <a:spcPct val="110000"/>
+              </a:lnSpc>
+              <a:spcBef>
+                <a:spcPts val="0"/>
+              </a:spcBef>
+              <a:spcAft>
+                <a:spcPts val="0"/>
+              </a:spcAft>
+              <a:buNone/>
+            </a:lvl9pPr>
+          </a:lstStyle>
+          <a:p xmlns:a="http://schemas.openxmlformats.org/drawingml/2006/main"/>
+        </p:txBody>
+      </p:sp>
+      <p:sp>
+        <p:nvSpPr>
+          <p:cNvPr id="2" name="Left column">
+            <a:extLst xmlns:a="http://schemas.openxmlformats.org/drawingml/2006/main">
+              <a:ext uri="{FF2B5EF4-FFF2-40B4-BE49-F238E27FC236}">
+                <a16:creationId xmlns:a16="http://schemas.microsoft.com/office/drawing/2014/main" id="{BE4AF29F-0D64-43C4-AE6B-FE1725A9C5AA}"/>
+              </a:ext>
+            </a:extLst>
+          </p:cNvPr>
+          <p:cNvSpPr>
+            <a:spLocks xmlns:a="http://schemas.openxmlformats.org/drawingml/2006/main" noGrp="1"/>
+          </p:cNvSpPr>
+          <p:nvPr>
+            <p:ph type="body" idx="1"/>
+          </p:nvPr>
+        </p:nvSpPr>
+        <p:spPr>
+          <a:xfrm xmlns:a="http://schemas.openxmlformats.org/drawingml/2006/main">
+            <a:off x="685800" y="1905000"/>
+            <a:ext cx="5029200" cy="4267200"/>
+          </a:xfrm>
+          <a:prstGeom xmlns:a="http://schemas.openxmlformats.org/drawingml/2006/main" prst="rect">
+            <a:avLst/>
+          </a:prstGeom>
+          <a:noFill xmlns:a="http://schemas.openxmlformats.org/drawingml/2006/main"/>
+          <a:ln xmlns:a="http://schemas.openxmlformats.org/drawingml/2006/main">
+            <a:noFill/>
+            <a:prstDash val="solid"/>
+          </a:ln>
+        </p:spPr>
+        <p:txBody>
+          <a:bodyPr xmlns:a="http://schemas.openxmlformats.org/drawingml/2006/main" wrap="square" lIns="0" tIns="0" rIns="0" bIns="0" anchor="t">
+            <a:normAutofit/>
+          </a:bodyPr>
+          <a:lstStyle xmlns:a="http://schemas.openxmlformats.org/drawingml/2006/main">
+            <a:defPPr algn="l">
+              <a:defRPr sz="2250" b="0">
+                <a:solidFill>
+                  <a:schemeClr val="tx1"/>
+                </a:solidFill>
+                <a:latin typeface="+mn-lt"/>
+                <a:ea typeface="+mn-lt"/>
+                <a:cs typeface="+mn-lt"/>
+              </a:defRPr>
+            </a:defPPr>
+            <a:lvl1pPr marL="228600" indent="-228600">
+              <a:lnSpc>
+                <a:spcPct val="110000"/>
+              </a:lnSpc>
+              <a:spcBef>
+                <a:spcPts val="0"/>
+              </a:spcBef>
+              <a:spcAft>
+                <a:spcPts val="1200"/>
+              </a:spcAft>
+              <a:buChar char="•"/>
+            </a:lvl1pPr>
+            <a:lvl2pPr marL="533400" indent="-228600">
+              <a:lnSpc>
+                <a:spcPct val="110000"/>
+              </a:lnSpc>
+              <a:spcBef>
+                <a:spcPts val="0"/>
+              </a:spcBef>
+              <a:spcAft>
+                <a:spcPts val="1200"/>
+              </a:spcAft>
+              <a:buChar char="•"/>
+            </a:lvl2pPr>
+            <a:lvl3pPr marL="838200" indent="-228600">
+              <a:lnSpc>
+                <a:spcPct val="110000"/>
+              </a:lnSpc>
+              <a:spcBef>
+                <a:spcPts val="0"/>
+              </a:spcBef>
+              <a:spcAft>
+                <a:spcPts val="1200"/>
+              </a:spcAft>
+              <a:buChar char="•"/>
+            </a:lvl3pPr>
+            <a:lvl4pPr marL="1143000" indent="-228600">
+              <a:lnSpc>
+                <a:spcPct val="110000"/>
+              </a:lnSpc>
+              <a:spcBef>
+                <a:spcPts val="0"/>
+              </a:spcBef>
+              <a:spcAft>
+                <a:spcPts val="1200"/>
+              </a:spcAft>
+              <a:buChar char="•"/>
+            </a:lvl4pPr>
+            <a:lvl5pPr marL="1447800" indent="-228600">
+              <a:lnSpc>
+                <a:spcPct val="110000"/>
+              </a:lnSpc>
+              <a:spcBef>
+                <a:spcPts val="0"/>
+              </a:spcBef>
+              <a:spcAft>
+                <a:spcPts val="1200"/>
+              </a:spcAft>
+              <a:buChar char="•"/>
+            </a:lvl5pPr>
+            <a:lvl6pPr marL="1752600" indent="-228600">
+              <a:lnSpc>
+                <a:spcPct val="110000"/>
+              </a:lnSpc>
+              <a:spcBef>
+                <a:spcPts val="0"/>
+              </a:spcBef>
+              <a:spcAft>
+                <a:spcPts val="1200"/>
+              </a:spcAft>
+              <a:buChar char="•"/>
+            </a:lvl6pPr>
+            <a:lvl7pPr marL="2057400" indent="-228600">
+              <a:lnSpc>
+                <a:spcPct val="110000"/>
+              </a:lnSpc>
+              <a:spcBef>
+                <a:spcPts val="0"/>
+              </a:spcBef>
+              <a:spcAft>
+                <a:spcPts val="1200"/>
+              </a:spcAft>
+              <a:buChar char="•"/>
+            </a:lvl7pPr>
+            <a:lvl8pPr marL="2362200" indent="-228600">
+              <a:lnSpc>
+                <a:spcPct val="110000"/>
+              </a:lnSpc>
+              <a:spcBef>
+                <a:spcPts val="0"/>
+              </a:spcBef>
+              <a:spcAft>
+                <a:spcPts val="1200"/>
+              </a:spcAft>
+              <a:buChar char="•"/>
+            </a:lvl8pPr>
+            <a:lvl9pPr marL="2667000" indent="-228600">
+              <a:lnSpc>
+                <a:spcPct val="110000"/>
+              </a:lnSpc>
+              <a:spcBef>
+                <a:spcPts val="0"/>
+              </a:spcBef>
+              <a:spcAft>
+                <a:spcPts val="1200"/>
+              </a:spcAft>
+              <a:buChar char="•"/>
+            </a:lvl9pPr>
+          </a:lstStyle>
+          <a:p xmlns:a="http://schemas.openxmlformats.org/drawingml/2006/main"/>
+        </p:txBody>
+      </p:sp>
+    </p:spTree>
+  </p:cSld>
+</p:sldLayout>
+</file>
+
+<file path=ppt/slideLayouts/slideLayout6.xml><?xml version="1.0" encoding="utf-8"?>
+<p:sldLayout xmlns:p="http://schemas.openxmlformats.org/presentationml/2006/main" type="blank">
+  <p:cSld name="Blank">
     <p:spTree>
       <p:nvGrpSpPr>
         <p:cNvPr id="1" name=""/>
@@ -510,7 +2165,12 @@
   </p:cSld>
   <p:clrMap bg1="lt1" tx1="dk1" bg2="lt2" tx2="dk2" accent1="accent1" accent2="accent2" accent3="accent3" accent4="accent4" accent5="accent5" accent6="accent6" hlink="hlink" folHlink="folHlink"/>
   <p:sldLayoutIdLst>
-    <p:sldLayoutId xmlns:r="http://schemas.openxmlformats.org/officeDocument/2006/relationships" id="2147483649" r:id="R9fa3ff62b2194f38"/>
+    <p:sldLayoutId xmlns:r="http://schemas.openxmlformats.org/officeDocument/2006/relationships" id="2147483649" r:id="R26144fa052e544dc"/>
+    <p:sldLayoutId xmlns:r="http://schemas.openxmlformats.org/officeDocument/2006/relationships" id="2147483650" r:id="Rf8295cdb4b604269"/>
+    <p:sldLayoutId xmlns:r="http://schemas.openxmlformats.org/officeDocument/2006/relationships" id="2147483651" r:id="R9219d0dcd3334f0f"/>
+    <p:sldLayoutId xmlns:r="http://schemas.openxmlformats.org/officeDocument/2006/relationships" id="2147483652" r:id="R5cde899d09c649ee"/>
+    <p:sldLayoutId xmlns:r="http://schemas.openxmlformats.org/officeDocument/2006/relationships" id="2147483653" r:id="Ra62a4faae71142d2"/>
+    <p:sldLayoutId xmlns:r="http://schemas.openxmlformats.org/officeDocument/2006/relationships" id="2147483654" r:id="Reded5e7da4a04a35"/>
   </p:sldLayoutIdLst>
   <p:txStyles>
     <p:titleStyle>
@@ -833,16 +2493,16 @@
         <a:srgbClr val="96607D"/>
       </a:folHlink>
     </a:clrScheme>
-    <a:fontScheme name="Office">
+    <a:fontScheme name="">
       <a:majorFont>
-        <a:latin typeface="Calibri Light"/>
-        <a:ea typeface="Calibri Light"/>
-        <a:cs typeface="Calibri Light"/>
+        <a:latin typeface="Aptos"/>
+        <a:ea typeface=""/>
+        <a:cs typeface=""/>
       </a:majorFont>
       <a:minorFont>
-        <a:latin typeface="Calibri"/>
-        <a:ea typeface="Calibri"/>
-        <a:cs typeface="Calibri"/>
+        <a:latin typeface="Aptos"/>
+        <a:ea typeface=""/>
+        <a:cs typeface=""/>
       </a:minorFont>
     </a:fontScheme>
     <a:fmtScheme name="ChatGPT">
@@ -1058,10 +2718,10 @@
       </p:grpSpPr>
       <p:sp>
         <p:nvSpPr>
-          <p:cNvPr id="38" name="">
+          <p:cNvPr id="31" name="">
             <a:extLst xmlns:a="http://schemas.openxmlformats.org/drawingml/2006/main">
               <a:ext uri="{FF2B5EF4-FFF2-40B4-BE49-F238E27FC236}">
-                <a16:creationId xmlns:a16="http://schemas.microsoft.com/office/drawing/2014/main" id="{B7888E90-C5CA-4E00-AE9D-4D1E0B2B2D05}"/>
+                <a16:creationId xmlns:a16="http://schemas.microsoft.com/office/drawing/2014/main" id="{7F0BDC5D-49AF-47D0-848D-41B8BF51E68B}"/>
               </a:ext>
             </a:extLst>
           </p:cNvPr>
@@ -1091,7 +2751,7 @@
           <p:cNvPr id="2" name="">
             <a:extLst xmlns:a="http://schemas.openxmlformats.org/drawingml/2006/main">
               <a:ext uri="{FF2B5EF4-FFF2-40B4-BE49-F238E27FC236}">
-                <a16:creationId xmlns:a16="http://schemas.microsoft.com/office/drawing/2014/main" id="{5354E05E-730F-45DD-8DB4-27E42E794255}"/>
+                <a16:creationId xmlns:a16="http://schemas.microsoft.com/office/drawing/2014/main" id="{712B9B7D-4F47-4DD4-B48B-98CBFF56A842}"/>
               </a:ext>
             </a:extLst>
           </p:cNvPr>
@@ -1121,7 +2781,7 @@
           <p:cNvPr id="3" name="">
             <a:extLst xmlns:a="http://schemas.openxmlformats.org/drawingml/2006/main">
               <a:ext uri="{FF2B5EF4-FFF2-40B4-BE49-F238E27FC236}">
-                <a16:creationId xmlns:a16="http://schemas.microsoft.com/office/drawing/2014/main" id="{AFC6F060-7407-4BA9-B7DB-BD69A0A5B4D2}"/>
+                <a16:creationId xmlns:a16="http://schemas.microsoft.com/office/drawing/2014/main" id="{10F67499-25DC-4274-853A-1BF9A7F5F40C}"/>
               </a:ext>
             </a:extLst>
           </p:cNvPr>
@@ -1147,7 +2807,18 @@
           <a:bodyPr xmlns:a="http://schemas.openxmlformats.org/drawingml/2006/main" anchor="ctr">
             <a:normAutofit fontScale="100000"/>
           </a:bodyPr>
-          <a:lstStyle xmlns:a="http://schemas.openxmlformats.org/drawingml/2006/main"/>
+          <a:lstStyle xmlns:a="http://schemas.openxmlformats.org/drawingml/2006/main">
+            <a:defPPr algn="l">
+              <a:defRPr sz="1125" b="1">
+                <a:solidFill>
+                  <a:srgbClr val="41B5E6"/>
+                </a:solidFill>
+                <a:latin typeface="Century Gothic"/>
+                <a:ea typeface="Century Gothic"/>
+                <a:cs typeface="Century Gothic"/>
+              </a:defRPr>
+            </a:defPPr>
+          </a:lstStyle>
           <a:p xmlns:a="http://schemas.openxmlformats.org/drawingml/2006/main">
             <a:pPr algn="l">
               <a:defRPr sz="1125" b="1">
@@ -1168,7 +2839,7 @@
                 <a:ea typeface="Century Gothic"/>
                 <a:cs typeface="Century Gothic"/>
               </a:rPr>
-              <a:t>ЛЗ 6  ·  МОНТЕ-КАРЛО БОЛЖАМЫ</a:t>
+              <a:t>ЛЗ 6  ·  МЕРЗІМ БОЛЖАМЫ</a:t>
             </a:r>
           </a:p>
         </p:txBody>
@@ -1178,7 +2849,7 @@
           <p:cNvPr id="4" name="">
             <a:extLst xmlns:a="http://schemas.openxmlformats.org/drawingml/2006/main">
               <a:ext uri="{FF2B5EF4-FFF2-40B4-BE49-F238E27FC236}">
-                <a16:creationId xmlns:a16="http://schemas.microsoft.com/office/drawing/2014/main" id="{01993C6D-8183-41AB-8BF2-F4A528829F72}"/>
+                <a16:creationId xmlns:a16="http://schemas.microsoft.com/office/drawing/2014/main" id="{13227279-4968-4CCE-8F0F-C1E81EC3F2B8}"/>
               </a:ext>
             </a:extLst>
           </p:cNvPr>
@@ -1204,7 +2875,18 @@
           <a:bodyPr xmlns:a="http://schemas.openxmlformats.org/drawingml/2006/main" anchor="ctr">
             <a:normAutofit fontScale="100000"/>
           </a:bodyPr>
-          <a:lstStyle xmlns:a="http://schemas.openxmlformats.org/drawingml/2006/main"/>
+          <a:lstStyle xmlns:a="http://schemas.openxmlformats.org/drawingml/2006/main">
+            <a:defPPr algn="l">
+              <a:defRPr sz="2925" b="1">
+                <a:solidFill>
+                  <a:srgbClr val="F6FAFD"/>
+                </a:solidFill>
+                <a:latin typeface="Century Gothic"/>
+                <a:ea typeface="Century Gothic"/>
+                <a:cs typeface="Century Gothic"/>
+              </a:defRPr>
+            </a:defPPr>
+          </a:lstStyle>
           <a:p xmlns:a="http://schemas.openxmlformats.org/drawingml/2006/main">
             <a:pPr algn="l">
               <a:defRPr sz="2925" b="1">
@@ -1258,7 +2940,7 @@
           <p:cNvPr id="5" name="">
             <a:extLst xmlns:a="http://schemas.openxmlformats.org/drawingml/2006/main">
               <a:ext uri="{FF2B5EF4-FFF2-40B4-BE49-F238E27FC236}">
-                <a16:creationId xmlns:a16="http://schemas.microsoft.com/office/drawing/2014/main" id="{91DE05C5-BDD8-44CA-A554-751E4460C65B}"/>
+                <a16:creationId xmlns:a16="http://schemas.microsoft.com/office/drawing/2014/main" id="{3C98AF3F-5EB2-477F-99A4-C98897800C1F}"/>
               </a:ext>
             </a:extLst>
           </p:cNvPr>
@@ -1284,7 +2966,18 @@
           <a:bodyPr xmlns:a="http://schemas.openxmlformats.org/drawingml/2006/main" anchor="ctr">
             <a:normAutofit fontScale="100000"/>
           </a:bodyPr>
-          <a:lstStyle xmlns:a="http://schemas.openxmlformats.org/drawingml/2006/main"/>
+          <a:lstStyle xmlns:a="http://schemas.openxmlformats.org/drawingml/2006/main">
+            <a:defPPr algn="l">
+              <a:defRPr sz="1275" b="0">
+                <a:solidFill>
+                  <a:srgbClr val="9EADBD"/>
+                </a:solidFill>
+                <a:latin typeface="Century Gothic"/>
+                <a:ea typeface="Century Gothic"/>
+                <a:cs typeface="Century Gothic"/>
+              </a:defRPr>
+            </a:defPPr>
+          </a:lstStyle>
           <a:p xmlns:a="http://schemas.openxmlformats.org/drawingml/2006/main">
             <a:pPr algn="l">
               <a:defRPr sz="1275" b="0">
@@ -1315,7 +3008,7 @@
           <p:cNvPr id="6" name="">
             <a:extLst xmlns:a="http://schemas.openxmlformats.org/drawingml/2006/main">
               <a:ext uri="{FF2B5EF4-FFF2-40B4-BE49-F238E27FC236}">
-                <a16:creationId xmlns:a16="http://schemas.microsoft.com/office/drawing/2014/main" id="{9383310E-07B6-40D7-95DA-0E12DF683EDC}"/>
+                <a16:creationId xmlns:a16="http://schemas.microsoft.com/office/drawing/2014/main" id="{1D25FFB1-782C-4C65-AE15-D8B7BB5A54C4}"/>
               </a:ext>
             </a:extLst>
           </p:cNvPr>
@@ -1326,7 +3019,7 @@
         </p:nvSpPr>
         <p:spPr>
           <a:xfrm xmlns:a="http://schemas.openxmlformats.org/drawingml/2006/main">
-            <a:off x="419100" y="2628900"/>
+            <a:off x="419100" y="2533650"/>
             <a:ext cx="4762500" cy="247650"/>
           </a:xfrm>
           <a:prstGeom xmlns:a="http://schemas.openxmlformats.org/drawingml/2006/main" prst="rect">
@@ -1341,7 +3034,18 @@
           <a:bodyPr xmlns:a="http://schemas.openxmlformats.org/drawingml/2006/main" anchor="ctr">
             <a:normAutofit fontScale="100000"/>
           </a:bodyPr>
-          <a:lstStyle xmlns:a="http://schemas.openxmlformats.org/drawingml/2006/main"/>
+          <a:lstStyle xmlns:a="http://schemas.openxmlformats.org/drawingml/2006/main">
+            <a:defPPr algn="l">
+              <a:defRPr sz="975" b="1">
+                <a:solidFill>
+                  <a:srgbClr val="9EADBD"/>
+                </a:solidFill>
+                <a:latin typeface="Century Gothic"/>
+                <a:ea typeface="Century Gothic"/>
+                <a:cs typeface="Century Gothic"/>
+              </a:defRPr>
+            </a:defPPr>
+          </a:lstStyle>
           <a:p xmlns:a="http://schemas.openxmlformats.org/drawingml/2006/main">
             <a:pPr algn="l">
               <a:defRPr sz="975" b="1">
@@ -1362,7 +3066,7 @@
                 <a:ea typeface="Century Gothic"/>
                 <a:cs typeface="Century Gothic"/>
               </a:rPr>
-              <a:t>ЖҰМЫС ДИАПАЗОНЫ  ·  P50–P85</a:t>
+              <a:t>ЫҚТИМАЛ МЕРЗІМДЕР</a:t>
             </a:r>
           </a:p>
         </p:txBody>
@@ -1372,7 +3076,7 @@
           <p:cNvPr id="7" name="">
             <a:extLst xmlns:a="http://schemas.openxmlformats.org/drawingml/2006/main">
               <a:ext uri="{FF2B5EF4-FFF2-40B4-BE49-F238E27FC236}">
-                <a16:creationId xmlns:a16="http://schemas.microsoft.com/office/drawing/2014/main" id="{29232816-58CA-47C6-A241-D7785E6C330F}"/>
+                <a16:creationId xmlns:a16="http://schemas.microsoft.com/office/drawing/2014/main" id="{C9983F16-002D-46C1-A801-6742FF4083BF}"/>
               </a:ext>
             </a:extLst>
           </p:cNvPr>
@@ -1383,8 +3087,8 @@
         </p:nvSpPr>
         <p:spPr>
           <a:xfrm xmlns:a="http://schemas.openxmlformats.org/drawingml/2006/main">
-            <a:off x="400050" y="2905125"/>
-            <a:ext cx="5286375" cy="590550"/>
+            <a:off x="400050" y="2857500"/>
+            <a:ext cx="3143250" cy="533400"/>
           </a:xfrm>
           <a:prstGeom xmlns:a="http://schemas.openxmlformats.org/drawingml/2006/main" prst="rect">
             <a:avLst/>
@@ -1396,12 +3100,23 @@
         </p:spPr>
         <p:txBody>
           <a:bodyPr xmlns:a="http://schemas.openxmlformats.org/drawingml/2006/main" anchor="ctr">
-            <a:normAutofit fontScale="99242"/>
+            <a:normAutofit fontScale="94309"/>
           </a:bodyPr>
-          <a:lstStyle xmlns:a="http://schemas.openxmlformats.org/drawingml/2006/main"/>
+          <a:lstStyle xmlns:a="http://schemas.openxmlformats.org/drawingml/2006/main">
+            <a:defPPr algn="l">
+              <a:defRPr sz="3075" b="1">
+                <a:solidFill>
+                  <a:srgbClr val="F6FAFD"/>
+                </a:solidFill>
+                <a:latin typeface="Century Gothic"/>
+                <a:ea typeface="Century Gothic"/>
+                <a:cs typeface="Century Gothic"/>
+              </a:defRPr>
+            </a:defPPr>
+          </a:lstStyle>
           <a:p xmlns:a="http://schemas.openxmlformats.org/drawingml/2006/main">
             <a:pPr algn="l">
-              <a:defRPr sz="3300" b="1">
+              <a:defRPr sz="3075" b="1">
                 <a:solidFill>
                   <a:srgbClr val="F6FAFD"/>
                 </a:solidFill>
@@ -1411,7 +3126,7 @@
               </a:defRPr>
             </a:pPr>
             <a:r>
-              <a:rPr sz="3300" b="1">
+              <a:rPr sz="3075" b="1">
                 <a:solidFill>
                   <a:srgbClr val="F6FAFD"/>
                 </a:solidFill>
@@ -1419,7 +3134,7 @@
                 <a:ea typeface="Century Gothic"/>
                 <a:cs typeface="Century Gothic"/>
               </a:rPr>
-              <a:t>15–29 қараша</a:t>
+              <a:t>12 қараша</a:t>
             </a:r>
           </a:p>
         </p:txBody>
@@ -1429,7 +3144,7 @@
           <p:cNvPr id="8" name="">
             <a:extLst xmlns:a="http://schemas.openxmlformats.org/drawingml/2006/main">
               <a:ext uri="{FF2B5EF4-FFF2-40B4-BE49-F238E27FC236}">
-                <a16:creationId xmlns:a16="http://schemas.microsoft.com/office/drawing/2014/main" id="{72F5677D-DC36-4225-8B74-C190E0118AAC}"/>
+                <a16:creationId xmlns:a16="http://schemas.microsoft.com/office/drawing/2014/main" id="{34418AE9-25CE-42CB-B57B-5053D906C5F7}"/>
               </a:ext>
             </a:extLst>
           </p:cNvPr>
@@ -1440,40 +3155,8 @@
         </p:nvSpPr>
         <p:spPr>
           <a:xfrm xmlns:a="http://schemas.openxmlformats.org/drawingml/2006/main">
-            <a:off x="419100" y="3724275"/>
-            <a:ext cx="438150" cy="38100"/>
-          </a:xfrm>
-          <a:prstGeom xmlns:a="http://schemas.openxmlformats.org/drawingml/2006/main" prst="roundRect">
-            <a:avLst>
-              <a:gd name="adj" fmla="val 50000"/>
-            </a:avLst>
-          </a:prstGeom>
-          <a:solidFill xmlns:a="http://schemas.openxmlformats.org/drawingml/2006/main">
-            <a:srgbClr val="FF6B36"/>
-          </a:solidFill>
-          <a:ln xmlns:a="http://schemas.openxmlformats.org/drawingml/2006/main" w="0">
-            <a:noFill/>
-          </a:ln>
-        </p:spPr>
-      </p:sp>
-      <p:sp>
-        <p:nvSpPr>
-          <p:cNvPr id="9" name="">
-            <a:extLst xmlns:a="http://schemas.openxmlformats.org/drawingml/2006/main">
-              <a:ext uri="{FF2B5EF4-FFF2-40B4-BE49-F238E27FC236}">
-                <a16:creationId xmlns:a16="http://schemas.microsoft.com/office/drawing/2014/main" id="{DB8B881B-E2ED-4765-BD7C-66BDB919DD6C}"/>
-              </a:ext>
-            </a:extLst>
-          </p:cNvPr>
-          <p:cNvSpPr>
-            <a:spLocks xmlns:a="http://schemas.openxmlformats.org/drawingml/2006/main" noGrp="1"/>
-          </p:cNvSpPr>
-          <p:nvPr/>
-        </p:nvSpPr>
-        <p:spPr>
-          <a:xfrm xmlns:a="http://schemas.openxmlformats.org/drawingml/2006/main">
-            <a:off x="971550" y="3581400"/>
-            <a:ext cx="3333750" cy="323850"/>
+            <a:off x="3714750" y="2924175"/>
+            <a:ext cx="1143000" cy="400050"/>
           </a:xfrm>
           <a:prstGeom xmlns:a="http://schemas.openxmlformats.org/drawingml/2006/main" prst="rect">
             <a:avLst/>
@@ -1485,14 +3168,25 @@
         </p:spPr>
         <p:txBody>
           <a:bodyPr xmlns:a="http://schemas.openxmlformats.org/drawingml/2006/main" anchor="ctr">
-            <a:normAutofit fontScale="88406"/>
+            <a:normAutofit fontScale="96428"/>
           </a:bodyPr>
-          <a:lstStyle xmlns:a="http://schemas.openxmlformats.org/drawingml/2006/main"/>
+          <a:lstStyle xmlns:a="http://schemas.openxmlformats.org/drawingml/2006/main">
+            <a:defPPr algn="l">
+              <a:defRPr sz="2100" b="1">
+                <a:solidFill>
+                  <a:srgbClr val="41B5E6"/>
+                </a:solidFill>
+                <a:latin typeface="Century Gothic"/>
+                <a:ea typeface="Century Gothic"/>
+                <a:cs typeface="Century Gothic"/>
+              </a:defRPr>
+            </a:defPPr>
+          </a:lstStyle>
           <a:p xmlns:a="http://schemas.openxmlformats.org/drawingml/2006/main">
             <a:pPr algn="l">
-              <a:defRPr sz="1725" b="1">
-                <a:solidFill>
-                  <a:srgbClr val="FF6B36"/>
+              <a:defRPr sz="2100" b="1">
+                <a:solidFill>
+                  <a:srgbClr val="41B5E6"/>
                 </a:solidFill>
                 <a:latin typeface="Century Gothic"/>
                 <a:ea typeface="Century Gothic"/>
@@ -1500,25 +3194,25 @@
               </a:defRPr>
             </a:pPr>
             <a:r>
-              <a:rPr sz="1725" b="1">
-                <a:solidFill>
-                  <a:srgbClr val="FF6B36"/>
+              <a:rPr sz="2100" b="1">
+                <a:solidFill>
+                  <a:srgbClr val="41B5E6"/>
                 </a:solidFill>
                 <a:latin typeface="Century Gothic"/>
                 <a:ea typeface="Century Gothic"/>
                 <a:cs typeface="Century Gothic"/>
               </a:rPr>
-              <a:t>P85  ·  29.11.2026</a:t>
+              <a:t>50%</a:t>
             </a:r>
           </a:p>
         </p:txBody>
       </p:sp>
       <p:sp>
         <p:nvSpPr>
-          <p:cNvPr id="10" name="">
+          <p:cNvPr id="9" name="">
             <a:extLst xmlns:a="http://schemas.openxmlformats.org/drawingml/2006/main">
               <a:ext uri="{FF2B5EF4-FFF2-40B4-BE49-F238E27FC236}">
-                <a16:creationId xmlns:a16="http://schemas.microsoft.com/office/drawing/2014/main" id="{995FD281-7FDC-4634-B4A1-A4FD322BEBD2}"/>
+                <a16:creationId xmlns:a16="http://schemas.microsoft.com/office/drawing/2014/main" id="{0C237B8A-C29C-4E34-86EE-AD03903CCFBC}"/>
               </a:ext>
             </a:extLst>
           </p:cNvPr>
@@ -1529,8 +3223,8 @@
         </p:nvSpPr>
         <p:spPr>
           <a:xfrm xmlns:a="http://schemas.openxmlformats.org/drawingml/2006/main">
-            <a:off x="419100" y="4000500"/>
-            <a:ext cx="5143500" cy="323850"/>
+            <a:off x="400050" y="3524250"/>
+            <a:ext cx="3143250" cy="533400"/>
           </a:xfrm>
           <a:prstGeom xmlns:a="http://schemas.openxmlformats.org/drawingml/2006/main" prst="rect">
             <a:avLst/>
@@ -1542,12 +3236,23 @@
         </p:spPr>
         <p:txBody>
           <a:bodyPr xmlns:a="http://schemas.openxmlformats.org/drawingml/2006/main" anchor="ctr">
-            <a:normAutofit fontScale="100000"/>
+            <a:normAutofit fontScale="94309"/>
           </a:bodyPr>
-          <a:lstStyle xmlns:a="http://schemas.openxmlformats.org/drawingml/2006/main"/>
+          <a:lstStyle xmlns:a="http://schemas.openxmlformats.org/drawingml/2006/main">
+            <a:defPPr algn="l">
+              <a:defRPr sz="3075" b="1">
+                <a:solidFill>
+                  <a:srgbClr val="F6FAFD"/>
+                </a:solidFill>
+                <a:latin typeface="Century Gothic"/>
+                <a:ea typeface="Century Gothic"/>
+                <a:cs typeface="Century Gothic"/>
+              </a:defRPr>
+            </a:defPPr>
+          </a:lstStyle>
           <a:p xmlns:a="http://schemas.openxmlformats.org/drawingml/2006/main">
             <a:pPr algn="l">
-              <a:defRPr sz="1200" b="0">
+              <a:defRPr sz="3075" b="1">
                 <a:solidFill>
                   <a:srgbClr val="F6FAFD"/>
                 </a:solidFill>
@@ -1557,7 +3262,7 @@
               </a:defRPr>
             </a:pPr>
             <a:r>
-              <a:rPr sz="1200" b="0">
+              <a:rPr sz="3075" b="1">
                 <a:solidFill>
                   <a:srgbClr val="F6FAFD"/>
                 </a:solidFill>
@@ -1565,17 +3270,17 @@
                 <a:ea typeface="Century Gothic"/>
                 <a:cs typeface="Century Gothic"/>
               </a:rPr>
-              <a:t>Осы күнге дейін аяқтау ықтималдығы — 85%</a:t>
+              <a:t>26 қараша</a:t>
             </a:r>
           </a:p>
         </p:txBody>
       </p:sp>
       <p:sp>
         <p:nvSpPr>
-          <p:cNvPr id="11" name="">
+          <p:cNvPr id="10" name="">
             <a:extLst xmlns:a="http://schemas.openxmlformats.org/drawingml/2006/main">
               <a:ext uri="{FF2B5EF4-FFF2-40B4-BE49-F238E27FC236}">
-                <a16:creationId xmlns:a16="http://schemas.microsoft.com/office/drawing/2014/main" id="{36DF8D88-4AB1-4C07-804D-09347CFDA248}"/>
+                <a16:creationId xmlns:a16="http://schemas.microsoft.com/office/drawing/2014/main" id="{45667413-7123-42A0-B7BC-281E8AB68920}"/>
               </a:ext>
             </a:extLst>
           </p:cNvPr>
@@ -1586,7 +3291,75 @@
         </p:nvSpPr>
         <p:spPr>
           <a:xfrm xmlns:a="http://schemas.openxmlformats.org/drawingml/2006/main">
-            <a:off x="419100" y="4953000"/>
+            <a:off x="3714750" y="3590925"/>
+            <a:ext cx="1143000" cy="400050"/>
+          </a:xfrm>
+          <a:prstGeom xmlns:a="http://schemas.openxmlformats.org/drawingml/2006/main" prst="rect">
+            <a:avLst/>
+          </a:prstGeom>
+          <a:noFill xmlns:a="http://schemas.openxmlformats.org/drawingml/2006/main"/>
+          <a:ln xmlns:a="http://schemas.openxmlformats.org/drawingml/2006/main" w="0">
+            <a:noFill/>
+          </a:ln>
+        </p:spPr>
+        <p:txBody>
+          <a:bodyPr xmlns:a="http://schemas.openxmlformats.org/drawingml/2006/main" anchor="ctr">
+            <a:normAutofit fontScale="96428"/>
+          </a:bodyPr>
+          <a:lstStyle xmlns:a="http://schemas.openxmlformats.org/drawingml/2006/main">
+            <a:defPPr algn="l">
+              <a:defRPr sz="2100" b="1">
+                <a:solidFill>
+                  <a:srgbClr val="FF6B36"/>
+                </a:solidFill>
+                <a:latin typeface="Century Gothic"/>
+                <a:ea typeface="Century Gothic"/>
+                <a:cs typeface="Century Gothic"/>
+              </a:defRPr>
+            </a:defPPr>
+          </a:lstStyle>
+          <a:p xmlns:a="http://schemas.openxmlformats.org/drawingml/2006/main">
+            <a:pPr algn="l">
+              <a:defRPr sz="2100" b="1">
+                <a:solidFill>
+                  <a:srgbClr val="FF6B36"/>
+                </a:solidFill>
+                <a:latin typeface="Century Gothic"/>
+                <a:ea typeface="Century Gothic"/>
+                <a:cs typeface="Century Gothic"/>
+              </a:defRPr>
+            </a:pPr>
+            <a:r>
+              <a:rPr sz="2100" b="1">
+                <a:solidFill>
+                  <a:srgbClr val="FF6B36"/>
+                </a:solidFill>
+                <a:latin typeface="Century Gothic"/>
+                <a:ea typeface="Century Gothic"/>
+                <a:cs typeface="Century Gothic"/>
+              </a:rPr>
+              <a:t>85%</a:t>
+            </a:r>
+          </a:p>
+        </p:txBody>
+      </p:sp>
+      <p:sp>
+        <p:nvSpPr>
+          <p:cNvPr id="11" name="">
+            <a:extLst xmlns:a="http://schemas.openxmlformats.org/drawingml/2006/main">
+              <a:ext uri="{FF2B5EF4-FFF2-40B4-BE49-F238E27FC236}">
+                <a16:creationId xmlns:a16="http://schemas.microsoft.com/office/drawing/2014/main" id="{102F3B9C-1D86-40C7-A138-ABA89C1626C9}"/>
+              </a:ext>
+            </a:extLst>
+          </p:cNvPr>
+          <p:cNvSpPr>
+            <a:spLocks xmlns:a="http://schemas.openxmlformats.org/drawingml/2006/main" noGrp="1"/>
+          </p:cNvSpPr>
+          <p:nvPr/>
+        </p:nvSpPr>
+        <p:spPr>
+          <a:xfrm xmlns:a="http://schemas.openxmlformats.org/drawingml/2006/main">
+            <a:off x="419100" y="4572000"/>
             <a:ext cx="2857500" cy="228600"/>
           </a:xfrm>
           <a:prstGeom xmlns:a="http://schemas.openxmlformats.org/drawingml/2006/main" prst="rect">
@@ -1601,7 +3374,18 @@
           <a:bodyPr xmlns:a="http://schemas.openxmlformats.org/drawingml/2006/main" anchor="ctr">
             <a:normAutofit fontScale="100000"/>
           </a:bodyPr>
-          <a:lstStyle xmlns:a="http://schemas.openxmlformats.org/drawingml/2006/main"/>
+          <a:lstStyle xmlns:a="http://schemas.openxmlformats.org/drawingml/2006/main">
+            <a:defPPr algn="l">
+              <a:defRPr sz="900" b="1">
+                <a:solidFill>
+                  <a:srgbClr val="41B5E6"/>
+                </a:solidFill>
+                <a:latin typeface="Century Gothic"/>
+                <a:ea typeface="Century Gothic"/>
+                <a:cs typeface="Century Gothic"/>
+              </a:defRPr>
+            </a:defPPr>
+          </a:lstStyle>
           <a:p xmlns:a="http://schemas.openxmlformats.org/drawingml/2006/main">
             <a:pPr algn="l">
               <a:defRPr sz="900" b="1">
@@ -1632,7 +3416,7 @@
           <p:cNvPr id="12" name="">
             <a:extLst xmlns:a="http://schemas.openxmlformats.org/drawingml/2006/main">
               <a:ext uri="{FF2B5EF4-FFF2-40B4-BE49-F238E27FC236}">
-                <a16:creationId xmlns:a16="http://schemas.microsoft.com/office/drawing/2014/main" id="{DCA3E4CF-2ADF-4254-90C3-CBB8954EE039}"/>
+                <a16:creationId xmlns:a16="http://schemas.microsoft.com/office/drawing/2014/main" id="{187F04C9-E4AC-4E16-A6FC-17EC482B6409}"/>
               </a:ext>
             </a:extLst>
           </p:cNvPr>
@@ -1643,8 +3427,8 @@
         </p:nvSpPr>
         <p:spPr>
           <a:xfrm xmlns:a="http://schemas.openxmlformats.org/drawingml/2006/main">
-            <a:off x="419100" y="5257800"/>
-            <a:ext cx="5191125" cy="628650"/>
+            <a:off x="419100" y="4876800"/>
+            <a:ext cx="5191125" cy="666750"/>
           </a:xfrm>
           <a:prstGeom xmlns:a="http://schemas.openxmlformats.org/drawingml/2006/main" prst="rect">
             <a:avLst/>
@@ -1658,7 +3442,18 @@
           <a:bodyPr xmlns:a="http://schemas.openxmlformats.org/drawingml/2006/main" anchor="ctr">
             <a:normAutofit fontScale="100000"/>
           </a:bodyPr>
-          <a:lstStyle xmlns:a="http://schemas.openxmlformats.org/drawingml/2006/main"/>
+          <a:lstStyle xmlns:a="http://schemas.openxmlformats.org/drawingml/2006/main">
+            <a:defPPr algn="l">
+              <a:defRPr sz="1050" b="0">
+                <a:solidFill>
+                  <a:srgbClr val="9EADBD"/>
+                </a:solidFill>
+                <a:latin typeface="Century Gothic"/>
+                <a:ea typeface="Century Gothic"/>
+                <a:cs typeface="Century Gothic"/>
+              </a:defRPr>
+            </a:defPPr>
+          </a:lstStyle>
           <a:p xmlns:a="http://schemas.openxmlformats.org/drawingml/2006/main">
             <a:pPr algn="l">
               <a:defRPr sz="1050" b="0">
@@ -1679,7 +3474,7 @@
                 <a:ea typeface="Century Gothic"/>
                 <a:cs typeface="Century Gothic"/>
               </a:rPr>
-              <a:t>Көлем 18 элемент болып қалады. Команда құрамы өзгермейді. Апталық өнімділік тарихи үлестірімге сәйкес алынды.</a:t>
+              <a:t>Көлем 18 элемент болып қалады. Команда құрамы өзгермейді. Нөлдік апталар тарихи деректе сақталған.</a:t>
             </a:r>
           </a:p>
         </p:txBody>
@@ -1689,7 +3484,75 @@
           <p:cNvPr id="13" name="">
             <a:extLst xmlns:a="http://schemas.openxmlformats.org/drawingml/2006/main">
               <a:ext uri="{FF2B5EF4-FFF2-40B4-BE49-F238E27FC236}">
-                <a16:creationId xmlns:a16="http://schemas.microsoft.com/office/drawing/2014/main" id="{FF63BAEC-AC8B-491F-9BDA-E21783F85F53}"/>
+                <a16:creationId xmlns:a16="http://schemas.microsoft.com/office/drawing/2014/main" id="{304BA2AC-8062-48DA-87E1-7EE15BEE13FE}"/>
+              </a:ext>
+            </a:extLst>
+          </p:cNvPr>
+          <p:cNvSpPr>
+            <a:spLocks xmlns:a="http://schemas.openxmlformats.org/drawingml/2006/main" noGrp="1"/>
+          </p:cNvSpPr>
+          <p:nvPr/>
+        </p:nvSpPr>
+        <p:spPr>
+          <a:xfrm xmlns:a="http://schemas.openxmlformats.org/drawingml/2006/main">
+            <a:off x="419100" y="5753100"/>
+            <a:ext cx="4953000" cy="266700"/>
+          </a:xfrm>
+          <a:prstGeom xmlns:a="http://schemas.openxmlformats.org/drawingml/2006/main" prst="rect">
+            <a:avLst/>
+          </a:prstGeom>
+          <a:noFill xmlns:a="http://schemas.openxmlformats.org/drawingml/2006/main"/>
+          <a:ln xmlns:a="http://schemas.openxmlformats.org/drawingml/2006/main" w="0">
+            <a:noFill/>
+          </a:ln>
+        </p:spPr>
+        <p:txBody>
+          <a:bodyPr xmlns:a="http://schemas.openxmlformats.org/drawingml/2006/main" anchor="ctr">
+            <a:normAutofit fontScale="100000"/>
+          </a:bodyPr>
+          <a:lstStyle xmlns:a="http://schemas.openxmlformats.org/drawingml/2006/main">
+            <a:defPPr algn="l">
+              <a:defRPr sz="1125" b="1">
+                <a:solidFill>
+                  <a:srgbClr val="F6FAFD"/>
+                </a:solidFill>
+                <a:latin typeface="Century Gothic"/>
+                <a:ea typeface="Century Gothic"/>
+                <a:cs typeface="Century Gothic"/>
+              </a:defRPr>
+            </a:defPPr>
+          </a:lstStyle>
+          <a:p xmlns:a="http://schemas.openxmlformats.org/drawingml/2006/main">
+            <a:pPr algn="l">
+              <a:defRPr sz="1125" b="1">
+                <a:solidFill>
+                  <a:srgbClr val="F6FAFD"/>
+                </a:solidFill>
+                <a:latin typeface="Century Gothic"/>
+                <a:ea typeface="Century Gothic"/>
+                <a:cs typeface="Century Gothic"/>
+              </a:defRPr>
+            </a:pPr>
+            <a:r>
+              <a:rPr sz="1125" b="1">
+                <a:solidFill>
+                  <a:srgbClr val="F6FAFD"/>
+                </a:solidFill>
+                <a:latin typeface="Century Gothic"/>
+                <a:ea typeface="Century Gothic"/>
+                <a:cs typeface="Century Gothic"/>
+              </a:rPr>
+              <a:t>Келесі қайта есептеу: 22.10.2026</a:t>
+            </a:r>
+          </a:p>
+        </p:txBody>
+      </p:sp>
+      <p:sp>
+        <p:nvSpPr>
+          <p:cNvPr id="14" name="">
+            <a:extLst xmlns:a="http://schemas.openxmlformats.org/drawingml/2006/main">
+              <a:ext uri="{FF2B5EF4-FFF2-40B4-BE49-F238E27FC236}">
+                <a16:creationId xmlns:a16="http://schemas.microsoft.com/office/drawing/2014/main" id="{B3808496-4409-4910-B211-AC50F5A13313}"/>
               </a:ext>
             </a:extLst>
           </p:cNvPr>
@@ -1718,10 +3581,10 @@
       </p:sp>
       <p:sp>
         <p:nvSpPr>
-          <p:cNvPr id="14" name="">
+          <p:cNvPr id="15" name="">
             <a:extLst xmlns:a="http://schemas.openxmlformats.org/drawingml/2006/main">
               <a:ext uri="{FF2B5EF4-FFF2-40B4-BE49-F238E27FC236}">
-                <a16:creationId xmlns:a16="http://schemas.microsoft.com/office/drawing/2014/main" id="{DDFB4D10-F0FF-4039-8FAF-C8EA024BC7DD}"/>
+                <a16:creationId xmlns:a16="http://schemas.microsoft.com/office/drawing/2014/main" id="{3C9B4615-BF72-41A0-84E7-E4F585904CBD}"/>
               </a:ext>
             </a:extLst>
           </p:cNvPr>
@@ -1747,7 +3610,18 @@
           <a:bodyPr xmlns:a="http://schemas.openxmlformats.org/drawingml/2006/main" anchor="ctr">
             <a:normAutofit fontScale="92308"/>
           </a:bodyPr>
-          <a:lstStyle xmlns:a="http://schemas.openxmlformats.org/drawingml/2006/main"/>
+          <a:lstStyle xmlns:a="http://schemas.openxmlformats.org/drawingml/2006/main">
+            <a:defPPr algn="l">
+              <a:defRPr sz="975" b="1">
+                <a:solidFill>
+                  <a:srgbClr val="41B5E6"/>
+                </a:solidFill>
+                <a:latin typeface="Century Gothic"/>
+                <a:ea typeface="Century Gothic"/>
+                <a:cs typeface="Century Gothic"/>
+              </a:defRPr>
+            </a:defPPr>
+          </a:lstStyle>
           <a:p xmlns:a="http://schemas.openxmlformats.org/drawingml/2006/main">
             <a:pPr algn="l">
               <a:defRPr sz="975" b="1">
@@ -1768,17 +3642,17 @@
                 <a:ea typeface="Century Gothic"/>
                 <a:cs typeface="Century Gothic"/>
               </a:rPr>
-              <a:t>АЯҚТАЛУ ЫҚТИМАЛДЫҒЫ</a:t>
+              <a:t>ТАПСЫРЫС БЕРУШІГЕ ҰСЫНЫС</a:t>
             </a:r>
           </a:p>
         </p:txBody>
       </p:sp>
       <p:sp>
         <p:nvSpPr>
-          <p:cNvPr id="15" name="">
+          <p:cNvPr id="16" name="">
             <a:extLst xmlns:a="http://schemas.openxmlformats.org/drawingml/2006/main">
               <a:ext uri="{FF2B5EF4-FFF2-40B4-BE49-F238E27FC236}">
-                <a16:creationId xmlns:a16="http://schemas.microsoft.com/office/drawing/2014/main" id="{D57432C7-9A84-48DE-80C4-AB71A4D46777}"/>
+                <a16:creationId xmlns:a16="http://schemas.microsoft.com/office/drawing/2014/main" id="{99BC3F01-F275-49D6-A559-426FF6A007E6}"/>
               </a:ext>
             </a:extLst>
           </p:cNvPr>
@@ -1802,12 +3676,23 @@
         </p:spPr>
         <p:txBody>
           <a:bodyPr xmlns:a="http://schemas.openxmlformats.org/drawingml/2006/main" anchor="ctr">
-            <a:normAutofit fontScale="98095"/>
+            <a:normAutofit fontScale="100000"/>
           </a:bodyPr>
-          <a:lstStyle xmlns:a="http://schemas.openxmlformats.org/drawingml/2006/main"/>
+          <a:lstStyle xmlns:a="http://schemas.openxmlformats.org/drawingml/2006/main">
+            <a:defPPr algn="l">
+              <a:defRPr sz="4950" b="1">
+                <a:solidFill>
+                  <a:srgbClr val="F6FAFD"/>
+                </a:solidFill>
+                <a:latin typeface="Century Gothic"/>
+                <a:ea typeface="Century Gothic"/>
+                <a:cs typeface="Century Gothic"/>
+              </a:defRPr>
+            </a:defPPr>
+          </a:lstStyle>
           <a:p xmlns:a="http://schemas.openxmlformats.org/drawingml/2006/main">
             <a:pPr algn="l">
-              <a:defRPr sz="5250" b="1">
+              <a:defRPr sz="4950" b="1">
                 <a:solidFill>
                   <a:srgbClr val="F6FAFD"/>
                 </a:solidFill>
@@ -1817,7 +3702,7 @@
               </a:defRPr>
             </a:pPr>
             <a:r>
-              <a:rPr sz="5250" b="1">
+              <a:rPr sz="4950" b="1">
                 <a:solidFill>
                   <a:srgbClr val="F6FAFD"/>
                 </a:solidFill>
@@ -1825,17 +3710,17 @@
                 <a:ea typeface="Century Gothic"/>
                 <a:cs typeface="Century Gothic"/>
               </a:rPr>
-              <a:t>85%</a:t>
+              <a:t>26.11</a:t>
             </a:r>
           </a:p>
         </p:txBody>
       </p:sp>
       <p:sp>
         <p:nvSpPr>
-          <p:cNvPr id="16" name="">
+          <p:cNvPr id="17" name="">
             <a:extLst xmlns:a="http://schemas.openxmlformats.org/drawingml/2006/main">
               <a:ext uri="{FF2B5EF4-FFF2-40B4-BE49-F238E27FC236}">
-                <a16:creationId xmlns:a16="http://schemas.microsoft.com/office/drawing/2014/main" id="{912B0F3E-F038-42EB-81AF-33E1277DD892}"/>
+                <a16:creationId xmlns:a16="http://schemas.microsoft.com/office/drawing/2014/main" id="{FBE7FB99-E76A-4108-A4D1-B02B110935BF}"/>
               </a:ext>
             </a:extLst>
           </p:cNvPr>
@@ -1859,12 +3744,23 @@
         </p:spPr>
         <p:txBody>
           <a:bodyPr xmlns:a="http://schemas.openxmlformats.org/drawingml/2006/main" anchor="ctr">
-            <a:normAutofit fontScale="100000"/>
+            <a:normAutofit fontScale="99029"/>
           </a:bodyPr>
-          <a:lstStyle xmlns:a="http://schemas.openxmlformats.org/drawingml/2006/main"/>
+          <a:lstStyle xmlns:a="http://schemas.openxmlformats.org/drawingml/2006/main">
+            <a:defPPr algn="l">
+              <a:defRPr sz="1425" b="1">
+                <a:solidFill>
+                  <a:srgbClr val="F6FAFD"/>
+                </a:solidFill>
+                <a:latin typeface="Century Gothic"/>
+                <a:ea typeface="Century Gothic"/>
+                <a:cs typeface="Century Gothic"/>
+              </a:defRPr>
+            </a:defPPr>
+          </a:lstStyle>
           <a:p xmlns:a="http://schemas.openxmlformats.org/drawingml/2006/main">
             <a:pPr algn="l">
-              <a:defRPr sz="1500" b="1">
+              <a:defRPr sz="1425" b="1">
                 <a:solidFill>
                   <a:srgbClr val="F6FAFD"/>
                 </a:solidFill>
@@ -1874,7 +3770,7 @@
               </a:defRPr>
             </a:pPr>
             <a:r>
-              <a:rPr sz="1500" b="1">
+              <a:rPr sz="1425" b="1">
                 <a:solidFill>
                   <a:srgbClr val="F6FAFD"/>
                 </a:solidFill>
@@ -1882,12 +3778,12 @@
                 <a:ea typeface="Century Gothic"/>
                 <a:cs typeface="Century Gothic"/>
               </a:rPr>
-              <a:t>29 қарашаға дейін</a:t>
+              <a:t>Толық 18 элемент үшін</a:t>
             </a:r>
           </a:p>
           <a:p xmlns:a="http://schemas.openxmlformats.org/drawingml/2006/main">
             <a:pPr algn="l">
-              <a:defRPr sz="1500" b="1">
+              <a:defRPr sz="1425" b="1">
                 <a:solidFill>
                   <a:srgbClr val="F6FAFD"/>
                 </a:solidFill>
@@ -1897,7 +3793,7 @@
               </a:defRPr>
             </a:pPr>
             <a:r>
-              <a:rPr sz="1500" b="1">
+              <a:rPr sz="1425" b="1">
                 <a:solidFill>
                   <a:srgbClr val="F6FAFD"/>
                 </a:solidFill>
@@ -1905,17 +3801,17 @@
                 <a:ea typeface="Century Gothic"/>
                 <a:cs typeface="Century Gothic"/>
               </a:rPr>
-              <a:t>аяқтау ықтималдығы</a:t>
+              <a:t>ұсынылатын мерзім</a:t>
             </a:r>
           </a:p>
         </p:txBody>
       </p:sp>
       <p:sp>
         <p:nvSpPr>
-          <p:cNvPr id="17" name="">
+          <p:cNvPr id="18" name="">
             <a:extLst xmlns:a="http://schemas.openxmlformats.org/drawingml/2006/main">
               <a:ext uri="{FF2B5EF4-FFF2-40B4-BE49-F238E27FC236}">
-                <a16:creationId xmlns:a16="http://schemas.microsoft.com/office/drawing/2014/main" id="{4A7A49F3-BE6F-435D-976B-9AB640DA55F2}"/>
+                <a16:creationId xmlns:a16="http://schemas.microsoft.com/office/drawing/2014/main" id="{1B186C80-EFDF-4BB5-88CD-5987AA7F1E6D}"/>
               </a:ext>
             </a:extLst>
           </p:cNvPr>
@@ -1926,7 +3822,7 @@
         </p:nvSpPr>
         <p:spPr>
           <a:xfrm xmlns:a="http://schemas.openxmlformats.org/drawingml/2006/main">
-            <a:off x="6515100" y="2419350"/>
+            <a:off x="6515100" y="2400300"/>
             <a:ext cx="3905250" cy="209550"/>
           </a:xfrm>
           <a:prstGeom xmlns:a="http://schemas.openxmlformats.org/drawingml/2006/main" prst="rect">
@@ -1941,7 +3837,18 @@
           <a:bodyPr xmlns:a="http://schemas.openxmlformats.org/drawingml/2006/main" anchor="ctr">
             <a:normAutofit fontScale="86111"/>
           </a:bodyPr>
-          <a:lstStyle xmlns:a="http://schemas.openxmlformats.org/drawingml/2006/main"/>
+          <a:lstStyle xmlns:a="http://schemas.openxmlformats.org/drawingml/2006/main">
+            <a:defPPr algn="l">
+              <a:defRPr sz="900" b="1">
+                <a:solidFill>
+                  <a:srgbClr val="9EADBD"/>
+                </a:solidFill>
+                <a:latin typeface="Century Gothic"/>
+                <a:ea typeface="Century Gothic"/>
+                <a:cs typeface="Century Gothic"/>
+              </a:defRPr>
+            </a:defPPr>
+          </a:lstStyle>
           <a:p xmlns:a="http://schemas.openxmlformats.org/drawingml/2006/main">
             <a:pPr algn="l">
               <a:defRPr sz="900" b="1">
@@ -1962,17 +3869,17 @@
                 <a:ea typeface="Century Gothic"/>
                 <a:cs typeface="Century Gothic"/>
               </a:rPr>
-              <a:t>МЕРЗІМДЕР ДИАПАЗОНЫ</a:t>
+              <a:t>АЯҚТАЛУ ЫҚТИМАЛДЫҒЫ</a:t>
             </a:r>
           </a:p>
         </p:txBody>
       </p:sp>
       <p:sp>
         <p:nvSpPr>
-          <p:cNvPr id="18" name="">
+          <p:cNvPr id="19" name="">
             <a:extLst xmlns:a="http://schemas.openxmlformats.org/drawingml/2006/main">
               <a:ext uri="{FF2B5EF4-FFF2-40B4-BE49-F238E27FC236}">
-                <a16:creationId xmlns:a16="http://schemas.microsoft.com/office/drawing/2014/main" id="{98D990B5-0A8A-410B-902F-2B87209DA79F}"/>
+                <a16:creationId xmlns:a16="http://schemas.microsoft.com/office/drawing/2014/main" id="{377C5C79-D031-4DC1-9BCB-B6589A8E4094}"/>
               </a:ext>
             </a:extLst>
           </p:cNvPr>
@@ -1983,8 +3890,8 @@
         </p:nvSpPr>
         <p:spPr>
           <a:xfrm xmlns:a="http://schemas.openxmlformats.org/drawingml/2006/main">
-            <a:off x="6858000" y="3333750"/>
-            <a:ext cx="4000500" cy="38100"/>
+            <a:off x="7000875" y="3257550"/>
+            <a:ext cx="3333750" cy="38100"/>
           </a:xfrm>
           <a:prstGeom xmlns:a="http://schemas.openxmlformats.org/drawingml/2006/main" prst="roundRect">
             <a:avLst>
@@ -2001,10 +3908,10 @@
       </p:sp>
       <p:sp>
         <p:nvSpPr>
-          <p:cNvPr id="19" name="">
+          <p:cNvPr id="20" name="">
             <a:extLst xmlns:a="http://schemas.openxmlformats.org/drawingml/2006/main">
               <a:ext uri="{FF2B5EF4-FFF2-40B4-BE49-F238E27FC236}">
-                <a16:creationId xmlns:a16="http://schemas.microsoft.com/office/drawing/2014/main" id="{19F1CFAC-A955-40DF-8AEE-D38914347F2E}"/>
+                <a16:creationId xmlns:a16="http://schemas.microsoft.com/office/drawing/2014/main" id="{012521AF-4F91-40AB-9AA3-22AE8AF3F8A0}"/>
               </a:ext>
             </a:extLst>
           </p:cNvPr>
@@ -2015,8 +3922,8 @@
         </p:nvSpPr>
         <p:spPr>
           <a:xfrm xmlns:a="http://schemas.openxmlformats.org/drawingml/2006/main">
-            <a:off x="6791325" y="2895600"/>
-            <a:ext cx="742950" cy="228600"/>
+            <a:off x="6819900" y="2781300"/>
+            <a:ext cx="933450" cy="247650"/>
           </a:xfrm>
           <a:prstGeom xmlns:a="http://schemas.openxmlformats.org/drawingml/2006/main" prst="rect">
             <a:avLst/>
@@ -2028,12 +3935,23 @@
         </p:spPr>
         <p:txBody>
           <a:bodyPr xmlns:a="http://schemas.openxmlformats.org/drawingml/2006/main" anchor="ctr">
-            <a:normAutofit fontScale="92308"/>
+            <a:normAutofit fontScale="85417"/>
           </a:bodyPr>
-          <a:lstStyle xmlns:a="http://schemas.openxmlformats.org/drawingml/2006/main"/>
+          <a:lstStyle xmlns:a="http://schemas.openxmlformats.org/drawingml/2006/main">
+            <a:defPPr algn="ctr">
+              <a:defRPr sz="1200" b="1">
+                <a:solidFill>
+                  <a:srgbClr val="41B5E6"/>
+                </a:solidFill>
+                <a:latin typeface="Century Gothic"/>
+                <a:ea typeface="Century Gothic"/>
+                <a:cs typeface="Century Gothic"/>
+              </a:defRPr>
+            </a:defPPr>
+          </a:lstStyle>
           <a:p xmlns:a="http://schemas.openxmlformats.org/drawingml/2006/main">
             <a:pPr algn="ctr">
-              <a:defRPr sz="975" b="1">
+              <a:defRPr sz="1200" b="1">
                 <a:solidFill>
                   <a:srgbClr val="41B5E6"/>
                 </a:solidFill>
@@ -2043,7 +3961,7 @@
               </a:defRPr>
             </a:pPr>
             <a:r>
-              <a:rPr sz="975" b="1">
+              <a:rPr sz="1200" b="1">
                 <a:solidFill>
                   <a:srgbClr val="41B5E6"/>
                 </a:solidFill>
@@ -2051,17 +3969,17 @@
                 <a:ea typeface="Century Gothic"/>
                 <a:cs typeface="Century Gothic"/>
               </a:rPr>
-              <a:t>P50</a:t>
+              <a:t>50%</a:t>
             </a:r>
           </a:p>
         </p:txBody>
       </p:sp>
       <p:sp>
         <p:nvSpPr>
-          <p:cNvPr id="20" name="">
+          <p:cNvPr id="21" name="">
             <a:extLst xmlns:a="http://schemas.openxmlformats.org/drawingml/2006/main">
               <a:ext uri="{FF2B5EF4-FFF2-40B4-BE49-F238E27FC236}">
-                <a16:creationId xmlns:a16="http://schemas.microsoft.com/office/drawing/2014/main" id="{36293155-6606-4402-8A78-CA9B1315D87D}"/>
+                <a16:creationId xmlns:a16="http://schemas.microsoft.com/office/drawing/2014/main" id="{32F9E95E-D50A-43E4-AF7E-91A66042A8C3}"/>
               </a:ext>
             </a:extLst>
           </p:cNvPr>
@@ -2072,8 +3990,8 @@
         </p:nvSpPr>
         <p:spPr>
           <a:xfrm xmlns:a="http://schemas.openxmlformats.org/drawingml/2006/main">
-            <a:off x="7000875" y="3209925"/>
-            <a:ext cx="285750" cy="285750"/>
+            <a:off x="7143750" y="3124200"/>
+            <a:ext cx="304800" cy="304800"/>
           </a:xfrm>
           <a:prstGeom xmlns:a="http://schemas.openxmlformats.org/drawingml/2006/main" prst="ellipse">
             <a:avLst/>
@@ -2088,10 +4006,10 @@
       </p:sp>
       <p:sp>
         <p:nvSpPr>
-          <p:cNvPr id="21" name="">
+          <p:cNvPr id="22" name="">
             <a:extLst xmlns:a="http://schemas.openxmlformats.org/drawingml/2006/main">
               <a:ext uri="{FF2B5EF4-FFF2-40B4-BE49-F238E27FC236}">
-                <a16:creationId xmlns:a16="http://schemas.microsoft.com/office/drawing/2014/main" id="{BFC9B650-34A8-4315-8A25-F3F833123B3A}"/>
+                <a16:creationId xmlns:a16="http://schemas.microsoft.com/office/drawing/2014/main" id="{6B58A0AF-2935-4A2D-9D13-A9E3BF0C9221}"/>
               </a:ext>
             </a:extLst>
           </p:cNvPr>
@@ -2102,8 +4020,8 @@
         </p:nvSpPr>
         <p:spPr>
           <a:xfrm xmlns:a="http://schemas.openxmlformats.org/drawingml/2006/main">
-            <a:off x="6762750" y="3638550"/>
-            <a:ext cx="781050" cy="228600"/>
+            <a:off x="6858000" y="3562350"/>
+            <a:ext cx="876300" cy="228600"/>
           </a:xfrm>
           <a:prstGeom xmlns:a="http://schemas.openxmlformats.org/drawingml/2006/main" prst="rect">
             <a:avLst/>
@@ -2115,12 +4033,23 @@
         </p:spPr>
         <p:txBody>
           <a:bodyPr xmlns:a="http://schemas.openxmlformats.org/drawingml/2006/main" anchor="ctr">
-            <a:normAutofit fontScale="92308"/>
+            <a:normAutofit fontScale="85714"/>
           </a:bodyPr>
-          <a:lstStyle xmlns:a="http://schemas.openxmlformats.org/drawingml/2006/main"/>
+          <a:lstStyle xmlns:a="http://schemas.openxmlformats.org/drawingml/2006/main">
+            <a:defPPr algn="ctr">
+              <a:defRPr sz="1050" b="1">
+                <a:solidFill>
+                  <a:srgbClr val="F6FAFD"/>
+                </a:solidFill>
+                <a:latin typeface="Century Gothic"/>
+                <a:ea typeface="Century Gothic"/>
+                <a:cs typeface="Century Gothic"/>
+              </a:defRPr>
+            </a:defPPr>
+          </a:lstStyle>
           <a:p xmlns:a="http://schemas.openxmlformats.org/drawingml/2006/main">
             <a:pPr algn="ctr">
-              <a:defRPr sz="975" b="1">
+              <a:defRPr sz="1050" b="1">
                 <a:solidFill>
                   <a:srgbClr val="F6FAFD"/>
                 </a:solidFill>
@@ -2130,7 +4059,7 @@
               </a:defRPr>
             </a:pPr>
             <a:r>
-              <a:rPr sz="975" b="1">
+              <a:rPr sz="1050" b="1">
                 <a:solidFill>
                   <a:srgbClr val="F6FAFD"/>
                 </a:solidFill>
@@ -2138,17 +4067,17 @@
                 <a:ea typeface="Century Gothic"/>
                 <a:cs typeface="Century Gothic"/>
               </a:rPr>
-              <a:t>15.11</a:t>
+              <a:t>12.11</a:t>
             </a:r>
           </a:p>
         </p:txBody>
       </p:sp>
       <p:sp>
         <p:nvSpPr>
-          <p:cNvPr id="22" name="">
+          <p:cNvPr id="23" name="">
             <a:extLst xmlns:a="http://schemas.openxmlformats.org/drawingml/2006/main">
               <a:ext uri="{FF2B5EF4-FFF2-40B4-BE49-F238E27FC236}">
-                <a16:creationId xmlns:a16="http://schemas.microsoft.com/office/drawing/2014/main" id="{3FD87748-99F4-43FC-B479-D7C17E726316}"/>
+                <a16:creationId xmlns:a16="http://schemas.microsoft.com/office/drawing/2014/main" id="{CBF17268-471F-4F72-A137-6500F9763455}"/>
               </a:ext>
             </a:extLst>
           </p:cNvPr>
@@ -2159,8 +4088,8 @@
         </p:nvSpPr>
         <p:spPr>
           <a:xfrm xmlns:a="http://schemas.openxmlformats.org/drawingml/2006/main">
-            <a:off x="7981950" y="2895600"/>
-            <a:ext cx="742950" cy="228600"/>
+            <a:off x="9725025" y="2781300"/>
+            <a:ext cx="933450" cy="247650"/>
           </a:xfrm>
           <a:prstGeom xmlns:a="http://schemas.openxmlformats.org/drawingml/2006/main" prst="rect">
             <a:avLst/>
@@ -2172,14 +4101,25 @@
         </p:spPr>
         <p:txBody>
           <a:bodyPr xmlns:a="http://schemas.openxmlformats.org/drawingml/2006/main" anchor="ctr">
-            <a:normAutofit fontScale="92308"/>
+            <a:normAutofit fontScale="85417"/>
           </a:bodyPr>
-          <a:lstStyle xmlns:a="http://schemas.openxmlformats.org/drawingml/2006/main"/>
+          <a:lstStyle xmlns:a="http://schemas.openxmlformats.org/drawingml/2006/main">
+            <a:defPPr algn="ctr">
+              <a:defRPr sz="1200" b="1">
+                <a:solidFill>
+                  <a:srgbClr val="FF6B36"/>
+                </a:solidFill>
+                <a:latin typeface="Century Gothic"/>
+                <a:ea typeface="Century Gothic"/>
+                <a:cs typeface="Century Gothic"/>
+              </a:defRPr>
+            </a:defPPr>
+          </a:lstStyle>
           <a:p xmlns:a="http://schemas.openxmlformats.org/drawingml/2006/main">
             <a:pPr algn="ctr">
-              <a:defRPr sz="975" b="1">
-                <a:solidFill>
-                  <a:srgbClr val="41B5E6"/>
+              <a:defRPr sz="1200" b="1">
+                <a:solidFill>
+                  <a:srgbClr val="FF6B36"/>
                 </a:solidFill>
                 <a:latin typeface="Century Gothic"/>
                 <a:ea typeface="Century Gothic"/>
@@ -2187,25 +4127,25 @@
               </a:defRPr>
             </a:pPr>
             <a:r>
-              <a:rPr sz="975" b="1">
-                <a:solidFill>
-                  <a:srgbClr val="41B5E6"/>
+              <a:rPr sz="1200" b="1">
+                <a:solidFill>
+                  <a:srgbClr val="FF6B36"/>
                 </a:solidFill>
                 <a:latin typeface="Century Gothic"/>
                 <a:ea typeface="Century Gothic"/>
                 <a:cs typeface="Century Gothic"/>
               </a:rPr>
-              <a:t>P70</a:t>
+              <a:t>85%</a:t>
             </a:r>
           </a:p>
         </p:txBody>
       </p:sp>
       <p:sp>
         <p:nvSpPr>
-          <p:cNvPr id="23" name="">
+          <p:cNvPr id="24" name="">
             <a:extLst xmlns:a="http://schemas.openxmlformats.org/drawingml/2006/main">
               <a:ext uri="{FF2B5EF4-FFF2-40B4-BE49-F238E27FC236}">
-                <a16:creationId xmlns:a16="http://schemas.microsoft.com/office/drawing/2014/main" id="{BAD4FC55-47FF-40B8-B91E-CF01CB97BE5C}"/>
+                <a16:creationId xmlns:a16="http://schemas.microsoft.com/office/drawing/2014/main" id="{204DC422-7670-4A30-A363-5443EE8D0D05}"/>
               </a:ext>
             </a:extLst>
           </p:cNvPr>
@@ -2216,14 +4156,14 @@
         </p:nvSpPr>
         <p:spPr>
           <a:xfrm xmlns:a="http://schemas.openxmlformats.org/drawingml/2006/main">
-            <a:off x="8191500" y="3209925"/>
-            <a:ext cx="285750" cy="285750"/>
+            <a:off x="10048875" y="3124200"/>
+            <a:ext cx="304800" cy="304800"/>
           </a:xfrm>
           <a:prstGeom xmlns:a="http://schemas.openxmlformats.org/drawingml/2006/main" prst="ellipse">
             <a:avLst/>
           </a:prstGeom>
           <a:solidFill xmlns:a="http://schemas.openxmlformats.org/drawingml/2006/main">
-            <a:srgbClr val="41B5E6"/>
+            <a:srgbClr val="FF6B36"/>
           </a:solidFill>
           <a:ln xmlns:a="http://schemas.openxmlformats.org/drawingml/2006/main" w="0">
             <a:noFill/>
@@ -2232,10 +4172,10 @@
       </p:sp>
       <p:sp>
         <p:nvSpPr>
-          <p:cNvPr id="24" name="">
+          <p:cNvPr id="25" name="">
             <a:extLst xmlns:a="http://schemas.openxmlformats.org/drawingml/2006/main">
               <a:ext uri="{FF2B5EF4-FFF2-40B4-BE49-F238E27FC236}">
-                <a16:creationId xmlns:a16="http://schemas.microsoft.com/office/drawing/2014/main" id="{4F6E131D-C8C3-4450-9DF4-069D421DF85E}"/>
+                <a16:creationId xmlns:a16="http://schemas.microsoft.com/office/drawing/2014/main" id="{EB1C45B8-B57A-471F-8D88-D79CF55A5BE3}"/>
               </a:ext>
             </a:extLst>
           </p:cNvPr>
@@ -2246,8 +4186,8 @@
         </p:nvSpPr>
         <p:spPr>
           <a:xfrm xmlns:a="http://schemas.openxmlformats.org/drawingml/2006/main">
-            <a:off x="7953375" y="3638550"/>
-            <a:ext cx="781050" cy="228600"/>
+            <a:off x="9763125" y="3562350"/>
+            <a:ext cx="876300" cy="228600"/>
           </a:xfrm>
           <a:prstGeom xmlns:a="http://schemas.openxmlformats.org/drawingml/2006/main" prst="rect">
             <a:avLst/>
@@ -2259,12 +4199,23 @@
         </p:spPr>
         <p:txBody>
           <a:bodyPr xmlns:a="http://schemas.openxmlformats.org/drawingml/2006/main" anchor="ctr">
-            <a:normAutofit fontScale="92308"/>
+            <a:normAutofit fontScale="85714"/>
           </a:bodyPr>
-          <a:lstStyle xmlns:a="http://schemas.openxmlformats.org/drawingml/2006/main"/>
+          <a:lstStyle xmlns:a="http://schemas.openxmlformats.org/drawingml/2006/main">
+            <a:defPPr algn="ctr">
+              <a:defRPr sz="1050" b="1">
+                <a:solidFill>
+                  <a:srgbClr val="F6FAFD"/>
+                </a:solidFill>
+                <a:latin typeface="Century Gothic"/>
+                <a:ea typeface="Century Gothic"/>
+                <a:cs typeface="Century Gothic"/>
+              </a:defRPr>
+            </a:defPPr>
+          </a:lstStyle>
           <a:p xmlns:a="http://schemas.openxmlformats.org/drawingml/2006/main">
             <a:pPr algn="ctr">
-              <a:defRPr sz="975" b="1">
+              <a:defRPr sz="1050" b="1">
                 <a:solidFill>
                   <a:srgbClr val="F6FAFD"/>
                 </a:solidFill>
@@ -2274,7 +4225,7 @@
               </a:defRPr>
             </a:pPr>
             <a:r>
-              <a:rPr sz="975" b="1">
+              <a:rPr sz="1050" b="1">
                 <a:solidFill>
                   <a:srgbClr val="F6FAFD"/>
                 </a:solidFill>
@@ -2282,17 +4233,17 @@
                 <a:ea typeface="Century Gothic"/>
                 <a:cs typeface="Century Gothic"/>
               </a:rPr>
-              <a:t>22.11</a:t>
+              <a:t>26.11</a:t>
             </a:r>
           </a:p>
         </p:txBody>
       </p:sp>
       <p:sp>
         <p:nvSpPr>
-          <p:cNvPr id="25" name="">
+          <p:cNvPr id="26" name="">
             <a:extLst xmlns:a="http://schemas.openxmlformats.org/drawingml/2006/main">
               <a:ext uri="{FF2B5EF4-FFF2-40B4-BE49-F238E27FC236}">
-                <a16:creationId xmlns:a16="http://schemas.microsoft.com/office/drawing/2014/main" id="{7AAF9638-CC31-44F9-B547-9748E20BC97A}"/>
+                <a16:creationId xmlns:a16="http://schemas.microsoft.com/office/drawing/2014/main" id="{98AD89E8-A522-44F8-9EAF-1A759EAC457E}"/>
               </a:ext>
             </a:extLst>
           </p:cNvPr>
@@ -2303,8 +4254,40 @@
         </p:nvSpPr>
         <p:spPr>
           <a:xfrm xmlns:a="http://schemas.openxmlformats.org/drawingml/2006/main">
-            <a:off x="9172575" y="2895600"/>
-            <a:ext cx="742950" cy="228600"/>
+            <a:off x="6515100" y="4057650"/>
+            <a:ext cx="4229100" cy="19050"/>
+          </a:xfrm>
+          <a:prstGeom xmlns:a="http://schemas.openxmlformats.org/drawingml/2006/main" prst="roundRect">
+            <a:avLst>
+              <a:gd name="adj" fmla="val 50000"/>
+            </a:avLst>
+          </a:prstGeom>
+          <a:solidFill xmlns:a="http://schemas.openxmlformats.org/drawingml/2006/main">
+            <a:srgbClr val="29445D"/>
+          </a:solidFill>
+          <a:ln xmlns:a="http://schemas.openxmlformats.org/drawingml/2006/main" w="0">
+            <a:noFill/>
+          </a:ln>
+        </p:spPr>
+      </p:sp>
+      <p:sp>
+        <p:nvSpPr>
+          <p:cNvPr id="27" name="">
+            <a:extLst xmlns:a="http://schemas.openxmlformats.org/drawingml/2006/main">
+              <a:ext uri="{FF2B5EF4-FFF2-40B4-BE49-F238E27FC236}">
+                <a16:creationId xmlns:a16="http://schemas.microsoft.com/office/drawing/2014/main" id="{2D327990-9EAC-4120-A59E-7E36E1C7B24B}"/>
+              </a:ext>
+            </a:extLst>
+          </p:cNvPr>
+          <p:cNvSpPr>
+            <a:spLocks xmlns:a="http://schemas.openxmlformats.org/drawingml/2006/main" noGrp="1"/>
+          </p:cNvSpPr>
+          <p:nvPr/>
+        </p:nvSpPr>
+        <p:spPr>
+          <a:xfrm xmlns:a="http://schemas.openxmlformats.org/drawingml/2006/main">
+            <a:off x="6515100" y="4276725"/>
+            <a:ext cx="3714750" cy="266700"/>
           </a:xfrm>
           <a:prstGeom xmlns:a="http://schemas.openxmlformats.org/drawingml/2006/main" prst="rect">
             <a:avLst/>
@@ -2316,14 +4299,25 @@
         </p:spPr>
         <p:txBody>
           <a:bodyPr xmlns:a="http://schemas.openxmlformats.org/drawingml/2006/main" anchor="ctr">
-            <a:normAutofit fontScale="92308"/>
+            <a:normAutofit fontScale="76667"/>
           </a:bodyPr>
-          <a:lstStyle xmlns:a="http://schemas.openxmlformats.org/drawingml/2006/main"/>
+          <a:lstStyle xmlns:a="http://schemas.openxmlformats.org/drawingml/2006/main">
+            <a:defPPr algn="l">
+              <a:defRPr sz="1500" b="1">
+                <a:solidFill>
+                  <a:srgbClr val="61D2A4"/>
+                </a:solidFill>
+                <a:latin typeface="Century Gothic"/>
+                <a:ea typeface="Century Gothic"/>
+                <a:cs typeface="Century Gothic"/>
+              </a:defRPr>
+            </a:defPPr>
+          </a:lstStyle>
           <a:p xmlns:a="http://schemas.openxmlformats.org/drawingml/2006/main">
-            <a:pPr algn="ctr">
-              <a:defRPr sz="975" b="1">
-                <a:solidFill>
-                  <a:srgbClr val="FF6B36"/>
+            <a:pPr algn="l">
+              <a:defRPr sz="1500" b="1">
+                <a:solidFill>
+                  <a:srgbClr val="61D2A4"/>
                 </a:solidFill>
                 <a:latin typeface="Century Gothic"/>
                 <a:ea typeface="Century Gothic"/>
@@ -2331,25 +4325,25 @@
               </a:defRPr>
             </a:pPr>
             <a:r>
-              <a:rPr sz="975" b="1">
-                <a:solidFill>
-                  <a:srgbClr val="FF6B36"/>
+              <a:rPr sz="1500" b="1">
+                <a:solidFill>
+                  <a:srgbClr val="61D2A4"/>
                 </a:solidFill>
                 <a:latin typeface="Century Gothic"/>
                 <a:ea typeface="Century Gothic"/>
                 <a:cs typeface="Century Gothic"/>
               </a:rPr>
-              <a:t>P85</a:t>
+              <a:t>Егер 19.11 міндетті болса</a:t>
             </a:r>
           </a:p>
         </p:txBody>
       </p:sp>
       <p:sp>
         <p:nvSpPr>
-          <p:cNvPr id="26" name="">
+          <p:cNvPr id="28" name="">
             <a:extLst xmlns:a="http://schemas.openxmlformats.org/drawingml/2006/main">
               <a:ext uri="{FF2B5EF4-FFF2-40B4-BE49-F238E27FC236}">
-                <a16:creationId xmlns:a16="http://schemas.microsoft.com/office/drawing/2014/main" id="{DF555139-CA68-476C-B69D-A81C4D35C1F8}"/>
+                <a16:creationId xmlns:a16="http://schemas.microsoft.com/office/drawing/2014/main" id="{00D9FD57-D469-4D11-BF03-34B59FBCFDAB}"/>
               </a:ext>
             </a:extLst>
           </p:cNvPr>
@@ -2360,296 +4354,8 @@
         </p:nvSpPr>
         <p:spPr>
           <a:xfrm xmlns:a="http://schemas.openxmlformats.org/drawingml/2006/main">
-            <a:off x="9382125" y="3209925"/>
-            <a:ext cx="285750" cy="285750"/>
-          </a:xfrm>
-          <a:prstGeom xmlns:a="http://schemas.openxmlformats.org/drawingml/2006/main" prst="ellipse">
-            <a:avLst/>
-          </a:prstGeom>
-          <a:solidFill xmlns:a="http://schemas.openxmlformats.org/drawingml/2006/main">
-            <a:srgbClr val="FF6B36"/>
-          </a:solidFill>
-          <a:ln xmlns:a="http://schemas.openxmlformats.org/drawingml/2006/main" w="0">
-            <a:noFill/>
-          </a:ln>
-        </p:spPr>
-      </p:sp>
-      <p:sp>
-        <p:nvSpPr>
-          <p:cNvPr id="27" name="">
-            <a:extLst xmlns:a="http://schemas.openxmlformats.org/drawingml/2006/main">
-              <a:ext uri="{FF2B5EF4-FFF2-40B4-BE49-F238E27FC236}">
-                <a16:creationId xmlns:a16="http://schemas.microsoft.com/office/drawing/2014/main" id="{226F346A-4585-49DF-9B36-966DC528C24C}"/>
-              </a:ext>
-            </a:extLst>
-          </p:cNvPr>
-          <p:cNvSpPr>
-            <a:spLocks xmlns:a="http://schemas.openxmlformats.org/drawingml/2006/main" noGrp="1"/>
-          </p:cNvSpPr>
-          <p:nvPr/>
-        </p:nvSpPr>
-        <p:spPr>
-          <a:xfrm xmlns:a="http://schemas.openxmlformats.org/drawingml/2006/main">
-            <a:off x="9144000" y="3638550"/>
-            <a:ext cx="781050" cy="228600"/>
-          </a:xfrm>
-          <a:prstGeom xmlns:a="http://schemas.openxmlformats.org/drawingml/2006/main" prst="rect">
-            <a:avLst/>
-          </a:prstGeom>
-          <a:noFill xmlns:a="http://schemas.openxmlformats.org/drawingml/2006/main"/>
-          <a:ln xmlns:a="http://schemas.openxmlformats.org/drawingml/2006/main" w="0">
-            <a:noFill/>
-          </a:ln>
-        </p:spPr>
-        <p:txBody>
-          <a:bodyPr xmlns:a="http://schemas.openxmlformats.org/drawingml/2006/main" anchor="ctr">
-            <a:normAutofit fontScale="92308"/>
-          </a:bodyPr>
-          <a:lstStyle xmlns:a="http://schemas.openxmlformats.org/drawingml/2006/main"/>
-          <a:p xmlns:a="http://schemas.openxmlformats.org/drawingml/2006/main">
-            <a:pPr algn="ctr">
-              <a:defRPr sz="975" b="1">
-                <a:solidFill>
-                  <a:srgbClr val="F6FAFD"/>
-                </a:solidFill>
-                <a:latin typeface="Century Gothic"/>
-                <a:ea typeface="Century Gothic"/>
-                <a:cs typeface="Century Gothic"/>
-              </a:defRPr>
-            </a:pPr>
-            <a:r>
-              <a:rPr sz="975" b="1">
-                <a:solidFill>
-                  <a:srgbClr val="F6FAFD"/>
-                </a:solidFill>
-                <a:latin typeface="Century Gothic"/>
-                <a:ea typeface="Century Gothic"/>
-                <a:cs typeface="Century Gothic"/>
-              </a:rPr>
-              <a:t>29.11</a:t>
-            </a:r>
-          </a:p>
-        </p:txBody>
-      </p:sp>
-      <p:sp>
-        <p:nvSpPr>
-          <p:cNvPr id="28" name="">
-            <a:extLst xmlns:a="http://schemas.openxmlformats.org/drawingml/2006/main">
-              <a:ext uri="{FF2B5EF4-FFF2-40B4-BE49-F238E27FC236}">
-                <a16:creationId xmlns:a16="http://schemas.microsoft.com/office/drawing/2014/main" id="{D348C09B-BAE4-49DB-AC93-70C06F684408}"/>
-              </a:ext>
-            </a:extLst>
-          </p:cNvPr>
-          <p:cNvSpPr>
-            <a:spLocks xmlns:a="http://schemas.openxmlformats.org/drawingml/2006/main" noGrp="1"/>
-          </p:cNvSpPr>
-          <p:nvPr/>
-        </p:nvSpPr>
-        <p:spPr>
-          <a:xfrm xmlns:a="http://schemas.openxmlformats.org/drawingml/2006/main">
-            <a:off x="10363200" y="2895600"/>
-            <a:ext cx="742950" cy="228600"/>
-          </a:xfrm>
-          <a:prstGeom xmlns:a="http://schemas.openxmlformats.org/drawingml/2006/main" prst="rect">
-            <a:avLst/>
-          </a:prstGeom>
-          <a:noFill xmlns:a="http://schemas.openxmlformats.org/drawingml/2006/main"/>
-          <a:ln xmlns:a="http://schemas.openxmlformats.org/drawingml/2006/main" w="0">
-            <a:noFill/>
-          </a:ln>
-        </p:spPr>
-        <p:txBody>
-          <a:bodyPr xmlns:a="http://schemas.openxmlformats.org/drawingml/2006/main" anchor="ctr">
-            <a:normAutofit fontScale="92308"/>
-          </a:bodyPr>
-          <a:lstStyle xmlns:a="http://schemas.openxmlformats.org/drawingml/2006/main"/>
-          <a:p xmlns:a="http://schemas.openxmlformats.org/drawingml/2006/main">
-            <a:pPr algn="ctr">
-              <a:defRPr sz="975" b="1">
-                <a:solidFill>
-                  <a:srgbClr val="61D2A4"/>
-                </a:solidFill>
-                <a:latin typeface="Century Gothic"/>
-                <a:ea typeface="Century Gothic"/>
-                <a:cs typeface="Century Gothic"/>
-              </a:defRPr>
-            </a:pPr>
-            <a:r>
-              <a:rPr sz="975" b="1">
-                <a:solidFill>
-                  <a:srgbClr val="61D2A4"/>
-                </a:solidFill>
-                <a:latin typeface="Century Gothic"/>
-                <a:ea typeface="Century Gothic"/>
-                <a:cs typeface="Century Gothic"/>
-              </a:rPr>
-              <a:t>P95</a:t>
-            </a:r>
-          </a:p>
-        </p:txBody>
-      </p:sp>
-      <p:sp>
-        <p:nvSpPr>
-          <p:cNvPr id="29" name="">
-            <a:extLst xmlns:a="http://schemas.openxmlformats.org/drawingml/2006/main">
-              <a:ext uri="{FF2B5EF4-FFF2-40B4-BE49-F238E27FC236}">
-                <a16:creationId xmlns:a16="http://schemas.microsoft.com/office/drawing/2014/main" id="{E510AFAA-C716-4E62-9138-4AA70C7FEA0D}"/>
-              </a:ext>
-            </a:extLst>
-          </p:cNvPr>
-          <p:cNvSpPr>
-            <a:spLocks xmlns:a="http://schemas.openxmlformats.org/drawingml/2006/main" noGrp="1"/>
-          </p:cNvSpPr>
-          <p:nvPr/>
-        </p:nvSpPr>
-        <p:spPr>
-          <a:xfrm xmlns:a="http://schemas.openxmlformats.org/drawingml/2006/main">
-            <a:off x="10572750" y="3209925"/>
-            <a:ext cx="285750" cy="285750"/>
-          </a:xfrm>
-          <a:prstGeom xmlns:a="http://schemas.openxmlformats.org/drawingml/2006/main" prst="ellipse">
-            <a:avLst/>
-          </a:prstGeom>
-          <a:solidFill xmlns:a="http://schemas.openxmlformats.org/drawingml/2006/main">
-            <a:srgbClr val="61D2A4"/>
-          </a:solidFill>
-          <a:ln xmlns:a="http://schemas.openxmlformats.org/drawingml/2006/main" w="0">
-            <a:noFill/>
-          </a:ln>
-        </p:spPr>
-      </p:sp>
-      <p:sp>
-        <p:nvSpPr>
-          <p:cNvPr id="30" name="">
-            <a:extLst xmlns:a="http://schemas.openxmlformats.org/drawingml/2006/main">
-              <a:ext uri="{FF2B5EF4-FFF2-40B4-BE49-F238E27FC236}">
-                <a16:creationId xmlns:a16="http://schemas.microsoft.com/office/drawing/2014/main" id="{304FF460-E197-455A-B228-DBBAFC1B643C}"/>
-              </a:ext>
-            </a:extLst>
-          </p:cNvPr>
-          <p:cNvSpPr>
-            <a:spLocks xmlns:a="http://schemas.openxmlformats.org/drawingml/2006/main" noGrp="1"/>
-          </p:cNvSpPr>
-          <p:nvPr/>
-        </p:nvSpPr>
-        <p:spPr>
-          <a:xfrm xmlns:a="http://schemas.openxmlformats.org/drawingml/2006/main">
-            <a:off x="10334625" y="3638550"/>
-            <a:ext cx="781050" cy="228600"/>
-          </a:xfrm>
-          <a:prstGeom xmlns:a="http://schemas.openxmlformats.org/drawingml/2006/main" prst="rect">
-            <a:avLst/>
-          </a:prstGeom>
-          <a:noFill xmlns:a="http://schemas.openxmlformats.org/drawingml/2006/main"/>
-          <a:ln xmlns:a="http://schemas.openxmlformats.org/drawingml/2006/main" w="0">
-            <a:noFill/>
-          </a:ln>
-        </p:spPr>
-        <p:txBody>
-          <a:bodyPr xmlns:a="http://schemas.openxmlformats.org/drawingml/2006/main" anchor="ctr">
-            <a:normAutofit fontScale="92308"/>
-          </a:bodyPr>
-          <a:lstStyle xmlns:a="http://schemas.openxmlformats.org/drawingml/2006/main"/>
-          <a:p xmlns:a="http://schemas.openxmlformats.org/drawingml/2006/main">
-            <a:pPr algn="ctr">
-              <a:defRPr sz="975" b="1">
-                <a:solidFill>
-                  <a:srgbClr val="F6FAFD"/>
-                </a:solidFill>
-                <a:latin typeface="Century Gothic"/>
-                <a:ea typeface="Century Gothic"/>
-                <a:cs typeface="Century Gothic"/>
-              </a:defRPr>
-            </a:pPr>
-            <a:r>
-              <a:rPr sz="975" b="1">
-                <a:solidFill>
-                  <a:srgbClr val="F6FAFD"/>
-                </a:solidFill>
-                <a:latin typeface="Century Gothic"/>
-                <a:ea typeface="Century Gothic"/>
-                <a:cs typeface="Century Gothic"/>
-              </a:rPr>
-              <a:t>13.12</a:t>
-            </a:r>
-          </a:p>
-        </p:txBody>
-      </p:sp>
-      <p:sp>
-        <p:nvSpPr>
-          <p:cNvPr id="31" name="">
-            <a:extLst xmlns:a="http://schemas.openxmlformats.org/drawingml/2006/main">
-              <a:ext uri="{FF2B5EF4-FFF2-40B4-BE49-F238E27FC236}">
-                <a16:creationId xmlns:a16="http://schemas.microsoft.com/office/drawing/2014/main" id="{2DC5E26E-1FB8-4F92-8FBD-6504181A8177}"/>
-              </a:ext>
-            </a:extLst>
-          </p:cNvPr>
-          <p:cNvSpPr>
-            <a:spLocks xmlns:a="http://schemas.openxmlformats.org/drawingml/2006/main" noGrp="1"/>
-          </p:cNvSpPr>
-          <p:nvPr/>
-        </p:nvSpPr>
-        <p:spPr>
-          <a:xfrm xmlns:a="http://schemas.openxmlformats.org/drawingml/2006/main">
-            <a:off x="6515100" y="4267200"/>
-            <a:ext cx="1143000" cy="323850"/>
-          </a:xfrm>
-          <a:prstGeom xmlns:a="http://schemas.openxmlformats.org/drawingml/2006/main" prst="rect">
-            <a:avLst/>
-          </a:prstGeom>
-          <a:noFill xmlns:a="http://schemas.openxmlformats.org/drawingml/2006/main"/>
-          <a:ln xmlns:a="http://schemas.openxmlformats.org/drawingml/2006/main" w="0">
-            <a:noFill/>
-          </a:ln>
-        </p:spPr>
-        <p:txBody>
-          <a:bodyPr xmlns:a="http://schemas.openxmlformats.org/drawingml/2006/main" anchor="ctr">
-            <a:normAutofit fontScale="84722"/>
-          </a:bodyPr>
-          <a:lstStyle xmlns:a="http://schemas.openxmlformats.org/drawingml/2006/main"/>
-          <a:p xmlns:a="http://schemas.openxmlformats.org/drawingml/2006/main">
-            <a:pPr algn="l">
-              <a:defRPr sz="1800" b="1">
-                <a:solidFill>
-                  <a:srgbClr val="41B5E6"/>
-                </a:solidFill>
-                <a:latin typeface="Century Gothic"/>
-                <a:ea typeface="Century Gothic"/>
-                <a:cs typeface="Century Gothic"/>
-              </a:defRPr>
-            </a:pPr>
-            <a:r>
-              <a:rPr sz="1800" b="1">
-                <a:solidFill>
-                  <a:srgbClr val="41B5E6"/>
-                </a:solidFill>
-                <a:latin typeface="Century Gothic"/>
-                <a:ea typeface="Century Gothic"/>
-                <a:cs typeface="Century Gothic"/>
-              </a:rPr>
-              <a:t>50%</a:t>
-            </a:r>
-          </a:p>
-        </p:txBody>
-      </p:sp>
-      <p:sp>
-        <p:nvSpPr>
-          <p:cNvPr id="32" name="">
-            <a:extLst xmlns:a="http://schemas.openxmlformats.org/drawingml/2006/main">
-              <a:ext uri="{FF2B5EF4-FFF2-40B4-BE49-F238E27FC236}">
-                <a16:creationId xmlns:a16="http://schemas.microsoft.com/office/drawing/2014/main" id="{B338EB80-442B-4281-87BC-1C0B11F9BC7E}"/>
-              </a:ext>
-            </a:extLst>
-          </p:cNvPr>
-          <p:cNvSpPr>
-            <a:spLocks xmlns:a="http://schemas.openxmlformats.org/drawingml/2006/main" noGrp="1"/>
-          </p:cNvSpPr>
-          <p:nvPr/>
-        </p:nvSpPr>
-        <p:spPr>
-          <a:xfrm xmlns:a="http://schemas.openxmlformats.org/drawingml/2006/main">
-            <a:off x="6515100" y="4619625"/>
-            <a:ext cx="1714500" cy="495300"/>
+            <a:off x="6515100" y="4648200"/>
+            <a:ext cx="4229100" cy="685800"/>
           </a:xfrm>
           <a:prstGeom xmlns:a="http://schemas.openxmlformats.org/drawingml/2006/main" prst="rect">
             <a:avLst/>
@@ -2663,12 +4369,23 @@
           <a:bodyPr xmlns:a="http://schemas.openxmlformats.org/drawingml/2006/main" anchor="ctr">
             <a:normAutofit fontScale="100000"/>
           </a:bodyPr>
-          <a:lstStyle xmlns:a="http://schemas.openxmlformats.org/drawingml/2006/main"/>
+          <a:lstStyle xmlns:a="http://schemas.openxmlformats.org/drawingml/2006/main">
+            <a:defPPr algn="l">
+              <a:defRPr sz="1125" b="0">
+                <a:solidFill>
+                  <a:srgbClr val="F6FAFD"/>
+                </a:solidFill>
+                <a:latin typeface="Century Gothic"/>
+                <a:ea typeface="Century Gothic"/>
+                <a:cs typeface="Century Gothic"/>
+              </a:defRPr>
+            </a:defPPr>
+          </a:lstStyle>
           <a:p xmlns:a="http://schemas.openxmlformats.org/drawingml/2006/main">
             <a:pPr algn="l">
-              <a:defRPr sz="975" b="0">
-                <a:solidFill>
-                  <a:srgbClr val="9EADBD"/>
+              <a:defRPr sz="1125" b="0">
+                <a:solidFill>
+                  <a:srgbClr val="F6FAFD"/>
                 </a:solidFill>
                 <a:latin typeface="Century Gothic"/>
                 <a:ea typeface="Century Gothic"/>
@@ -2676,217 +4393,25 @@
               </a:defRPr>
             </a:pPr>
             <a:r>
-              <a:rPr sz="975" b="0">
-                <a:solidFill>
-                  <a:srgbClr val="9EADBD"/>
+              <a:rPr sz="1125" b="0">
+                <a:solidFill>
+                  <a:srgbClr val="F6FAFD"/>
                 </a:solidFill>
                 <a:latin typeface="Century Gothic"/>
                 <a:ea typeface="Century Gothic"/>
                 <a:cs typeface="Century Gothic"/>
               </a:rPr>
-              <a:t>ең ықтимал орташа</a:t>
-            </a:r>
-          </a:p>
-          <a:p xmlns:a="http://schemas.openxmlformats.org/drawingml/2006/main">
-            <a:pPr algn="l">
-              <a:defRPr sz="975" b="0">
-                <a:solidFill>
-                  <a:srgbClr val="9EADBD"/>
-                </a:solidFill>
-                <a:latin typeface="Century Gothic"/>
-                <a:ea typeface="Century Gothic"/>
-                <a:cs typeface="Century Gothic"/>
-              </a:defRPr>
-            </a:pPr>
-            <a:r>
-              <a:rPr sz="975" b="0">
-                <a:solidFill>
-                  <a:srgbClr val="9EADBD"/>
-                </a:solidFill>
-                <a:latin typeface="Century Gothic"/>
-                <a:ea typeface="Century Gothic"/>
-                <a:cs typeface="Century Gothic"/>
-              </a:rPr>
-              <a:t>сценарий</a:t>
+              <a:t>US-13–US-16 келесі релизге ауысады. 14 элементті 19.11 дейін аяқтау ықтималдығы 85% болады.</a:t>
             </a:r>
           </a:p>
         </p:txBody>
       </p:sp>
       <p:sp>
         <p:nvSpPr>
-          <p:cNvPr id="33" name="">
+          <p:cNvPr id="29" name="">
             <a:extLst xmlns:a="http://schemas.openxmlformats.org/drawingml/2006/main">
               <a:ext uri="{FF2B5EF4-FFF2-40B4-BE49-F238E27FC236}">
-                <a16:creationId xmlns:a16="http://schemas.microsoft.com/office/drawing/2014/main" id="{ADB424B5-AB88-40FD-8F33-0A331A9DCEBF}"/>
-              </a:ext>
-            </a:extLst>
-          </p:cNvPr>
-          <p:cNvSpPr>
-            <a:spLocks xmlns:a="http://schemas.openxmlformats.org/drawingml/2006/main" noGrp="1"/>
-          </p:cNvSpPr>
-          <p:nvPr/>
-        </p:nvSpPr>
-        <p:spPr>
-          <a:xfrm xmlns:a="http://schemas.openxmlformats.org/drawingml/2006/main">
-            <a:off x="8505825" y="4267200"/>
-            <a:ext cx="19050" cy="838200"/>
-          </a:xfrm>
-          <a:prstGeom xmlns:a="http://schemas.openxmlformats.org/drawingml/2006/main" prst="roundRect">
-            <a:avLst>
-              <a:gd name="adj" fmla="val 50000"/>
-            </a:avLst>
-          </a:prstGeom>
-          <a:solidFill xmlns:a="http://schemas.openxmlformats.org/drawingml/2006/main">
-            <a:srgbClr val="29445D"/>
-          </a:solidFill>
-          <a:ln xmlns:a="http://schemas.openxmlformats.org/drawingml/2006/main" w="0">
-            <a:noFill/>
-          </a:ln>
-        </p:spPr>
-      </p:sp>
-      <p:sp>
-        <p:nvSpPr>
-          <p:cNvPr id="34" name="">
-            <a:extLst xmlns:a="http://schemas.openxmlformats.org/drawingml/2006/main">
-              <a:ext uri="{FF2B5EF4-FFF2-40B4-BE49-F238E27FC236}">
-                <a16:creationId xmlns:a16="http://schemas.microsoft.com/office/drawing/2014/main" id="{B59918B6-8021-4972-8AF8-1281E666CE82}"/>
-              </a:ext>
-            </a:extLst>
-          </p:cNvPr>
-          <p:cNvSpPr>
-            <a:spLocks xmlns:a="http://schemas.openxmlformats.org/drawingml/2006/main" noGrp="1"/>
-          </p:cNvSpPr>
-          <p:nvPr/>
-        </p:nvSpPr>
-        <p:spPr>
-          <a:xfrm xmlns:a="http://schemas.openxmlformats.org/drawingml/2006/main">
-            <a:off x="8801100" y="4267200"/>
-            <a:ext cx="1143000" cy="323850"/>
-          </a:xfrm>
-          <a:prstGeom xmlns:a="http://schemas.openxmlformats.org/drawingml/2006/main" prst="rect">
-            <a:avLst/>
-          </a:prstGeom>
-          <a:noFill xmlns:a="http://schemas.openxmlformats.org/drawingml/2006/main"/>
-          <a:ln xmlns:a="http://schemas.openxmlformats.org/drawingml/2006/main" w="0">
-            <a:noFill/>
-          </a:ln>
-        </p:spPr>
-        <p:txBody>
-          <a:bodyPr xmlns:a="http://schemas.openxmlformats.org/drawingml/2006/main" anchor="ctr">
-            <a:normAutofit fontScale="84722"/>
-          </a:bodyPr>
-          <a:lstStyle xmlns:a="http://schemas.openxmlformats.org/drawingml/2006/main"/>
-          <a:p xmlns:a="http://schemas.openxmlformats.org/drawingml/2006/main">
-            <a:pPr algn="l">
-              <a:defRPr sz="1800" b="1">
-                <a:solidFill>
-                  <a:srgbClr val="61D2A4"/>
-                </a:solidFill>
-                <a:latin typeface="Century Gothic"/>
-                <a:ea typeface="Century Gothic"/>
-                <a:cs typeface="Century Gothic"/>
-              </a:defRPr>
-            </a:pPr>
-            <a:r>
-              <a:rPr sz="1800" b="1">
-                <a:solidFill>
-                  <a:srgbClr val="61D2A4"/>
-                </a:solidFill>
-                <a:latin typeface="Century Gothic"/>
-                <a:ea typeface="Century Gothic"/>
-                <a:cs typeface="Century Gothic"/>
-              </a:rPr>
-              <a:t>95%</a:t>
-            </a:r>
-          </a:p>
-        </p:txBody>
-      </p:sp>
-      <p:sp>
-        <p:nvSpPr>
-          <p:cNvPr id="35" name="">
-            <a:extLst xmlns:a="http://schemas.openxmlformats.org/drawingml/2006/main">
-              <a:ext uri="{FF2B5EF4-FFF2-40B4-BE49-F238E27FC236}">
-                <a16:creationId xmlns:a16="http://schemas.microsoft.com/office/drawing/2014/main" id="{C975D328-3C5F-4BC8-9379-7522A98C5067}"/>
-              </a:ext>
-            </a:extLst>
-          </p:cNvPr>
-          <p:cNvSpPr>
-            <a:spLocks xmlns:a="http://schemas.openxmlformats.org/drawingml/2006/main" noGrp="1"/>
-          </p:cNvSpPr>
-          <p:nvPr/>
-        </p:nvSpPr>
-        <p:spPr>
-          <a:xfrm xmlns:a="http://schemas.openxmlformats.org/drawingml/2006/main">
-            <a:off x="8801100" y="4619625"/>
-            <a:ext cx="2000250" cy="495300"/>
-          </a:xfrm>
-          <a:prstGeom xmlns:a="http://schemas.openxmlformats.org/drawingml/2006/main" prst="rect">
-            <a:avLst/>
-          </a:prstGeom>
-          <a:noFill xmlns:a="http://schemas.openxmlformats.org/drawingml/2006/main"/>
-          <a:ln xmlns:a="http://schemas.openxmlformats.org/drawingml/2006/main" w="0">
-            <a:noFill/>
-          </a:ln>
-        </p:spPr>
-        <p:txBody>
-          <a:bodyPr xmlns:a="http://schemas.openxmlformats.org/drawingml/2006/main" anchor="ctr">
-            <a:normAutofit fontScale="100000"/>
-          </a:bodyPr>
-          <a:lstStyle xmlns:a="http://schemas.openxmlformats.org/drawingml/2006/main"/>
-          <a:p xmlns:a="http://schemas.openxmlformats.org/drawingml/2006/main">
-            <a:pPr algn="l">
-              <a:defRPr sz="975" b="0">
-                <a:solidFill>
-                  <a:srgbClr val="9EADBD"/>
-                </a:solidFill>
-                <a:latin typeface="Century Gothic"/>
-                <a:ea typeface="Century Gothic"/>
-                <a:cs typeface="Century Gothic"/>
-              </a:defRPr>
-            </a:pPr>
-            <a:r>
-              <a:rPr sz="975" b="0">
-                <a:solidFill>
-                  <a:srgbClr val="9EADBD"/>
-                </a:solidFill>
-                <a:latin typeface="Century Gothic"/>
-                <a:ea typeface="Century Gothic"/>
-                <a:cs typeface="Century Gothic"/>
-              </a:rPr>
-              <a:t>сақтық қоры жоғары</a:t>
-            </a:r>
-          </a:p>
-          <a:p xmlns:a="http://schemas.openxmlformats.org/drawingml/2006/main">
-            <a:pPr algn="l">
-              <a:defRPr sz="975" b="0">
-                <a:solidFill>
-                  <a:srgbClr val="9EADBD"/>
-                </a:solidFill>
-                <a:latin typeface="Century Gothic"/>
-                <a:ea typeface="Century Gothic"/>
-                <a:cs typeface="Century Gothic"/>
-              </a:defRPr>
-            </a:pPr>
-            <a:r>
-              <a:rPr sz="975" b="0">
-                <a:solidFill>
-                  <a:srgbClr val="9EADBD"/>
-                </a:solidFill>
-                <a:latin typeface="Century Gothic"/>
-                <a:ea typeface="Century Gothic"/>
-                <a:cs typeface="Century Gothic"/>
-              </a:rPr>
-              <a:t>сценарий</a:t>
-            </a:r>
-          </a:p>
-        </p:txBody>
-      </p:sp>
-      <p:sp>
-        <p:nvSpPr>
-          <p:cNvPr id="36" name="">
-            <a:extLst xmlns:a="http://schemas.openxmlformats.org/drawingml/2006/main">
-              <a:ext uri="{FF2B5EF4-FFF2-40B4-BE49-F238E27FC236}">
-                <a16:creationId xmlns:a16="http://schemas.microsoft.com/office/drawing/2014/main" id="{7A70E89C-2CF3-4774-A690-0DD1FD48BD79}"/>
+                <a16:creationId xmlns:a16="http://schemas.microsoft.com/office/drawing/2014/main" id="{08AAB199-B37E-4E76-8468-92ACF6FBAEE4}"/>
               </a:ext>
             </a:extLst>
           </p:cNvPr>
@@ -2912,7 +4437,18 @@
           <a:bodyPr xmlns:a="http://schemas.openxmlformats.org/drawingml/2006/main" anchor="ctr">
             <a:normAutofit fontScale="90000"/>
           </a:bodyPr>
-          <a:lstStyle xmlns:a="http://schemas.openxmlformats.org/drawingml/2006/main"/>
+          <a:lstStyle xmlns:a="http://schemas.openxmlformats.org/drawingml/2006/main">
+            <a:defPPr algn="l">
+              <a:defRPr sz="1125" b="1">
+                <a:solidFill>
+                  <a:srgbClr val="F6FAFD"/>
+                </a:solidFill>
+                <a:latin typeface="Century Gothic"/>
+                <a:ea typeface="Century Gothic"/>
+                <a:cs typeface="Century Gothic"/>
+              </a:defRPr>
+            </a:defPPr>
+          </a:lstStyle>
           <a:p xmlns:a="http://schemas.openxmlformats.org/drawingml/2006/main">
             <a:pPr algn="l">
               <a:defRPr sz="1125" b="1">
@@ -2933,17 +4469,17 @@
                 <a:ea typeface="Century Gothic"/>
                 <a:cs typeface="Century Gothic"/>
               </a:rPr>
-              <a:t>Жұмыс көлемі, сыртқы блоктаушылар немесе команда құрамының өзгеруі болжамды өзгертеді.</a:t>
+              <a:t>Көлем, команда немесе сыртқы блоктаушылар өзгерсе, болжам қайта есептеледі.</a:t>
             </a:r>
           </a:p>
         </p:txBody>
       </p:sp>
       <p:sp>
         <p:nvSpPr>
-          <p:cNvPr id="37" name="">
+          <p:cNvPr id="30" name="">
             <a:extLst xmlns:a="http://schemas.openxmlformats.org/drawingml/2006/main">
               <a:ext uri="{FF2B5EF4-FFF2-40B4-BE49-F238E27FC236}">
-                <a16:creationId xmlns:a16="http://schemas.microsoft.com/office/drawing/2014/main" id="{DB2CECF8-E90E-4045-9715-4DACCF3B243D}"/>
+                <a16:creationId xmlns:a16="http://schemas.microsoft.com/office/drawing/2014/main" id="{38D81C24-E0EA-449E-9593-1D086B4249F9}"/>
               </a:ext>
             </a:extLst>
           </p:cNvPr>
@@ -2955,7 +4491,7 @@
         <p:spPr>
           <a:xfrm xmlns:a="http://schemas.openxmlformats.org/drawingml/2006/main">
             <a:off x="419100" y="6419850"/>
-            <a:ext cx="6572250" cy="190500"/>
+            <a:ext cx="7620000" cy="190500"/>
           </a:xfrm>
           <a:prstGeom xmlns:a="http://schemas.openxmlformats.org/drawingml/2006/main" prst="rect">
             <a:avLst/>
@@ -2969,7 +4505,18 @@
           <a:bodyPr xmlns:a="http://schemas.openxmlformats.org/drawingml/2006/main" anchor="ctr">
             <a:normAutofit fontScale="86667"/>
           </a:bodyPr>
-          <a:lstStyle xmlns:a="http://schemas.openxmlformats.org/drawingml/2006/main"/>
+          <a:lstStyle xmlns:a="http://schemas.openxmlformats.org/drawingml/2006/main">
+            <a:defPPr algn="l">
+              <a:defRPr sz="750" b="0">
+                <a:solidFill>
+                  <a:srgbClr val="9EADBD"/>
+                </a:solidFill>
+                <a:latin typeface="Century Gothic"/>
+                <a:ea typeface="Century Gothic"/>
+                <a:cs typeface="Century Gothic"/>
+              </a:defRPr>
+            </a:defPPr>
+          </a:lstStyle>
           <a:p xmlns:a="http://schemas.openxmlformats.org/drawingml/2006/main">
             <a:pPr algn="l">
               <a:defRPr sz="750" b="0">
@@ -2990,7 +4537,7 @@
                 <a:ea typeface="Century Gothic"/>
                 <a:cs typeface="Century Gothic"/>
               </a:rPr>
-              <a:t>Дереккөз: Pallets Click · 106 жабылған тапсырма · 26 апта · сыртқы балама дерек</a:t>
+              <a:t>Дереккөз: Pallets Click  ·  106 issue  ·  26 апта  ·  қаралған күні 08.10.2026</a:t>
             </a:r>
           </a:p>
         </p:txBody>
@@ -2998,7 +4545,7 @@
     </p:spTree>
     <p:extLst>
       <p:ext uri="{BB962C8B-B14F-4D97-AF65-F5344CB8AC3E}">
-        <p14:creationId xmlns:p14="http://schemas.microsoft.com/office/powerpoint/2010/main" val="1270668123"/>
+        <p14:creationId xmlns:p14="http://schemas.microsoft.com/office/powerpoint/2010/main" val="1708251623"/>
       </p:ext>
     </p:extLst>
   </p:cSld>
@@ -3046,16 +4593,16 @@
         <a:srgbClr val="96607D"/>
       </a:folHlink>
     </a:clrScheme>
-    <a:fontScheme name="Office">
+    <a:fontScheme name="">
       <a:majorFont>
-        <a:latin typeface="Calibri Light"/>
-        <a:ea typeface="Calibri Light"/>
-        <a:cs typeface="Calibri Light"/>
+        <a:latin typeface="Aptos"/>
+        <a:ea typeface=""/>
+        <a:cs typeface=""/>
       </a:majorFont>
       <a:minorFont>
-        <a:latin typeface="Calibri"/>
-        <a:ea typeface="Calibri"/>
-        <a:cs typeface="Calibri"/>
+        <a:latin typeface="Aptos"/>
+        <a:ea typeface=""/>
+        <a:cs typeface=""/>
       </a:minorFont>
     </a:fontScheme>
     <a:fmtScheme name="ChatGPT">

</xml_diff>